<commit_message>
Deck fix: run-level styling was silently dropped (wrong pptxgenjs nesting) -> all text rendered black; rebuilt with correct {text, options} runs, color audit now clean
Co-Authored-By: Claude Opus 4.8 <noreply@anthropic.com>
Claude-Session: https://claude.ai/code/session_016ijNmQwafUUda99bWttvKv
</commit_message>
<xml_diff>
--- a/docs/MATGENQ_Audit_CxO.pptx
+++ b/docs/MATGENQ_Audit_CxO.pptx
@@ -1700,8 +1700,11 @@
             <a:r>
               <a:rPr lang="en-US" sz="5400" b="1" dirty="0">
                 <a:solidFill>
-                  <a:srgbClr val="000000"/>
-                </a:solidFill>
+                  <a:srgbClr val="FFFFFF"/>
+                </a:solidFill>
+                <a:latin typeface="Calibri" pitchFamily="34" charset="0"/>
+                <a:ea typeface="Calibri" pitchFamily="34" charset="-122"/>
+                <a:cs typeface="Calibri" pitchFamily="34" charset="-120"/>
               </a:rPr>
               <a:t>MATGEN-Q</a:t>
             </a:r>
@@ -1736,8 +1739,11 @@
             <a:r>
               <a:rPr lang="en-US" sz="2800" b="1" dirty="0">
                 <a:solidFill>
-                  <a:srgbClr val="000000"/>
-                </a:solidFill>
+                  <a:srgbClr val="02C39A"/>
+                </a:solidFill>
+                <a:latin typeface="Calibri" pitchFamily="34" charset="0"/>
+                <a:ea typeface="Calibri" pitchFamily="34" charset="-122"/>
+                <a:cs typeface="Calibri" pitchFamily="34" charset="-120"/>
               </a:rPr>
               <a:t>The Audit Layer for Materials R&amp;D</a:t>
             </a:r>
@@ -1775,8 +1781,11 @@
             <a:r>
               <a:rPr lang="en-US" sz="1700" dirty="0">
                 <a:solidFill>
-                  <a:srgbClr val="000000"/>
-                </a:solidFill>
+                  <a:srgbClr val="CADCFC"/>
+                </a:solidFill>
+                <a:latin typeface="Calibri" pitchFamily="34" charset="0"/>
+                <a:ea typeface="Calibri" pitchFamily="34" charset="-122"/>
+                <a:cs typeface="Calibri" pitchFamily="34" charset="-120"/>
               </a:rPr>
               <a:t>Computational chemistry that knows which side of the truth it is on —</a:t>
             </a:r>
@@ -1792,8 +1801,11 @@
             <a:r>
               <a:rPr lang="en-US" sz="1700" dirty="0">
                 <a:solidFill>
-                  <a:srgbClr val="000000"/>
-                </a:solidFill>
+                  <a:srgbClr val="CADCFC"/>
+                </a:solidFill>
+                <a:latin typeface="Calibri" pitchFamily="34" charset="0"/>
+                <a:ea typeface="Calibri" pitchFamily="34" charset="-122"/>
+                <a:cs typeface="Calibri" pitchFamily="34" charset="-120"/>
               </a:rPr>
               <a:t>and proves when the standard methods are silently wrong.</a:t>
             </a:r>
@@ -1854,8 +1866,11 @@
             <a:r>
               <a:rPr lang="en-US" sz="1250" dirty="0">
                 <a:solidFill>
-                  <a:srgbClr val="000000"/>
-                </a:solidFill>
+                  <a:srgbClr val="CADCFC"/>
+                </a:solidFill>
+                <a:latin typeface="Calibri" pitchFamily="34" charset="0"/>
+                <a:ea typeface="Calibri" pitchFamily="34" charset="-122"/>
+                <a:cs typeface="Calibri" pitchFamily="34" charset="-120"/>
               </a:rPr>
               <a:t>Team EIGENNEXUS  ·  GIC 2026 Advanced Materials Finalist (Mitsubishi Chemical &amp; AIST)</a:t>
             </a:r>
@@ -1871,8 +1886,11 @@
             <a:r>
               <a:rPr lang="en-US" sz="1250" dirty="0">
                 <a:solidFill>
-                  <a:srgbClr val="000000"/>
-                </a:solidFill>
+                  <a:srgbClr val="CADCFC"/>
+                </a:solidFill>
+                <a:latin typeface="Calibri" pitchFamily="34" charset="0"/>
+                <a:ea typeface="Calibri" pitchFamily="34" charset="-122"/>
+                <a:cs typeface="Calibri" pitchFamily="34" charset="-120"/>
               </a:rPr>
               <a:t>Every number on every slide is committed, reproducible evidence — one command, 24 automated checks.</a:t>
             </a:r>
@@ -1939,8 +1957,11 @@
             <a:r>
               <a:rPr lang="en-US" sz="3300" b="1" dirty="0">
                 <a:solidFill>
-                  <a:srgbClr val="000000"/>
-                </a:solidFill>
+                  <a:srgbClr val="1A2238"/>
+                </a:solidFill>
+                <a:latin typeface="Calibri" pitchFamily="34" charset="0"/>
+                <a:ea typeface="Calibri" pitchFamily="34" charset="-122"/>
+                <a:cs typeface="Calibri" pitchFamily="34" charset="-120"/>
               </a:rPr>
               <a:t>Every “gold standard” fails silently — we caught all three</a:t>
             </a:r>
@@ -1975,8 +1996,11 @@
             <a:r>
               <a:rPr lang="en-US" sz="1500" dirty="0">
                 <a:solidFill>
-                  <a:srgbClr val="000000"/>
-                </a:solidFill>
+                  <a:srgbClr val="6B7280"/>
+                </a:solidFill>
+                <a:latin typeface="Calibri" pitchFamily="34" charset="0"/>
+                <a:ea typeface="Calibri" pitchFamily="34" charset="-122"/>
+                <a:cs typeface="Calibri" pitchFamily="34" charset="-120"/>
               </a:rPr>
               <a:t>Materials R&amp;D advances candidates to synthesis based on computed numbers nobody can double-check. We audited the standard toolchain on real industrial chemistry:</a:t>
             </a:r>
@@ -2064,8 +2088,11 @@
             <a:r>
               <a:rPr lang="en-US" sz="1100" b="1" spc="200" kern="0" dirty="0">
                 <a:solidFill>
-                  <a:srgbClr val="000000"/>
-                </a:solidFill>
+                  <a:srgbClr val="6B7280"/>
+                </a:solidFill>
+                <a:latin typeface="Calibri" pitchFamily="34" charset="0"/>
+                <a:ea typeface="Calibri" pitchFamily="34" charset="-122"/>
+                <a:cs typeface="Calibri" pitchFamily="34" charset="-120"/>
               </a:rPr>
               <a:t>SCREENING TIER</a:t>
             </a:r>
@@ -2100,8 +2127,11 @@
             <a:r>
               <a:rPr lang="en-US" sz="2400" b="1" dirty="0">
                 <a:solidFill>
-                  <a:srgbClr val="000000"/>
-                </a:solidFill>
+                  <a:srgbClr val="1A2238"/>
+                </a:solidFill>
+                <a:latin typeface="Calibri" pitchFamily="34" charset="0"/>
+                <a:ea typeface="Calibri" pitchFamily="34" charset="-122"/>
+                <a:cs typeface="Calibri" pitchFamily="34" charset="-120"/>
               </a:rPr>
               <a:t>DFT</a:t>
             </a:r>
@@ -2139,8 +2169,11 @@
             <a:r>
               <a:rPr lang="en-US" sz="1750" b="1" dirty="0">
                 <a:solidFill>
-                  <a:srgbClr val="000000"/>
-                </a:solidFill>
+                  <a:srgbClr val="C13438"/>
+                </a:solidFill>
+                <a:latin typeface="Calibri" pitchFamily="34" charset="0"/>
+                <a:ea typeface="Calibri" pitchFamily="34" charset="-122"/>
+                <a:cs typeface="Calibri" pitchFamily="34" charset="-120"/>
               </a:rPr>
               <a:t>Wrong ground state</a:t>
             </a:r>
@@ -2178,8 +2211,11 @@
             <a:r>
               <a:rPr lang="en-US" sz="1250" dirty="0">
                 <a:solidFill>
-                  <a:srgbClr val="000000"/>
-                </a:solidFill>
+                  <a:srgbClr val="1A2238"/>
+                </a:solidFill>
+                <a:latin typeface="Calibri" pitchFamily="34" charset="0"/>
+                <a:ea typeface="Calibri" pitchFamily="34" charset="-122"/>
+                <a:cs typeface="Calibri" pitchFamily="34" charset="-120"/>
               </a:rPr>
               <a:t>CrO spin state: functionals disagree by 1.9 eV; B3LYP inverts the answer outright — a screen built on it mis-ranks every CrO-like candidate.</a:t>
             </a:r>
@@ -2267,8 +2303,11 @@
             <a:r>
               <a:rPr lang="en-US" sz="1100" b="1" spc="200" kern="0" dirty="0">
                 <a:solidFill>
-                  <a:srgbClr val="000000"/>
-                </a:solidFill>
+                  <a:srgbClr val="6B7280"/>
+                </a:solidFill>
+                <a:latin typeface="Calibri" pitchFamily="34" charset="0"/>
+                <a:ea typeface="Calibri" pitchFamily="34" charset="-122"/>
+                <a:cs typeface="Calibri" pitchFamily="34" charset="-120"/>
               </a:rPr>
               <a:t>ACCURACY TIER</a:t>
             </a:r>
@@ -2303,8 +2342,11 @@
             <a:r>
               <a:rPr lang="en-US" sz="2400" b="1" dirty="0">
                 <a:solidFill>
-                  <a:srgbClr val="000000"/>
-                </a:solidFill>
+                  <a:srgbClr val="1A2238"/>
+                </a:solidFill>
+                <a:latin typeface="Calibri" pitchFamily="34" charset="0"/>
+                <a:ea typeface="Calibri" pitchFamily="34" charset="-122"/>
+                <a:cs typeface="Calibri" pitchFamily="34" charset="-120"/>
               </a:rPr>
               <a:t>CCSD(T)</a:t>
             </a:r>
@@ -2342,8 +2384,11 @@
             <a:r>
               <a:rPr lang="en-US" sz="1750" b="1" dirty="0">
                 <a:solidFill>
-                  <a:srgbClr val="000000"/>
-                </a:solidFill>
+                  <a:srgbClr val="C13438"/>
+                </a:solidFill>
+                <a:latin typeface="Calibri" pitchFamily="34" charset="0"/>
+                <a:ea typeface="Calibri" pitchFamily="34" charset="-122"/>
+                <a:cs typeface="Calibri" pitchFamily="34" charset="-120"/>
               </a:rPr>
               <a:t>Off by 217 mHa — confidently</a:t>
             </a:r>
@@ -2381,8 +2426,11 @@
             <a:r>
               <a:rPr lang="en-US" sz="1250" dirty="0">
                 <a:solidFill>
-                  <a:srgbClr val="000000"/>
-                </a:solidFill>
+                  <a:srgbClr val="1A2238"/>
+                </a:solidFill>
+                <a:latin typeface="Calibri" pitchFamily="34" charset="0"/>
+                <a:ea typeface="Calibri" pitchFamily="34" charset="-122"/>
+                <a:cs typeface="Calibri" pitchFamily="34" charset="-120"/>
               </a:rPr>
               <a:t>Collapses non-variationally below the exact energy on bond-breaking — precise-looking, unphysical, and it never warns you.</a:t>
             </a:r>
@@ -2470,8 +2518,11 @@
             <a:r>
               <a:rPr lang="en-US" sz="1100" b="1" spc="200" kern="0" dirty="0">
                 <a:solidFill>
-                  <a:srgbClr val="000000"/>
-                </a:solidFill>
+                  <a:srgbClr val="6B7280"/>
+                </a:solidFill>
+                <a:latin typeface="Calibri" pitchFamily="34" charset="0"/>
+                <a:ea typeface="Calibri" pitchFamily="34" charset="-122"/>
+                <a:cs typeface="Calibri" pitchFamily="34" charset="-120"/>
               </a:rPr>
               <a:t>REFERENCE TIER</a:t>
             </a:r>
@@ -2506,8 +2557,11 @@
             <a:r>
               <a:rPr lang="en-US" sz="2400" b="1" dirty="0">
                 <a:solidFill>
-                  <a:srgbClr val="000000"/>
-                </a:solidFill>
+                  <a:srgbClr val="1A2238"/>
+                </a:solidFill>
+                <a:latin typeface="Calibri" pitchFamily="34" charset="0"/>
+                <a:ea typeface="Calibri" pitchFamily="34" charset="-122"/>
+                <a:cs typeface="Calibri" pitchFamily="34" charset="-120"/>
               </a:rPr>
               <a:t>DMRG</a:t>
             </a:r>
@@ -2545,8 +2599,11 @@
             <a:r>
               <a:rPr lang="en-US" sz="1750" b="1" dirty="0">
                 <a:solidFill>
-                  <a:srgbClr val="000000"/>
-                </a:solidFill>
+                  <a:srgbClr val="C13438"/>
+                </a:solidFill>
+                <a:latin typeface="Calibri" pitchFamily="34" charset="0"/>
+                <a:ea typeface="Calibri" pitchFamily="34" charset="-122"/>
+                <a:cs typeface="Calibri" pitchFamily="34" charset="-120"/>
               </a:rPr>
               <a:t>~3 mHa silent truncation error</a:t>
             </a:r>
@@ -2584,8 +2641,11 @@
             <a:r>
               <a:rPr lang="en-US" sz="1250" dirty="0">
                 <a:solidFill>
-                  <a:srgbClr val="000000"/>
-                </a:solidFill>
+                  <a:srgbClr val="1A2238"/>
+                </a:solidFill>
+                <a:latin typeface="Calibri" pitchFamily="34" charset="0"/>
+                <a:ea typeface="Calibri" pitchFamily="34" charset="-122"/>
+                <a:cs typeface="Calibri" pitchFamily="34" charset="-120"/>
               </a:rPr>
               <a:t>At a realistic 38-qubit transition-metal problem, the heavy-artillery reference itself was off by ~1.9 kcal/mol — detected only by our audit.</a:t>
             </a:r>
@@ -2669,8 +2729,11 @@
             <a:r>
               <a:rPr lang="en-US" sz="1550" dirty="0">
                 <a:solidFill>
-                  <a:srgbClr val="000000"/>
-                </a:solidFill>
+                  <a:srgbClr val="CADCFC"/>
+                </a:solidFill>
+                <a:latin typeface="Calibri" pitchFamily="34" charset="0"/>
+                <a:ea typeface="Calibri" pitchFamily="34" charset="-122"/>
+                <a:cs typeface="Calibri" pitchFamily="34" charset="-120"/>
               </a:rPr>
               <a:t>The cost of a silent failure: </a:t>
             </a:r>
@@ -2681,10 +2744,13 @@
               <a:buNone/>
             </a:pPr>
             <a:r>
-              <a:rPr lang="en-US" sz="1550" dirty="0">
-                <a:solidFill>
-                  <a:srgbClr val="000000"/>
-                </a:solidFill>
+              <a:rPr lang="en-US" sz="1550" b="1" dirty="0">
+                <a:solidFill>
+                  <a:srgbClr val="FFFFFF"/>
+                </a:solidFill>
+                <a:latin typeface="Calibri" pitchFamily="34" charset="0"/>
+                <a:ea typeface="Calibri" pitchFamily="34" charset="-122"/>
+                <a:cs typeface="Calibri" pitchFamily="34" charset="-120"/>
               </a:rPr>
               <a:t>one mis-ranked candidate sends a synthesis campaign after a dead end — $100k to $1M+ </a:t>
             </a:r>
@@ -2697,8 +2763,11 @@
             <a:r>
               <a:rPr lang="en-US" sz="1550" dirty="0">
                 <a:solidFill>
-                  <a:srgbClr val="000000"/>
-                </a:solidFill>
+                  <a:srgbClr val="CADCFC"/>
+                </a:solidFill>
+                <a:latin typeface="Calibri" pitchFamily="34" charset="0"/>
+                <a:ea typeface="Calibri" pitchFamily="34" charset="-122"/>
+                <a:cs typeface="Calibri" pitchFamily="34" charset="-120"/>
               </a:rPr>
               <a:t>in staff, materials, and lost time before the lab finds out.</a:t>
             </a:r>
@@ -2765,8 +2834,11 @@
             <a:r>
               <a:rPr lang="en-US" sz="3300" b="1" dirty="0">
                 <a:solidFill>
-                  <a:srgbClr val="000000"/>
-                </a:solidFill>
+                  <a:srgbClr val="FFFFFF"/>
+                </a:solidFill>
+                <a:latin typeface="Calibri" pitchFamily="34" charset="0"/>
+                <a:ea typeface="Calibri" pitchFamily="34" charset="-122"/>
+                <a:cs typeface="Calibri" pitchFamily="34" charset="-120"/>
               </a:rPr>
               <a:t>The audit: a measuring tape that can only read long</a:t>
             </a:r>
@@ -2801,8 +2873,11 @@
             <a:r>
               <a:rPr lang="en-US" sz="1500" dirty="0">
                 <a:solidFill>
-                  <a:srgbClr val="000000"/>
-                </a:solidFill>
+                  <a:srgbClr val="CADCFC"/>
+                </a:solidFill>
+                <a:latin typeface="Calibri" pitchFamily="34" charset="0"/>
+                <a:ea typeface="Calibri" pitchFamily="34" charset="-122"/>
+                <a:cs typeface="Calibri" pitchFamily="34" charset="-120"/>
               </a:rPr>
               <a:t>Three properties no standard method has — each mathematical or demonstrated, not promised:</a:t>
             </a:r>
@@ -2903,8 +2978,11 @@
             <a:r>
               <a:rPr lang="en-US" sz="1850" b="1" dirty="0">
                 <a:solidFill>
-                  <a:srgbClr val="000000"/>
-                </a:solidFill>
+                  <a:srgbClr val="02C39A"/>
+                </a:solidFill>
+                <a:latin typeface="Calibri" pitchFamily="34" charset="0"/>
+                <a:ea typeface="Calibri" pitchFamily="34" charset="-122"/>
+                <a:cs typeface="Calibri" pitchFamily="34" charset="-120"/>
               </a:rPr>
               <a:t>One-sided by construction</a:t>
             </a:r>
@@ -2942,8 +3020,11 @@
             <a:r>
               <a:rPr lang="en-US" sz="1350" dirty="0">
                 <a:solidFill>
-                  <a:srgbClr val="000000"/>
-                </a:solidFill>
+                  <a:srgbClr val="FFFFFF"/>
+                </a:solidFill>
+                <a:latin typeface="Calibri" pitchFamily="34" charset="0"/>
+                <a:ea typeface="Calibri" pitchFamily="34" charset="-122"/>
+                <a:cs typeface="Calibri" pitchFamily="34" charset="-120"/>
               </a:rPr>
               <a:t>Its energy can never fall below the truth — a guarantee of mathematics, not testing. It always knows which side of the answer it is on.</a:t>
             </a:r>
@@ -3044,8 +3125,11 @@
             <a:r>
               <a:rPr lang="en-US" sz="1850" b="1" dirty="0">
                 <a:solidFill>
-                  <a:srgbClr val="000000"/>
-                </a:solidFill>
+                  <a:srgbClr val="02C39A"/>
+                </a:solidFill>
+                <a:latin typeface="Calibri" pitchFamily="34" charset="0"/>
+                <a:ea typeface="Calibri" pitchFamily="34" charset="-122"/>
+                <a:cs typeface="Calibri" pitchFamily="34" charset="-120"/>
               </a:rPr>
               <a:t>Self-certifying</a:t>
             </a:r>
@@ -3083,8 +3167,11 @@
             <a:r>
               <a:rPr lang="en-US" sz="1350" dirty="0">
                 <a:solidFill>
-                  <a:srgbClr val="000000"/>
-                </a:solidFill>
+                  <a:srgbClr val="FFFFFF"/>
+                </a:solidFill>
+                <a:latin typeface="Calibri" pitchFamily="34" charset="0"/>
+                <a:ea typeface="Calibri" pitchFamily="34" charset="-122"/>
+                <a:cs typeface="Calibri" pitchFamily="34" charset="-120"/>
               </a:rPr>
               <a:t>Every result carries its own error estimate that shrinks as compute is added (demonstrated tracking reality at R² = 0.999). When the bar is under chemical accuracy, the number is the truth for every practical purpose.</a:t>
             </a:r>
@@ -3185,8 +3272,11 @@
             <a:r>
               <a:rPr lang="en-US" sz="1850" b="1" dirty="0">
                 <a:solidFill>
-                  <a:srgbClr val="000000"/>
-                </a:solidFill>
+                  <a:srgbClr val="02C39A"/>
+                </a:solidFill>
+                <a:latin typeface="Calibri" pitchFamily="34" charset="0"/>
+                <a:ea typeface="Calibri" pitchFamily="34" charset="-122"/>
+                <a:cs typeface="Calibri" pitchFamily="34" charset="-120"/>
               </a:rPr>
               <a:t>Convicts other methods — even before full convergence</a:t>
             </a:r>
@@ -3224,8 +3314,11 @@
             <a:r>
               <a:rPr lang="en-US" sz="1350" dirty="0">
                 <a:solidFill>
-                  <a:srgbClr val="000000"/>
-                </a:solidFill>
+                  <a:srgbClr val="FFFFFF"/>
+                </a:solidFill>
+                <a:latin typeface="Calibri" pitchFamily="34" charset="0"/>
+                <a:ea typeface="Calibri" pitchFamily="34" charset="-122"/>
+                <a:cs typeface="Calibri" pitchFamily="34" charset="-120"/>
               </a:rPr>
               <a:t>Any answer sitting on the impossible side of the audit’s bound is provably wrong. No expert judgment call, no debate — that is how CCSD(T) and the DMRG reference were caught.</a:t>
             </a:r>
@@ -3258,10 +3351,13 @@
               <a:buNone/>
             </a:pPr>
             <a:r>
-              <a:rPr lang="en-US" sz="1250" dirty="0">
-                <a:solidFill>
-                  <a:srgbClr val="000000"/>
-                </a:solidFill>
+              <a:rPr lang="en-US" sz="1250" i="1" dirty="0">
+                <a:solidFill>
+                  <a:srgbClr val="CADCFC"/>
+                </a:solidFill>
+                <a:latin typeface="Calibri" pitchFamily="34" charset="0"/>
+                <a:ea typeface="Calibri" pitchFamily="34" charset="-122"/>
+                <a:cs typeface="Calibri" pitchFamily="34" charset="-120"/>
               </a:rPr>
               <a:t>Discipline to match: predictions pre-registered and cryptographically frozen before every decisive run — failures published with the same prominence as wins.</a:t>
             </a:r>
@@ -3328,8 +3424,11 @@
             <a:r>
               <a:rPr lang="en-US" sz="3200" b="1" dirty="0">
                 <a:solidFill>
-                  <a:srgbClr val="000000"/>
-                </a:solidFill>
+                  <a:srgbClr val="1A2238"/>
+                </a:solidFill>
+                <a:latin typeface="Calibri" pitchFamily="34" charset="0"/>
+                <a:ea typeface="Calibri" pitchFamily="34" charset="-122"/>
+                <a:cs typeface="Calibri" pitchFamily="34" charset="-120"/>
               </a:rPr>
               <a:t>Proof, not promises — audited against nature and at scale</a:t>
             </a:r>
@@ -3454,8 +3553,11 @@
             <a:r>
               <a:rPr lang="en-US" sz="1800" b="1" dirty="0">
                 <a:solidFill>
-                  <a:srgbClr val="000000"/>
-                </a:solidFill>
+                  <a:srgbClr val="1A2238"/>
+                </a:solidFill>
+                <a:latin typeface="Calibri" pitchFamily="34" charset="0"/>
+                <a:ea typeface="Calibri" pitchFamily="34" charset="-122"/>
+                <a:cs typeface="Calibri" pitchFamily="34" charset="-120"/>
               </a:rPr>
               <a:t>CrO ground state</a:t>
             </a:r>
@@ -3493,8 +3595,11 @@
             <a:r>
               <a:rPr lang="en-US" sz="1280" dirty="0">
                 <a:solidFill>
-                  <a:srgbClr val="000000"/>
-                </a:solidFill>
+                  <a:srgbClr val="1A2238"/>
+                </a:solidFill>
+                <a:latin typeface="Calibri" pitchFamily="34" charset="0"/>
+                <a:ea typeface="Calibri" pitchFamily="34" charset="-122"/>
+                <a:cs typeface="Calibri" pitchFamily="34" charset="-120"/>
               </a:rPr>
               <a:t>DFT (B3LYP) predicts the wrong ground state. The audit predicts the one measured in the laboratory — decades of spectroscopy agree with us, not DFT.</a:t>
             </a:r>
@@ -3619,8 +3724,11 @@
             <a:r>
               <a:rPr lang="en-US" sz="1800" b="1" dirty="0">
                 <a:solidFill>
-                  <a:srgbClr val="000000"/>
-                </a:solidFill>
+                  <a:srgbClr val="1A2238"/>
+                </a:solidFill>
+                <a:latin typeface="Calibri" pitchFamily="34" charset="0"/>
+                <a:ea typeface="Calibri" pitchFamily="34" charset="-122"/>
+                <a:cs typeface="Calibri" pitchFamily="34" charset="-120"/>
               </a:rPr>
               <a:t>VO ground state — predicted blind</a:t>
             </a:r>
@@ -3658,8 +3766,11 @@
             <a:r>
               <a:rPr lang="en-US" sz="1280" dirty="0">
                 <a:solidFill>
-                  <a:srgbClr val="000000"/>
-                </a:solidFill>
+                  <a:srgbClr val="1A2238"/>
+                </a:solidFill>
+                <a:latin typeface="Calibri" pitchFamily="34" charset="0"/>
+                <a:ea typeface="Calibri" pitchFamily="34" charset="-122"/>
+                <a:cs typeface="Calibri" pitchFamily="34" charset="-120"/>
               </a:rPr>
               <a:t>Prediction locked by cryptographic hash before the single frozen run. Result: matches the laboratory ground state. The audit is right when it cannot possibly peek.</a:t>
             </a:r>
@@ -3784,8 +3895,11 @@
             <a:r>
               <a:rPr lang="en-US" sz="1800" b="1" dirty="0">
                 <a:solidFill>
-                  <a:srgbClr val="000000"/>
-                </a:solidFill>
+                  <a:srgbClr val="1A2238"/>
+                </a:solidFill>
+                <a:latin typeface="Calibri" pitchFamily="34" charset="0"/>
+                <a:ea typeface="Calibri" pitchFamily="34" charset="-122"/>
+                <a:cs typeface="Calibri" pitchFamily="34" charset="-120"/>
               </a:rPr>
               <a:t>CCSD(T) caught red-handed</a:t>
             </a:r>
@@ -3823,8 +3937,11 @@
             <a:r>
               <a:rPr lang="en-US" sz="1280" dirty="0">
                 <a:solidFill>
-                  <a:srgbClr val="000000"/>
-                </a:solidFill>
+                  <a:srgbClr val="1A2238"/>
+                </a:solidFill>
+                <a:latin typeface="Calibri" pitchFamily="34" charset="0"/>
+                <a:ea typeface="Calibri" pitchFamily="34" charset="-122"/>
+                <a:cs typeface="Calibri" pitchFamily="34" charset="-120"/>
               </a:rPr>
               <a:t>Its answer sat 217 mHa below the exact energy — inside the region our bound proves impossible. The “accuracy gold standard,” convicted by mathematics.</a:t>
             </a:r>
@@ -3949,8 +4066,11 @@
             <a:r>
               <a:rPr lang="en-US" sz="1800" b="1" dirty="0">
                 <a:solidFill>
-                  <a:srgbClr val="000000"/>
-                </a:solidFill>
+                  <a:srgbClr val="1A2238"/>
+                </a:solidFill>
+                <a:latin typeface="Calibri" pitchFamily="34" charset="0"/>
+                <a:ea typeface="Calibri" pitchFamily="34" charset="-122"/>
+                <a:cs typeface="Calibri" pitchFamily="34" charset="-120"/>
               </a:rPr>
               <a:t>DMRG reference corrected — for $12</a:t>
             </a:r>
@@ -3988,8 +4108,11 @@
             <a:r>
               <a:rPr lang="en-US" sz="1280" dirty="0">
                 <a:solidFill>
-                  <a:srgbClr val="000000"/>
-                </a:solidFill>
+                  <a:srgbClr val="1A2238"/>
+                </a:solidFill>
+                <a:latin typeface="Calibri" pitchFamily="34" charset="0"/>
+                <a:ea typeface="Calibri" pitchFamily="34" charset="-122"/>
+                <a:cs typeface="Calibri" pitchFamily="34" charset="-120"/>
               </a:rPr>
               <a:t>At 38 qubits on CrO, the audit landed below the trusted reference: provably closer to the truth. Compute cost of the audit: ~$12 and under 3 hours on a rented cloud GPU.</a:t>
             </a:r>
@@ -4022,10 +4145,13 @@
               <a:buNone/>
             </a:pPr>
             <a:r>
-              <a:rPr lang="en-US" sz="1250" dirty="0">
-                <a:solidFill>
-                  <a:srgbClr val="000000"/>
-                </a:solidFill>
+              <a:rPr lang="en-US" sz="1250" i="1" dirty="0">
+                <a:solidFill>
+                  <a:srgbClr val="6B7280"/>
+                </a:solidFill>
+                <a:latin typeface="Calibri" pitchFamily="34" charset="0"/>
+                <a:ea typeface="Calibri" pitchFamily="34" charset="-122"/>
+                <a:cs typeface="Calibri" pitchFamily="34" charset="-120"/>
               </a:rPr>
               <a:t>Also in the evidence base: NiO (second oxide class), Sn-oxide EUV photoresist chemistry, and exact-to-the-digit execution on NVIDIA GPUs.</a:t>
             </a:r>
@@ -4092,8 +4218,11 @@
             <a:r>
               <a:rPr lang="en-US" sz="3200" b="1" dirty="0">
                 <a:solidFill>
-                  <a:srgbClr val="000000"/>
-                </a:solidFill>
+                  <a:srgbClr val="1A2238"/>
+                </a:solidFill>
+                <a:latin typeface="Calibri" pitchFamily="34" charset="0"/>
+                <a:ea typeface="Calibri" pitchFamily="34" charset="-122"/>
+                <a:cs typeface="Calibri" pitchFamily="34" charset="-120"/>
               </a:rPr>
               <a:t>Triage, not replacement — audit the load-bearing welds</a:t>
             </a:r>
@@ -4128,8 +4257,11 @@
             <a:r>
               <a:rPr lang="en-US" sz="1500" dirty="0">
                 <a:solidFill>
-                  <a:srgbClr val="000000"/>
-                </a:solidFill>
+                  <a:srgbClr val="6B7280"/>
+                </a:solidFill>
+                <a:latin typeface="Calibri" pitchFamily="34" charset="0"/>
+                <a:ea typeface="Calibri" pitchFamily="34" charset="-122"/>
+                <a:cs typeface="Calibri" pitchFamily="34" charset="-120"/>
               </a:rPr>
               <a:t>DFT keeps the screening job it is priced for. The audit sits at the one place errors become expensive: the go / no-go gate before synthesis.</a:t>
             </a:r>
@@ -4186,8 +4318,11 @@
             <a:r>
               <a:rPr lang="en-US" sz="1250" dirty="0">
                 <a:solidFill>
-                  <a:srgbClr val="000000"/>
-                </a:solidFill>
+                  <a:srgbClr val="1A2238"/>
+                </a:solidFill>
+                <a:latin typeface="Calibri" pitchFamily="34" charset="0"/>
+                <a:ea typeface="Calibri" pitchFamily="34" charset="-122"/>
+                <a:cs typeface="Calibri" pitchFamily="34" charset="-120"/>
               </a:rPr>
               <a:t>~10⁶ candidates — DFT screen (pennies each)</a:t>
             </a:r>
@@ -4244,8 +4379,11 @@
             <a:r>
               <a:rPr lang="en-US" sz="1250" dirty="0">
                 <a:solidFill>
-                  <a:srgbClr val="000000"/>
-                </a:solidFill>
+                  <a:srgbClr val="1A2238"/>
+                </a:solidFill>
+                <a:latin typeface="Calibri" pitchFamily="34" charset="0"/>
+                <a:ea typeface="Calibri" pitchFamily="34" charset="-122"/>
+                <a:cs typeface="Calibri" pitchFamily="34" charset="-120"/>
               </a:rPr>
               <a:t>~10² survivors — refined models</a:t>
             </a:r>
@@ -4302,8 +4440,11 @@
             <a:r>
               <a:rPr lang="en-US" sz="1250" b="1" dirty="0">
                 <a:solidFill>
-                  <a:srgbClr val="000000"/>
-                </a:solidFill>
+                  <a:srgbClr val="FFFFFF"/>
+                </a:solidFill>
+                <a:latin typeface="Calibri" pitchFamily="34" charset="0"/>
+                <a:ea typeface="Calibri" pitchFamily="34" charset="-122"/>
+                <a:cs typeface="Calibri" pitchFamily="34" charset="-120"/>
               </a:rPr>
               <a:t>Dozens: go / no-go synthesis decisions</a:t>
             </a:r>
@@ -4387,8 +4528,11 @@
             <a:r>
               <a:rPr lang="en-US" sz="1350" b="1" dirty="0">
                 <a:solidFill>
-                  <a:srgbClr val="000000"/>
-                </a:solidFill>
+                  <a:srgbClr val="16205B"/>
+                </a:solidFill>
+                <a:latin typeface="Calibri" pitchFamily="34" charset="0"/>
+                <a:ea typeface="Calibri" pitchFamily="34" charset="-122"/>
+                <a:cs typeface="Calibri" pitchFamily="34" charset="-120"/>
               </a:rPr>
               <a:t>MATGEN-Q AUDIT — $10–100 per decisive number</a:t>
             </a:r>
@@ -4469,8 +4613,11 @@
             <a:r>
               <a:rPr lang="en-US" sz="3400" b="1" dirty="0">
                 <a:solidFill>
-                  <a:srgbClr val="000000"/>
-                </a:solidFill>
+                  <a:srgbClr val="C13438"/>
+                </a:solidFill>
+                <a:latin typeface="Calibri" pitchFamily="34" charset="0"/>
+                <a:ea typeface="Calibri" pitchFamily="34" charset="-122"/>
+                <a:cs typeface="Calibri" pitchFamily="34" charset="-120"/>
               </a:rPr>
               <a:t>$100k – $1M+</a:t>
             </a:r>
@@ -4508,8 +4655,11 @@
             <a:r>
               <a:rPr lang="en-US" sz="1300" dirty="0">
                 <a:solidFill>
-                  <a:srgbClr val="000000"/>
-                </a:solidFill>
+                  <a:srgbClr val="1A2238"/>
+                </a:solidFill>
+                <a:latin typeface="Calibri" pitchFamily="34" charset="0"/>
+                <a:ea typeface="Calibri" pitchFamily="34" charset="-122"/>
+                <a:cs typeface="Calibri" pitchFamily="34" charset="-120"/>
               </a:rPr>
               <a:t>cost of one synthesis campaign chasing a computationally mis-ranked candidate — the failure mode the audit exists to catch.</a:t>
             </a:r>
@@ -4566,8 +4716,11 @@
             <a:r>
               <a:rPr lang="en-US" sz="1900" b="1" dirty="0">
                 <a:solidFill>
-                  <a:srgbClr val="000000"/>
-                </a:solidFill>
+                  <a:srgbClr val="02C39A"/>
+                </a:solidFill>
+                <a:latin typeface="Calibri" pitchFamily="34" charset="0"/>
+                <a:ea typeface="Calibri" pitchFamily="34" charset="-122"/>
+                <a:cs typeface="Calibri" pitchFamily="34" charset="-120"/>
               </a:rPr>
               <a:t>One avoided dead-end per year</a:t>
             </a:r>
@@ -4605,8 +4758,11 @@
             <a:r>
               <a:rPr lang="en-US" sz="1300" dirty="0">
                 <a:solidFill>
-                  <a:srgbClr val="000000"/>
-                </a:solidFill>
+                  <a:srgbClr val="FFFFFF"/>
+                </a:solidFill>
+                <a:latin typeface="Calibri" pitchFamily="34" charset="0"/>
+                <a:ea typeface="Calibri" pitchFamily="34" charset="-122"/>
+                <a:cs typeface="Calibri" pitchFamily="34" charset="-120"/>
               </a:rPr>
               <a:t>pays for the audit layer across an entire screening portfolio. It doesn’t need “millions saved” to be worth deploying — though that is where the mechanism points.</a:t>
             </a:r>
@@ -4639,10 +4795,13 @@
               <a:buNone/>
             </a:pPr>
             <a:r>
-              <a:rPr lang="en-US" sz="1300" dirty="0">
-                <a:solidFill>
-                  <a:srgbClr val="000000"/>
-                </a:solidFill>
+              <a:rPr lang="en-US" sz="1300" i="1" dirty="0">
+                <a:solidFill>
+                  <a:srgbClr val="6B7280"/>
+                </a:solidFill>
+                <a:latin typeface="Calibri" pitchFamily="34" charset="0"/>
+                <a:ea typeface="Calibri" pitchFamily="34" charset="-122"/>
+                <a:cs typeface="Calibri" pitchFamily="34" charset="-120"/>
               </a:rPr>
               <a:t>You don’t X-ray every weld in the shipyard — you X-ray the ones the hull depends on.</a:t>
             </a:r>
@@ -4709,8 +4868,11 @@
             <a:r>
               <a:rPr lang="en-US" sz="3200" b="1" dirty="0">
                 <a:solidFill>
-                  <a:srgbClr val="000000"/>
-                </a:solidFill>
+                  <a:srgbClr val="1A2238"/>
+                </a:solidFill>
+                <a:latin typeface="Calibri" pitchFamily="34" charset="0"/>
+                <a:ea typeface="Calibri" pitchFamily="34" charset="-122"/>
+                <a:cs typeface="Calibri" pitchFamily="34" charset="-120"/>
               </a:rPr>
               <a:t>Why now: it runs today, and the frontier only moves outward</a:t>
             </a:r>
@@ -4818,8 +4980,11 @@
             <a:r>
               <a:rPr lang="en-US" sz="1850" b="1" dirty="0">
                 <a:solidFill>
-                  <a:srgbClr val="000000"/>
-                </a:solidFill>
+                  <a:srgbClr val="1A2238"/>
+                </a:solidFill>
+                <a:latin typeface="Calibri" pitchFamily="34" charset="0"/>
+                <a:ea typeface="Calibri" pitchFamily="34" charset="-122"/>
+                <a:cs typeface="Calibri" pitchFamily="34" charset="-120"/>
               </a:rPr>
               <a:t>Executed on real hardware — today</a:t>
             </a:r>
@@ -4857,8 +5022,11 @@
             <a:r>
               <a:rPr lang="en-US" sz="1300" dirty="0">
                 <a:solidFill>
-                  <a:srgbClr val="000000"/>
-                </a:solidFill>
+                  <a:srgbClr val="1A2238"/>
+                </a:solidFill>
+                <a:latin typeface="Calibri" pitchFamily="34" charset="0"/>
+                <a:ea typeface="Calibri" pitchFamily="34" charset="-122"/>
+                <a:cs typeface="Calibri" pitchFamily="34" charset="-120"/>
               </a:rPr>
               <a:t>Exact to the digit at 20 qubits and chemically accurate at 28 on rented NVIDIA GPUs; reference-correcting at 38; the 40-qubit flagship in flight. No exotic infrastructure — cloud instances anyone can rent.</a:t>
             </a:r>
@@ -4959,8 +5127,11 @@
             <a:r>
               <a:rPr lang="en-US" sz="1850" b="1" dirty="0">
                 <a:solidFill>
-                  <a:srgbClr val="000000"/>
-                </a:solidFill>
+                  <a:srgbClr val="02C39A"/>
+                </a:solidFill>
+                <a:latin typeface="Calibri" pitchFamily="34" charset="0"/>
+                <a:ea typeface="Calibri" pitchFamily="34" charset="-122"/>
+                <a:cs typeface="Calibri" pitchFamily="34" charset="-120"/>
               </a:rPr>
               <a:t>Built for the quantum curve</a:t>
             </a:r>
@@ -4998,8 +5169,11 @@
             <a:r>
               <a:rPr lang="en-US" sz="1300" dirty="0">
                 <a:solidFill>
-                  <a:srgbClr val="000000"/>
-                </a:solidFill>
+                  <a:srgbClr val="FFFFFF"/>
+                </a:solidFill>
+                <a:latin typeface="Calibri" pitchFamily="34" charset="0"/>
+                <a:ea typeface="Calibri" pitchFamily="34" charset="-122"/>
+                <a:cs typeface="Calibri" pitchFamily="34" charset="-120"/>
               </a:rPr>
               <a:t>The expensive step — selecting which configurations matter — is exactly what a quantum sampler does natively (CUDA-Q today, trapped-ion QPUs next: our verified circuits are already in the queue). As devices mature, certified truth gets cheaper every year.</a:t>
             </a:r>
@@ -5107,8 +5281,11 @@
             <a:r>
               <a:rPr lang="en-US" sz="1850" b="1" dirty="0">
                 <a:solidFill>
-                  <a:srgbClr val="000000"/>
-                </a:solidFill>
+                  <a:srgbClr val="1A2238"/>
+                </a:solidFill>
+                <a:latin typeface="Calibri" pitchFamily="34" charset="0"/>
+                <a:ea typeface="Calibri" pitchFamily="34" charset="-122"/>
+                <a:cs typeface="Calibri" pitchFamily="34" charset="-120"/>
               </a:rPr>
               <a:t>Credibility as a feature</a:t>
             </a:r>
@@ -5146,8 +5323,11 @@
             <a:r>
               <a:rPr lang="en-US" sz="1300" dirty="0">
                 <a:solidFill>
-                  <a:srgbClr val="000000"/>
-                </a:solidFill>
+                  <a:srgbClr val="1A2238"/>
+                </a:solidFill>
+                <a:latin typeface="Calibri" pitchFamily="34" charset="0"/>
+                <a:ea typeface="Calibri" pitchFamily="34" charset="-122"/>
+                <a:cs typeface="Calibri" pitchFamily="34" charset="-120"/>
               </a:rPr>
               <a:t>Clinical-trial-style pre-registration, cryptographically frozen blind tests, published failures, and a one-command reproduction path with 24 automated checks. An audit you can audit.</a:t>
             </a:r>
@@ -5180,10 +5360,13 @@
               <a:buNone/>
             </a:pPr>
             <a:r>
-              <a:rPr lang="en-US" sz="1250" dirty="0">
-                <a:solidFill>
-                  <a:srgbClr val="000000"/>
-                </a:solidFill>
+              <a:rPr lang="en-US" sz="1250" i="1" dirty="0">
+                <a:solidFill>
+                  <a:srgbClr val="6B7280"/>
+                </a:solidFill>
+                <a:latin typeface="Calibri" pitchFamily="34" charset="0"/>
+                <a:ea typeface="Calibri" pitchFamily="34" charset="-122"/>
+                <a:cs typeface="Calibri" pitchFamily="34" charset="-120"/>
               </a:rPr>
               <a:t>Semiconductors (EUV photoresists) · catalysis · battery materials · magnetics — demonstrated on the chemistry these industries actually struggle with.</a:t>
             </a:r>
@@ -5250,8 +5433,11 @@
             <a:r>
               <a:rPr lang="en-US" sz="3300" b="1" dirty="0">
                 <a:solidFill>
-                  <a:srgbClr val="000000"/>
-                </a:solidFill>
+                  <a:srgbClr val="FFFFFF"/>
+                </a:solidFill>
+                <a:latin typeface="Calibri" pitchFamily="34" charset="0"/>
+                <a:ea typeface="Calibri" pitchFamily="34" charset="-122"/>
+                <a:cs typeface="Calibri" pitchFamily="34" charset="-120"/>
               </a:rPr>
               <a:t>What is proven — and what is roadmap</a:t>
             </a:r>
@@ -5332,8 +5518,11 @@
             <a:r>
               <a:rPr lang="en-US" sz="1550" b="1" dirty="0">
                 <a:solidFill>
-                  <a:srgbClr val="000000"/>
-                </a:solidFill>
+                  <a:srgbClr val="02C39A"/>
+                </a:solidFill>
+                <a:latin typeface="Calibri" pitchFamily="34" charset="0"/>
+                <a:ea typeface="Calibri" pitchFamily="34" charset="-122"/>
+                <a:cs typeface="Calibri" pitchFamily="34" charset="-120"/>
               </a:rPr>
               <a:t>PROVEN (committed, reproducible)</a:t>
             </a:r>
@@ -5362,71 +5551,96 @@
           <a:bodyPr wrap="square" lIns="0" tIns="0" rIns="0" bIns="0" rtlCol="0" anchor="ctr"/>
           <a:lstStyle/>
           <a:p>
-            <a:pPr indent="0" marL="0">
+            <a:pPr marL="342900" indent="-342900">
               <a:lnSpc>
                 <a:spcPct val="108000"/>
               </a:lnSpc>
               <a:spcAft>
                 <a:spcPts val="1000"/>
               </a:spcAft>
-              <a:buNone/>
+              <a:buSzPct val="100000"/>
+              <a:buChar char="•"/>
             </a:pPr>
             <a:r>
               <a:rPr lang="en-US" sz="1350" dirty="0">
                 <a:solidFill>
-                  <a:srgbClr val="000000"/>
-                </a:solidFill>
+                  <a:srgbClr val="FFFFFF"/>
+                </a:solidFill>
+                <a:latin typeface="Calibri" pitchFamily="34" charset="0"/>
+                <a:ea typeface="Calibri" pitchFamily="34" charset="-122"/>
+                <a:cs typeface="Calibri" pitchFamily="34" charset="-120"/>
               </a:rPr>
               <a:t>Silent failures caught in DFT, CCSD(T), and DMRG on industrial chemistry</a:t>
             </a:r>
-            <a:pPr indent="0" marL="0">
+            <a:endParaRPr lang="en-US" sz="1350" dirty="0"/>
+          </a:p>
+          <a:p>
+            <a:pPr marL="342900" indent="-342900">
               <a:lnSpc>
                 <a:spcPct val="108000"/>
               </a:lnSpc>
               <a:spcAft>
                 <a:spcPts val="1000"/>
               </a:spcAft>
-              <a:buNone/>
+              <a:buSzPct val="100000"/>
+              <a:buChar char="•"/>
             </a:pPr>
             <a:r>
               <a:rPr lang="en-US" sz="1350" dirty="0">
                 <a:solidFill>
-                  <a:srgbClr val="000000"/>
-                </a:solidFill>
+                  <a:srgbClr val="FFFFFF"/>
+                </a:solidFill>
+                <a:latin typeface="Calibri" pitchFamily="34" charset="0"/>
+                <a:ea typeface="Calibri" pitchFamily="34" charset="-122"/>
+                <a:cs typeface="Calibri" pitchFamily="34" charset="-120"/>
               </a:rPr>
               <a:t>Two laboratory-verified ground-state calls — one cryptographically blind</a:t>
             </a:r>
-            <a:pPr indent="0" marL="0">
+            <a:endParaRPr lang="en-US" sz="1350" dirty="0"/>
+          </a:p>
+          <a:p>
+            <a:pPr marL="342900" indent="-342900">
               <a:lnSpc>
                 <a:spcPct val="108000"/>
               </a:lnSpc>
               <a:spcAft>
                 <a:spcPts val="1000"/>
               </a:spcAft>
-              <a:buNone/>
+              <a:buSzPct val="100000"/>
+              <a:buChar char="•"/>
             </a:pPr>
             <a:r>
               <a:rPr lang="en-US" sz="1350" dirty="0">
                 <a:solidFill>
-                  <a:srgbClr val="000000"/>
-                </a:solidFill>
+                  <a:srgbClr val="FFFFFF"/>
+                </a:solidFill>
+                <a:latin typeface="Calibri" pitchFamily="34" charset="0"/>
+                <a:ea typeface="Calibri" pitchFamily="34" charset="-122"/>
+                <a:cs typeface="Calibri" pitchFamily="34" charset="-120"/>
               </a:rPr>
               <a:t>Audit-at-scale: 38-qubit reference corrected for ~$12 of cloud compute</a:t>
             </a:r>
-            <a:pPr indent="0" marL="0">
+            <a:endParaRPr lang="en-US" sz="1350" dirty="0"/>
+          </a:p>
+          <a:p>
+            <a:pPr marL="342900" indent="-342900">
               <a:lnSpc>
                 <a:spcPct val="108000"/>
               </a:lnSpc>
               <a:spcAft>
                 <a:spcPts val="1000"/>
               </a:spcAft>
-              <a:buNone/>
+              <a:buSzPct val="100000"/>
+              <a:buChar char="•"/>
             </a:pPr>
             <a:r>
               <a:rPr lang="en-US" sz="1350" dirty="0">
                 <a:solidFill>
-                  <a:srgbClr val="000000"/>
-                </a:solidFill>
+                  <a:srgbClr val="FFFFFF"/>
+                </a:solidFill>
+                <a:latin typeface="Calibri" pitchFamily="34" charset="0"/>
+                <a:ea typeface="Calibri" pitchFamily="34" charset="-122"/>
+                <a:cs typeface="Calibri" pitchFamily="34" charset="-120"/>
               </a:rPr>
               <a:t>Exact GPU execution (20q) and chemical accuracy beyond it (28q)</a:t>
             </a:r>
@@ -5507,8 +5721,11 @@
             <a:r>
               <a:rPr lang="en-US" sz="1550" b="1" dirty="0">
                 <a:solidFill>
-                  <a:srgbClr val="000000"/>
-                </a:solidFill>
+                  <a:srgbClr val="CADCFC"/>
+                </a:solidFill>
+                <a:latin typeface="Calibri" pitchFamily="34" charset="0"/>
+                <a:ea typeface="Calibri" pitchFamily="34" charset="-122"/>
+                <a:cs typeface="Calibri" pitchFamily="34" charset="-120"/>
               </a:rPr>
               <a:t>ROADMAP (stated as such, never as done)</a:t>
             </a:r>
@@ -5537,71 +5754,96 @@
           <a:bodyPr wrap="square" lIns="0" tIns="0" rIns="0" bIns="0" rtlCol="0" anchor="ctr"/>
           <a:lstStyle/>
           <a:p>
-            <a:pPr indent="0" marL="0">
+            <a:pPr marL="342900" indent="-342900">
               <a:lnSpc>
                 <a:spcPct val="108000"/>
               </a:lnSpc>
               <a:spcAft>
                 <a:spcPts val="1000"/>
               </a:spcAft>
-              <a:buNone/>
+              <a:buSzPct val="100000"/>
+              <a:buChar char="•"/>
             </a:pPr>
             <a:r>
               <a:rPr lang="en-US" sz="1350" dirty="0">
                 <a:solidFill>
-                  <a:srgbClr val="000000"/>
-                </a:solidFill>
+                  <a:srgbClr val="FFFFFF"/>
+                </a:solidFill>
+                <a:latin typeface="Calibri" pitchFamily="34" charset="0"/>
+                <a:ea typeface="Calibri" pitchFamily="34" charset="-122"/>
+                <a:cs typeface="Calibri" pitchFamily="34" charset="-120"/>
               </a:rPr>
               <a:t>40-qubit certified pass — flagship run executing now</a:t>
             </a:r>
-            <a:pPr indent="0" marL="0">
+            <a:endParaRPr lang="en-US" sz="1350" dirty="0"/>
+          </a:p>
+          <a:p>
+            <a:pPr marL="342900" indent="-342900">
               <a:lnSpc>
                 <a:spcPct val="108000"/>
               </a:lnSpc>
               <a:spcAft>
                 <a:spcPts val="1000"/>
               </a:spcAft>
-              <a:buNone/>
+              <a:buSzPct val="100000"/>
+              <a:buChar char="•"/>
             </a:pPr>
             <a:r>
               <a:rPr lang="en-US" sz="1350" dirty="0">
                 <a:solidFill>
-                  <a:srgbClr val="000000"/>
-                </a:solidFill>
+                  <a:srgbClr val="FFFFFF"/>
+                </a:solidFill>
+                <a:latin typeface="Calibri" pitchFamily="34" charset="0"/>
+                <a:ea typeface="Calibri" pitchFamily="34" charset="-122"/>
+                <a:cs typeface="Calibri" pitchFamily="34" charset="-120"/>
               </a:rPr>
               <a:t>Real trapped-ion QPU results — verified circuits already queued</a:t>
             </a:r>
-            <a:pPr indent="0" marL="0">
+            <a:endParaRPr lang="en-US" sz="1350" dirty="0"/>
+          </a:p>
+          <a:p>
+            <a:pPr marL="342900" indent="-342900">
               <a:lnSpc>
                 <a:spcPct val="108000"/>
               </a:lnSpc>
               <a:spcAft>
                 <a:spcPts val="1000"/>
               </a:spcAft>
-              <a:buNone/>
+              <a:buSzPct val="100000"/>
+              <a:buChar char="•"/>
             </a:pPr>
             <a:r>
               <a:rPr lang="en-US" sz="1350" dirty="0">
                 <a:solidFill>
-                  <a:srgbClr val="000000"/>
-                </a:solidFill>
+                  <a:srgbClr val="FFFFFF"/>
+                </a:solidFill>
+                <a:latin typeface="Calibri" pitchFamily="34" charset="0"/>
+                <a:ea typeface="Calibri" pitchFamily="34" charset="-122"/>
+                <a:cs typeface="Calibri" pitchFamily="34" charset="-120"/>
               </a:rPr>
               <a:t>Broader chemistry coverage beyond the demonstrated oxide classes</a:t>
             </a:r>
-            <a:pPr indent="0" marL="0">
+            <a:endParaRPr lang="en-US" sz="1350" dirty="0"/>
+          </a:p>
+          <a:p>
+            <a:pPr marL="342900" indent="-342900">
               <a:lnSpc>
                 <a:spcPct val="108000"/>
               </a:lnSpc>
               <a:spcAft>
                 <a:spcPts val="1000"/>
               </a:spcAft>
-              <a:buNone/>
+              <a:buSzPct val="100000"/>
+              <a:buChar char="•"/>
             </a:pPr>
             <a:r>
               <a:rPr lang="en-US" sz="1350" dirty="0">
                 <a:solidFill>
-                  <a:srgbClr val="000000"/>
-                </a:solidFill>
+                  <a:srgbClr val="FFFFFF"/>
+                </a:solidFill>
+                <a:latin typeface="Calibri" pitchFamily="34" charset="0"/>
+                <a:ea typeface="Calibri" pitchFamily="34" charset="-122"/>
+                <a:cs typeface="Calibri" pitchFamily="34" charset="-120"/>
               </a:rPr>
               <a:t>Device-sampled selection moving the certified frontier past 40 qubits</a:t>
             </a:r>
@@ -5659,10 +5901,13 @@
               <a:buNone/>
             </a:pPr>
             <a:r>
-              <a:rPr lang="en-US" sz="1700" dirty="0">
-                <a:solidFill>
-                  <a:srgbClr val="000000"/>
-                </a:solidFill>
+              <a:rPr lang="en-US" sz="1700" b="1" dirty="0">
+                <a:solidFill>
+                  <a:srgbClr val="16205B"/>
+                </a:solidFill>
+                <a:latin typeface="Calibri" pitchFamily="34" charset="0"/>
+                <a:ea typeface="Calibri" pitchFamily="34" charset="-122"/>
+                <a:cs typeface="Calibri" pitchFamily="34" charset="-120"/>
               </a:rPr>
               <a:t>The ask: </a:t>
             </a:r>
@@ -5675,8 +5920,11 @@
             <a:r>
               <a:rPr lang="en-US" sz="1700" dirty="0">
                 <a:solidFill>
-                  <a:srgbClr val="000000"/>
-                </a:solidFill>
+                  <a:srgbClr val="16205B"/>
+                </a:solidFill>
+                <a:latin typeface="Calibri" pitchFamily="34" charset="0"/>
+                <a:ea typeface="Calibri" pitchFamily="34" charset="-122"/>
+                <a:cs typeface="Calibri" pitchFamily="34" charset="-120"/>
               </a:rPr>
               <a:t>pilot the MATGEN-Q audit on the decision-gate numbers of one live screening program — and count the dead-ends it removes.</a:t>
             </a:r>

</xml_diff>

<commit_message>
Deck: add the fair one-liner (slide 3) + open fine-print on energies-vs-differences (slide 4)
Co-Authored-By: Claude Opus 4.8 <noreply@anthropic.com>
Claude-Session: https://claude.ai/code/session_016ijNmQwafUUda99bWttvKv
</commit_message>
<xml_diff>
--- a/docs/MATGENQ_Audit_CxO.pptx
+++ b/docs/MATGENQ_Audit_CxO.pptx
@@ -3334,34 +3334,37 @@
         </p:nvSpPr>
         <p:spPr>
           <a:xfrm>
-            <a:off x="640080" y="6172200"/>
-            <a:ext cx="10927080" cy="457200"/>
-          </a:xfrm>
-          <a:prstGeom prst="rect">
-            <a:avLst/>
-          </a:prstGeom>
-          <a:noFill/>
-          <a:ln/>
-        </p:spPr>
-        <p:txBody>
-          <a:bodyPr wrap="square" lIns="0" tIns="0" rIns="0" bIns="0" rtlCol="0" anchor="ctr"/>
-          <a:lstStyle/>
-          <a:p>
-            <a:pPr indent="0" marL="0">
-              <a:buNone/>
-            </a:pPr>
-            <a:r>
-              <a:rPr lang="en-US" sz="1250" i="1" dirty="0">
-                <a:solidFill>
-                  <a:srgbClr val="CADCFC"/>
-                </a:solidFill>
-                <a:latin typeface="Calibri" pitchFamily="34" charset="0"/>
-                <a:ea typeface="Calibri" pitchFamily="34" charset="-122"/>
-                <a:cs typeface="Calibri" pitchFamily="34" charset="-120"/>
-              </a:rPr>
-              <a:t>Discipline to match: predictions pre-registered and cryptographically frozen before every decisive run — failures published with the same prominence as wins.</a:t>
-            </a:r>
-            <a:endParaRPr lang="en-US" sz="1250" dirty="0"/>
+            <a:off x="640080" y="6053328"/>
+            <a:ext cx="10927080" cy="685800"/>
+          </a:xfrm>
+          <a:prstGeom prst="rect">
+            <a:avLst/>
+          </a:prstGeom>
+          <a:noFill/>
+          <a:ln/>
+        </p:spPr>
+        <p:txBody>
+          <a:bodyPr wrap="square" lIns="0" tIns="0" rIns="0" bIns="0" rtlCol="0" anchor="ctr"/>
+          <a:lstStyle/>
+          <a:p>
+            <a:pPr indent="0" marL="0">
+              <a:lnSpc>
+                <a:spcPct val="108000"/>
+              </a:lnSpc>
+              <a:buNone/>
+            </a:pPr>
+            <a:r>
+              <a:rPr lang="en-US" sz="1450" b="1" i="1" dirty="0">
+                <a:solidFill>
+                  <a:srgbClr val="02C39A"/>
+                </a:solidFill>
+                <a:latin typeface="Calibri" pitchFamily="34" charset="0"/>
+                <a:ea typeface="Calibri" pitchFamily="34" charset="-122"/>
+                <a:cs typeface="Calibri" pitchFamily="34" charset="-120"/>
+              </a:rPr>
+              <a:t>“It always knows which side of the truth it is on, always knows roughly how far, becomes the truth if you pay enough compute — and can convict other methods of being wrong even before it gets there.”</a:t>
+            </a:r>
+            <a:endParaRPr lang="en-US" sz="1450" dirty="0"/>
           </a:p>
         </p:txBody>
       </p:sp>
@@ -4128,24 +4131,44 @@
         </p:nvSpPr>
         <p:spPr>
           <a:xfrm>
-            <a:off x="640080" y="6172200"/>
-            <a:ext cx="10927080" cy="411480"/>
-          </a:xfrm>
-          <a:prstGeom prst="rect">
-            <a:avLst/>
-          </a:prstGeom>
-          <a:noFill/>
-          <a:ln/>
-        </p:spPr>
-        <p:txBody>
-          <a:bodyPr wrap="square" lIns="0" tIns="0" rIns="0" bIns="0" rtlCol="0" anchor="ctr"/>
-          <a:lstStyle/>
-          <a:p>
-            <a:pPr indent="0" marL="0">
-              <a:buNone/>
-            </a:pPr>
-            <a:r>
-              <a:rPr lang="en-US" sz="1250" i="1" dirty="0">
+            <a:off x="640080" y="6053328"/>
+            <a:ext cx="10927080" cy="731520"/>
+          </a:xfrm>
+          <a:prstGeom prst="rect">
+            <a:avLst/>
+          </a:prstGeom>
+          <a:noFill/>
+          <a:ln/>
+        </p:spPr>
+        <p:txBody>
+          <a:bodyPr wrap="square" lIns="0" tIns="0" rIns="0" bIns="0" rtlCol="0" anchor="ctr"/>
+          <a:lstStyle/>
+          <a:p>
+            <a:pPr indent="0" marL="0">
+              <a:lnSpc>
+                <a:spcPct val="112000"/>
+              </a:lnSpc>
+              <a:buNone/>
+            </a:pPr>
+            <a:r>
+              <a:rPr lang="en-US" sz="1050" b="1" dirty="0">
+                <a:solidFill>
+                  <a:srgbClr val="1A2238"/>
+                </a:solidFill>
+                <a:latin typeface="Calibri" pitchFamily="34" charset="0"/>
+                <a:ea typeface="Calibri" pitchFamily="34" charset="-122"/>
+                <a:cs typeface="Calibri" pitchFamily="34" charset="-120"/>
+              </a:rPr>
+              <a:t>Fine print, stated openly: </a:t>
+            </a:r>
+            <a:pPr indent="0" marL="0">
+              <a:lnSpc>
+                <a:spcPct val="112000"/>
+              </a:lnSpc>
+              <a:buNone/>
+            </a:pPr>
+            <a:r>
+              <a:rPr lang="en-US" sz="1050" dirty="0">
                 <a:solidFill>
                   <a:srgbClr val="6B7280"/>
                 </a:solidFill>
@@ -4153,9 +4176,35 @@
                 <a:ea typeface="Calibri" pitchFamily="34" charset="-122"/>
                 <a:cs typeface="Calibri" pitchFamily="34" charset="-120"/>
               </a:rPr>
-              <a:t>Also in the evidence base: NiO (second oxide class), Sn-oxide EUV photoresist chemistry, and exact-to-the-digit execution on NVIDIA GPUs.</a:t>
-            </a:r>
-            <a:endParaRPr lang="en-US" sz="1250" dirty="0"/>
+              <a:t>the mathematical guarantee applies to energies; verdicts comparing two states (spin gaps) are trusted only after each state is individually converged to certified accuracy — as the CrO and VO calls above were.</a:t>
+            </a:r>
+            <a:pPr indent="0" marL="0">
+              <a:lnSpc>
+                <a:spcPct val="112000"/>
+              </a:lnSpc>
+              <a:buNone/>
+            </a:pPr>
+            <a:endParaRPr lang="en-US" sz="1050" dirty="0"/>
+          </a:p>
+          <a:p>
+            <a:pPr indent="0" marL="0">
+              <a:lnSpc>
+                <a:spcPct val="112000"/>
+              </a:lnSpc>
+              <a:buNone/>
+            </a:pPr>
+            <a:r>
+              <a:rPr lang="en-US" sz="1050" i="1" dirty="0">
+                <a:solidFill>
+                  <a:srgbClr val="6B7280"/>
+                </a:solidFill>
+                <a:latin typeface="Calibri" pitchFamily="34" charset="0"/>
+                <a:ea typeface="Calibri" pitchFamily="34" charset="-122"/>
+                <a:cs typeface="Calibri" pitchFamily="34" charset="-120"/>
+              </a:rPr>
+              <a:t>Also in the evidence base: NiO (second oxide class), Sn-oxide EUV photoresist chemistry, exact-to-the-digit GPU execution.</a:t>
+            </a:r>
+            <a:endParaRPr lang="en-US" sz="1050" dirty="0"/>
           </a:p>
         </p:txBody>
       </p:sp>

</xml_diff>

<commit_message>
Deck: market-size honesty on the economics slide (fine-print motif, slide 5)
Co-Authored-By: Claude Opus 4.8 <noreply@anthropic.com>
Claude-Session: https://claude.ai/code/session_016ijNmQwafUUda99bWttvKv
</commit_message>
<xml_diff>
--- a/docs/MATGENQ_Audit_CxO.pptx
+++ b/docs/MATGENQ_Audit_CxO.pptx
@@ -4827,24 +4827,79 @@
         </p:nvSpPr>
         <p:spPr>
           <a:xfrm>
-            <a:off x="640080" y="6217920"/>
-            <a:ext cx="10881360" cy="411480"/>
-          </a:xfrm>
-          <a:prstGeom prst="rect">
-            <a:avLst/>
-          </a:prstGeom>
-          <a:noFill/>
-          <a:ln/>
-        </p:spPr>
-        <p:txBody>
-          <a:bodyPr wrap="square" lIns="0" tIns="0" rIns="0" bIns="0" rtlCol="0" anchor="ctr"/>
-          <a:lstStyle/>
-          <a:p>
-            <a:pPr indent="0" marL="0">
-              <a:buNone/>
-            </a:pPr>
-            <a:r>
-              <a:rPr lang="en-US" sz="1300" i="1" dirty="0">
+            <a:off x="640080" y="5989320"/>
+            <a:ext cx="10927080" cy="822960"/>
+          </a:xfrm>
+          <a:prstGeom prst="rect">
+            <a:avLst/>
+          </a:prstGeom>
+          <a:noFill/>
+          <a:ln/>
+        </p:spPr>
+        <p:txBody>
+          <a:bodyPr wrap="square" lIns="0" tIns="0" rIns="0" bIns="0" rtlCol="0" anchor="ctr"/>
+          <a:lstStyle/>
+          <a:p>
+            <a:pPr indent="0" marL="0">
+              <a:lnSpc>
+                <a:spcPct val="112000"/>
+              </a:lnSpc>
+              <a:buNone/>
+            </a:pPr>
+            <a:r>
+              <a:rPr lang="en-US" sz="1250" i="1" dirty="0">
+                <a:solidFill>
+                  <a:srgbClr val="1A2238"/>
+                </a:solidFill>
+                <a:latin typeface="Calibri" pitchFamily="34" charset="0"/>
+                <a:ea typeface="Calibri" pitchFamily="34" charset="-122"/>
+                <a:cs typeface="Calibri" pitchFamily="34" charset="-120"/>
+              </a:rPr>
+              <a:t>You don’t X-ray every weld in the shipyard — you X-ray the ones the hull depends on.</a:t>
+            </a:r>
+            <a:pPr indent="0" marL="0">
+              <a:lnSpc>
+                <a:spcPct val="112000"/>
+              </a:lnSpc>
+              <a:buNone/>
+            </a:pPr>
+            <a:r>
+              <a:rPr lang="en-US" sz="1050" dirty="0">
+                <a:solidFill>
+                  <a:srgbClr val="1A2238"/>
+                </a:solidFill>
+                <a:latin typeface="Calibri" pitchFamily="34" charset="0"/>
+                <a:ea typeface="Calibri" pitchFamily="34" charset="-122"/>
+                <a:cs typeface="Calibri" pitchFamily="34" charset="-120"/>
+              </a:rPr>
+              <a:t>
+</a:t>
+            </a:r>
+            <a:pPr indent="0" marL="0">
+              <a:lnSpc>
+                <a:spcPct val="112000"/>
+              </a:lnSpc>
+              <a:buNone/>
+            </a:pPr>
+            <a:r>
+              <a:rPr lang="en-US" sz="1050" b="1" dirty="0">
+                <a:solidFill>
+                  <a:srgbClr val="1A2238"/>
+                </a:solidFill>
+                <a:latin typeface="Calibri" pitchFamily="34" charset="0"/>
+                <a:ea typeface="Calibri" pitchFamily="34" charset="-122"/>
+                <a:cs typeface="Calibri" pitchFamily="34" charset="-120"/>
+              </a:rPr>
+              <a:t>Fine print, stated openly: </a:t>
+            </a:r>
+            <a:pPr indent="0" marL="0">
+              <a:lnSpc>
+                <a:spcPct val="112000"/>
+              </a:lnSpc>
+              <a:buNone/>
+            </a:pPr>
+            <a:r>
+              <a:rPr lang="en-US" sz="1050" dirty="0">
                 <a:solidFill>
                   <a:srgbClr val="6B7280"/>
                 </a:solidFill>
@@ -4852,9 +4907,9 @@
                 <a:ea typeface="Calibri" pitchFamily="34" charset="-122"/>
                 <a:cs typeface="Calibri" pitchFamily="34" charset="-120"/>
               </a:rPr>
-              <a:t>You don’t X-ray every weld in the shipyard — you X-ray the ones the hull depends on.</a:t>
-            </a:r>
-            <a:endParaRPr lang="en-US" sz="1300" dirty="0"/>
+              <a:t>we do not claim a validated market size. Coverage today is the demonstrated oxide classes, and the audit certifies the correlated-electron solve — the silent-failure part — not every assumption in the modeling stack. The defensible claim is the one above: one avoided dead-end pays for the layer.</a:t>
+            </a:r>
+            <a:endParaRPr lang="en-US" sz="1050" dirty="0"/>
           </a:p>
         </p:txBody>
       </p:sp>

</xml_diff>

<commit_message>
Deck: new slide 4 — four-tier 'what the stamp covers' taxonomy
Guaranteed (single energies) / conditional (energy differences) /
estimate (PT2 extrapolations) / not claimed (upstream assumptions),
each with an evidence-backed example. Deck is now 8 slides; color,
bounds, and XML-schema audit clean.

Co-Authored-By: Claude Fable 5 <noreply@anthropic.com>
Claude-Session: https://claude.ai/code/session_016ijNmQwafUUda99bWttvKv
</commit_message>
<xml_diff>
--- a/docs/MATGENQ_Audit_CxO.pptx
+++ b/docs/MATGENQ_Audit_CxO.pptx
@@ -12,9 +12,10 @@
     <p:sldId id="260" r:id="rId6"/>
     <p:sldId id="261" r:id="rId7"/>
     <p:sldId id="262" r:id="rId8"/>
+    <p:sldId id="263" r:id="rId9"/>
   </p:sldIdLst>
   <p:notesMasterIdLst>
-    <p:notesMasterId r:id="rId9"/>
+    <p:notesMasterId r:id="rId10"/>
   </p:notesMasterIdLst>
   <p:sldSz cx="12192000" cy="6858000"/>
   <p:notesSz cx="6858000" cy="12192000"/>
@@ -1078,6 +1079,94 @@
 </p:notes>
 </file>
 
+<file path=ppt/notesSlides/notesSlide8.xml><?xml version="1.0" encoding="utf-8"?>
+<p:notes xmlns:a="http://schemas.openxmlformats.org/drawingml/2006/main" xmlns:r="http://schemas.openxmlformats.org/officeDocument/2006/relationships" xmlns:p="http://schemas.openxmlformats.org/presentationml/2006/main">
+  <p:cSld>
+    <p:spTree>
+      <p:nvGrpSpPr>
+        <p:cNvPr id="1" name=""/>
+        <p:cNvGrpSpPr/>
+        <p:nvPr/>
+      </p:nvGrpSpPr>
+      <p:grpSpPr>
+        <a:xfrm>
+          <a:off x="0" y="0"/>
+          <a:ext cx="0" cy="0"/>
+          <a:chOff x="0" y="0"/>
+          <a:chExt cx="0" cy="0"/>
+        </a:xfrm>
+      </p:grpSpPr>
+      <p:sp>
+        <p:nvSpPr>
+          <p:cNvPr id="2" name="Slide Image Placeholder 1"/>
+          <p:cNvSpPr>
+            <a:spLocks noGrp="1" noRot="1" noChangeAspect="1"/>
+          </p:cNvSpPr>
+          <p:nvPr>
+            <p:ph type="sldImg"/>
+          </p:nvPr>
+        </p:nvSpPr>
+        <p:spPr/>
+      </p:sp>
+      <p:sp>
+        <p:nvSpPr>
+          <p:cNvPr id="3" name="Notes Placeholder 2"/>
+          <p:cNvSpPr>
+            <a:spLocks noGrp="1"/>
+          </p:cNvSpPr>
+          <p:nvPr>
+            <p:ph type="body" idx="1"/>
+          </p:nvPr>
+        </p:nvSpPr>
+        <p:spPr/>
+        <p:txBody>
+          <a:bodyPr/>
+          <a:lstStyle/>
+          <a:p>
+            <a:r>
+              <a:rPr lang="en-US" dirty="0"/>
+              <a:t/>
+            </a:r>
+            <a:endParaRPr lang="en-US" dirty="0"/>
+          </a:p>
+        </p:txBody>
+      </p:sp>
+      <p:sp>
+        <p:nvSpPr>
+          <p:cNvPr id="4" name="Slide Number Placeholder 3"/>
+          <p:cNvSpPr>
+            <a:spLocks noGrp="1"/>
+          </p:cNvSpPr>
+          <p:nvPr>
+            <p:ph type="sldNum" sz="quarter" idx="10"/>
+          </p:nvPr>
+        </p:nvSpPr>
+        <p:spPr/>
+        <p:txBody>
+          <a:bodyPr/>
+          <a:lstStyle/>
+          <a:p>
+            <a:fld id="{F7021451-1387-4CA6-816F-3879F97B5CBC}" type="slidenum">
+              <a:rPr lang="en-US"/>
+              <a:t>8</a:t>
+            </a:fld>
+            <a:endParaRPr lang="en-US"/>
+          </a:p>
+        </p:txBody>
+      </p:sp>
+    </p:spTree>
+    <p:extLst>
+      <p:ext uri="{BB962C8B-B14F-4D97-AF65-F5344CB8AC3E}">
+        <p14:creationId xmlns:p14="http://schemas.microsoft.com/office/powerpoint/2010/main" val="1024086991"/>
+      </p:ext>
+    </p:extLst>
+  </p:cSld>
+  <p:clrMapOvr>
+    <a:masterClrMapping/>
+  </p:clrMapOvr>
+</p:notes>
+</file>
+
 <file path=ppt/slideLayouts/slideLayout1.xml><?xml version="1.0" encoding="utf-8"?>
 <p:sldLayout xmlns:a="http://schemas.openxmlformats.org/drawingml/2006/main" xmlns:r="http://schemas.openxmlformats.org/officeDocument/2006/relationships" xmlns:p="http://schemas.openxmlformats.org/presentationml/2006/main" preserve="1">
   <p:cSld name="DEFAULT">
@@ -3433,7 +3522,7 @@
                 <a:ea typeface="Calibri" pitchFamily="34" charset="-122"/>
                 <a:cs typeface="Calibri" pitchFamily="34" charset="-120"/>
               </a:rPr>
-              <a:t>Proof, not promises — audited against nature and at scale</a:t>
+              <a:t>What the stamp covers — and what it doesn’t</a:t>
             </a:r>
             <a:endParaRPr lang="en-US" sz="3200" dirty="0"/>
           </a:p>
@@ -3441,18 +3530,57 @@
       </p:sp>
       <p:sp>
         <p:nvSpPr>
-          <p:cNvPr id="3" name="Shape 1"/>
-          <p:cNvSpPr/>
-          <p:nvPr/>
-        </p:nvSpPr>
-        <p:spPr>
-          <a:xfrm>
-            <a:off x="640080" y="1234440"/>
-            <a:ext cx="5349240" cy="2194560"/>
+          <p:cNvPr id="3" name="Text 1"/>
+          <p:cNvSpPr/>
+          <p:nvPr/>
+        </p:nvSpPr>
+        <p:spPr>
+          <a:xfrm>
+            <a:off x="640080" y="1051560"/>
+            <a:ext cx="10881360" cy="411480"/>
+          </a:xfrm>
+          <a:prstGeom prst="rect">
+            <a:avLst/>
+          </a:prstGeom>
+          <a:noFill/>
+          <a:ln/>
+        </p:spPr>
+        <p:txBody>
+          <a:bodyPr wrap="square" lIns="0" tIns="0" rIns="0" bIns="0" rtlCol="0" anchor="ctr"/>
+          <a:lstStyle/>
+          <a:p>
+            <a:pPr indent="0" marL="0">
+              <a:buNone/>
+            </a:pPr>
+            <a:r>
+              <a:rPr lang="en-US" sz="1500" dirty="0">
+                <a:solidFill>
+                  <a:srgbClr val="6B7280"/>
+                </a:solidFill>
+                <a:latin typeface="Calibri" pitchFamily="34" charset="0"/>
+                <a:ea typeface="Calibri" pitchFamily="34" charset="-122"/>
+                <a:cs typeface="Calibri" pitchFamily="34" charset="-120"/>
+              </a:rPr>
+              <a:t>The guarantee is a scalpel, not a blanket. Four tiers of claim, each labeled on the product itself:</a:t>
+            </a:r>
+            <a:endParaRPr lang="en-US" sz="1500" dirty="0"/>
+          </a:p>
+        </p:txBody>
+      </p:sp>
+      <p:sp>
+        <p:nvSpPr>
+          <p:cNvPr id="4" name="Shape 2"/>
+          <p:cNvSpPr/>
+          <p:nvPr/>
+        </p:nvSpPr>
+        <p:spPr>
+          <a:xfrm>
+            <a:off x="640080" y="1600200"/>
+            <a:ext cx="10927080" cy="1060704"/>
           </a:xfrm>
           <a:prstGeom prst="roundRect">
             <a:avLst>
-              <a:gd name="adj" fmla="val 3750"/>
+              <a:gd name="adj" fmla="val 7759"/>
             </a:avLst>
           </a:prstGeom>
           <a:solidFill>
@@ -3460,9 +3588,9 @@
           </a:solidFill>
           <a:ln/>
           <a:effectLst>
-            <a:outerShdw sx="100000" sy="100000" kx="0" ky="0" algn="bl" rotWithShape="0" blurRad="88900" dist="25400" dir="5400000">
+            <a:outerShdw sx="100000" sy="100000" kx="0" ky="0" algn="bl" rotWithShape="0" blurRad="76200" dist="25400" dir="5400000">
               <a:srgbClr val="9AA3B2">
-                <a:alpha val="32000"/>
+                <a:alpha val="30000"/>
               </a:srgbClr>
             </a:outerShdw>
           </a:effectLst>
@@ -3470,14 +3598,139 @@
       </p:sp>
       <p:sp>
         <p:nvSpPr>
-          <p:cNvPr id="4" name="Shape 2"/>
-          <p:cNvSpPr/>
-          <p:nvPr/>
-        </p:nvSpPr>
-        <p:spPr>
-          <a:xfrm>
-            <a:off x="896112" y="1472184"/>
-            <a:ext cx="1600200" cy="310896"/>
+          <p:cNvPr id="5" name="Shape 3"/>
+          <p:cNvSpPr/>
+          <p:nvPr/>
+        </p:nvSpPr>
+        <p:spPr>
+          <a:xfrm>
+            <a:off x="896112" y="1837944"/>
+            <a:ext cx="585216" cy="585216"/>
+          </a:xfrm>
+          <a:prstGeom prst="ellipse">
+            <a:avLst/>
+          </a:prstGeom>
+          <a:solidFill>
+            <a:srgbClr val="02C39A"/>
+          </a:solidFill>
+          <a:ln/>
+        </p:spPr>
+      </p:sp>
+      <p:pic>
+        <p:nvPicPr>
+          <p:cNvPr id="6" name="Image 0" descr="preencoded.png">    </p:cNvPr>
+          <p:cNvPicPr>
+            <a:picLocks noChangeAspect="1"/>
+          </p:cNvPicPr>
+          <p:nvPr/>
+        </p:nvPicPr>
+        <p:blipFill>
+          <a:blip r:embed="rId1"/>
+          <a:stretch>
+            <a:fillRect/>
+          </a:stretch>
+        </p:blipFill>
+        <p:spPr>
+          <a:xfrm>
+            <a:off x="1048268" y="1990100"/>
+            <a:ext cx="280904" cy="280904"/>
+          </a:xfrm>
+          <a:prstGeom prst="rect">
+            <a:avLst/>
+          </a:prstGeom>
+        </p:spPr>
+      </p:pic>
+      <p:sp>
+        <p:nvSpPr>
+          <p:cNvPr id="7" name="Text 4"/>
+          <p:cNvSpPr/>
+          <p:nvPr/>
+        </p:nvSpPr>
+        <p:spPr>
+          <a:xfrm>
+            <a:off x="1737360" y="1709928"/>
+            <a:ext cx="7680960" cy="365760"/>
+          </a:xfrm>
+          <a:prstGeom prst="rect">
+            <a:avLst/>
+          </a:prstGeom>
+          <a:noFill/>
+          <a:ln/>
+        </p:spPr>
+        <p:txBody>
+          <a:bodyPr wrap="square" lIns="0" tIns="0" rIns="0" bIns="0" rtlCol="0" anchor="ctr"/>
+          <a:lstStyle/>
+          <a:p>
+            <a:pPr indent="0" marL="0">
+              <a:buNone/>
+            </a:pPr>
+            <a:r>
+              <a:rPr lang="en-US" sz="1650" b="1" dirty="0">
+                <a:solidFill>
+                  <a:srgbClr val="1A2238"/>
+                </a:solidFill>
+                <a:latin typeface="Calibri" pitchFamily="34" charset="0"/>
+                <a:ea typeface="Calibri" pitchFamily="34" charset="-122"/>
+                <a:cs typeface="Calibri" pitchFamily="34" charset="-120"/>
+              </a:rPr>
+              <a:t>Single energies</a:t>
+            </a:r>
+            <a:endParaRPr lang="en-US" sz="1650" dirty="0"/>
+          </a:p>
+        </p:txBody>
+      </p:sp>
+      <p:sp>
+        <p:nvSpPr>
+          <p:cNvPr id="8" name="Text 5"/>
+          <p:cNvSpPr/>
+          <p:nvPr/>
+        </p:nvSpPr>
+        <p:spPr>
+          <a:xfrm>
+            <a:off x="1737360" y="2075688"/>
+            <a:ext cx="7772400" cy="548640"/>
+          </a:xfrm>
+          <a:prstGeom prst="rect">
+            <a:avLst/>
+          </a:prstGeom>
+          <a:noFill/>
+          <a:ln/>
+        </p:spPr>
+        <p:txBody>
+          <a:bodyPr wrap="square" lIns="0" tIns="0" rIns="0" bIns="0" rtlCol="0" anchor="ctr"/>
+          <a:lstStyle/>
+          <a:p>
+            <a:pPr indent="0" marL="0">
+              <a:lnSpc>
+                <a:spcPct val="108000"/>
+              </a:lnSpc>
+              <a:buNone/>
+            </a:pPr>
+            <a:r>
+              <a:rPr lang="en-US" sz="1150" dirty="0">
+                <a:solidFill>
+                  <a:srgbClr val="1A2238"/>
+                </a:solidFill>
+                <a:latin typeface="Calibri" pitchFamily="34" charset="0"/>
+                <a:ea typeface="Calibri" pitchFamily="34" charset="-122"/>
+                <a:cs typeface="Calibri" pitchFamily="34" charset="-120"/>
+              </a:rPr>
+              <a:t>The variational bound and its error certificate apply directly — mathematics, not benchmarking. Every point of the CrO bond-breaking curve held to ≤2.8 mHa while CCSD(T) drifted by up to ~140.</a:t>
+            </a:r>
+            <a:endParaRPr lang="en-US" sz="1150" dirty="0"/>
+          </a:p>
+        </p:txBody>
+      </p:sp>
+      <p:sp>
+        <p:nvSpPr>
+          <p:cNvPr id="9" name="Shape 6"/>
+          <p:cNvSpPr/>
+          <p:nvPr/>
+        </p:nvSpPr>
+        <p:spPr>
+          <a:xfrm>
+            <a:off x="9738360" y="1975104"/>
+            <a:ext cx="1645920" cy="310896"/>
           </a:xfrm>
           <a:prstGeom prst="roundRect">
             <a:avLst>
@@ -3492,14 +3745,14 @@
       </p:sp>
       <p:sp>
         <p:nvSpPr>
-          <p:cNvPr id="5" name="Text 3"/>
-          <p:cNvSpPr/>
-          <p:nvPr/>
-        </p:nvSpPr>
-        <p:spPr>
-          <a:xfrm>
-            <a:off x="896112" y="1458468"/>
-            <a:ext cx="1600200" cy="338328"/>
+          <p:cNvPr id="10" name="Text 7"/>
+          <p:cNvSpPr/>
+          <p:nvPr/>
+        </p:nvSpPr>
+        <p:spPr>
+          <a:xfrm>
+            <a:off x="9738360" y="1961388"/>
+            <a:ext cx="1645920" cy="338328"/>
           </a:xfrm>
           <a:prstGeom prst="rect">
             <a:avLst/>
@@ -3523,7 +3776,7 @@
                 <a:ea typeface="Calibri" pitchFamily="34" charset="-122"/>
                 <a:cs typeface="Calibri" pitchFamily="34" charset="-120"/>
               </a:rPr>
-              <a:t>LAB-VERIFIED</a:t>
+              <a:t>GUARANTEED</a:t>
             </a:r>
             <a:endParaRPr lang="en-US" sz="1100" dirty="0"/>
           </a:p>
@@ -3531,99 +3784,18 @@
       </p:sp>
       <p:sp>
         <p:nvSpPr>
-          <p:cNvPr id="6" name="Text 4"/>
-          <p:cNvSpPr/>
-          <p:nvPr/>
-        </p:nvSpPr>
-        <p:spPr>
-          <a:xfrm>
-            <a:off x="896112" y="1856232"/>
-            <a:ext cx="4837176" cy="411480"/>
-          </a:xfrm>
-          <a:prstGeom prst="rect">
-            <a:avLst/>
-          </a:prstGeom>
-          <a:noFill/>
-          <a:ln/>
-        </p:spPr>
-        <p:txBody>
-          <a:bodyPr wrap="square" lIns="0" tIns="0" rIns="0" bIns="0" rtlCol="0" anchor="ctr"/>
-          <a:lstStyle/>
-          <a:p>
-            <a:pPr indent="0" marL="0">
-              <a:buNone/>
-            </a:pPr>
-            <a:r>
-              <a:rPr lang="en-US" sz="1800" b="1" dirty="0">
-                <a:solidFill>
-                  <a:srgbClr val="1A2238"/>
-                </a:solidFill>
-                <a:latin typeface="Calibri" pitchFamily="34" charset="0"/>
-                <a:ea typeface="Calibri" pitchFamily="34" charset="-122"/>
-                <a:cs typeface="Calibri" pitchFamily="34" charset="-120"/>
-              </a:rPr>
-              <a:t>CrO ground state</a:t>
-            </a:r>
-            <a:endParaRPr lang="en-US" sz="1800" dirty="0"/>
-          </a:p>
-        </p:txBody>
-      </p:sp>
-      <p:sp>
-        <p:nvSpPr>
-          <p:cNvPr id="7" name="Text 5"/>
-          <p:cNvSpPr/>
-          <p:nvPr/>
-        </p:nvSpPr>
-        <p:spPr>
-          <a:xfrm>
-            <a:off x="896112" y="2276856"/>
-            <a:ext cx="4837176" cy="1051560"/>
-          </a:xfrm>
-          <a:prstGeom prst="rect">
-            <a:avLst/>
-          </a:prstGeom>
-          <a:noFill/>
-          <a:ln/>
-        </p:spPr>
-        <p:txBody>
-          <a:bodyPr wrap="square" lIns="0" tIns="0" rIns="0" bIns="0" rtlCol="0" anchor="ctr"/>
-          <a:lstStyle/>
-          <a:p>
-            <a:pPr indent="0" marL="0">
-              <a:lnSpc>
-                <a:spcPct val="112000"/>
-              </a:lnSpc>
-              <a:buNone/>
-            </a:pPr>
-            <a:r>
-              <a:rPr lang="en-US" sz="1280" dirty="0">
-                <a:solidFill>
-                  <a:srgbClr val="1A2238"/>
-                </a:solidFill>
-                <a:latin typeface="Calibri" pitchFamily="34" charset="0"/>
-                <a:ea typeface="Calibri" pitchFamily="34" charset="-122"/>
-                <a:cs typeface="Calibri" pitchFamily="34" charset="-120"/>
-              </a:rPr>
-              <a:t>DFT (B3LYP) predicts the wrong ground state. The audit predicts the one measured in the laboratory — decades of spectroscopy agree with us, not DFT.</a:t>
-            </a:r>
-            <a:endParaRPr lang="en-US" sz="1280" dirty="0"/>
-          </a:p>
-        </p:txBody>
-      </p:sp>
-      <p:sp>
-        <p:nvSpPr>
-          <p:cNvPr id="8" name="Shape 6"/>
-          <p:cNvSpPr/>
-          <p:nvPr/>
-        </p:nvSpPr>
-        <p:spPr>
-          <a:xfrm>
-            <a:off x="6245352" y="1234440"/>
-            <a:ext cx="5349240" cy="2194560"/>
+          <p:cNvPr id="11" name="Shape 8"/>
+          <p:cNvSpPr/>
+          <p:nvPr/>
+        </p:nvSpPr>
+        <p:spPr>
+          <a:xfrm>
+            <a:off x="640080" y="2788920"/>
+            <a:ext cx="10927080" cy="1060704"/>
           </a:xfrm>
           <a:prstGeom prst="roundRect">
             <a:avLst>
-              <a:gd name="adj" fmla="val 3750"/>
+              <a:gd name="adj" fmla="val 7759"/>
             </a:avLst>
           </a:prstGeom>
           <a:solidFill>
@@ -3631,9 +3803,9 @@
           </a:solidFill>
           <a:ln/>
           <a:effectLst>
-            <a:outerShdw sx="100000" sy="100000" kx="0" ky="0" algn="bl" rotWithShape="0" blurRad="88900" dist="25400" dir="5400000">
+            <a:outerShdw sx="100000" sy="100000" kx="0" ky="0" algn="bl" rotWithShape="0" blurRad="76200" dist="25400" dir="5400000">
               <a:srgbClr val="9AA3B2">
-                <a:alpha val="32000"/>
+                <a:alpha val="30000"/>
               </a:srgbClr>
             </a:outerShdw>
           </a:effectLst>
@@ -3641,14 +3813,139 @@
       </p:sp>
       <p:sp>
         <p:nvSpPr>
-          <p:cNvPr id="9" name="Shape 7"/>
-          <p:cNvSpPr/>
-          <p:nvPr/>
-        </p:nvSpPr>
-        <p:spPr>
-          <a:xfrm>
-            <a:off x="6501384" y="1472184"/>
-            <a:ext cx="1600200" cy="310896"/>
+          <p:cNvPr id="12" name="Shape 9"/>
+          <p:cNvSpPr/>
+          <p:nvPr/>
+        </p:nvSpPr>
+        <p:spPr>
+          <a:xfrm>
+            <a:off x="896112" y="3026664"/>
+            <a:ext cx="585216" cy="585216"/>
+          </a:xfrm>
+          <a:prstGeom prst="ellipse">
+            <a:avLst/>
+          </a:prstGeom>
+          <a:solidFill>
+            <a:srgbClr val="F0A202"/>
+          </a:solidFill>
+          <a:ln/>
+        </p:spPr>
+      </p:sp>
+      <p:pic>
+        <p:nvPicPr>
+          <p:cNvPr id="13" name="Image 1" descr="preencoded.png">    </p:cNvPr>
+          <p:cNvPicPr>
+            <a:picLocks noChangeAspect="1"/>
+          </p:cNvPicPr>
+          <p:nvPr/>
+        </p:nvPicPr>
+        <p:blipFill>
+          <a:blip r:embed="rId2"/>
+          <a:stretch>
+            <a:fillRect/>
+          </a:stretch>
+        </p:blipFill>
+        <p:spPr>
+          <a:xfrm>
+            <a:off x="1048268" y="3178820"/>
+            <a:ext cx="280904" cy="280904"/>
+          </a:xfrm>
+          <a:prstGeom prst="rect">
+            <a:avLst/>
+          </a:prstGeom>
+        </p:spPr>
+      </p:pic>
+      <p:sp>
+        <p:nvSpPr>
+          <p:cNvPr id="14" name="Text 10"/>
+          <p:cNvSpPr/>
+          <p:nvPr/>
+        </p:nvSpPr>
+        <p:spPr>
+          <a:xfrm>
+            <a:off x="1737360" y="2898648"/>
+            <a:ext cx="7680960" cy="365760"/>
+          </a:xfrm>
+          <a:prstGeom prst="rect">
+            <a:avLst/>
+          </a:prstGeom>
+          <a:noFill/>
+          <a:ln/>
+        </p:spPr>
+        <p:txBody>
+          <a:bodyPr wrap="square" lIns="0" tIns="0" rIns="0" bIns="0" rtlCol="0" anchor="ctr"/>
+          <a:lstStyle/>
+          <a:p>
+            <a:pPr indent="0" marL="0">
+              <a:buNone/>
+            </a:pPr>
+            <a:r>
+              <a:rPr lang="en-US" sz="1650" b="1" dirty="0">
+                <a:solidFill>
+                  <a:srgbClr val="1A2238"/>
+                </a:solidFill>
+                <a:latin typeface="Calibri" pitchFamily="34" charset="0"/>
+                <a:ea typeface="Calibri" pitchFamily="34" charset="-122"/>
+                <a:cs typeface="Calibri" pitchFamily="34" charset="-120"/>
+              </a:rPr>
+              <a:t>Energy differences — spin gaps, barriers</a:t>
+            </a:r>
+            <a:endParaRPr lang="en-US" sz="1650" dirty="0"/>
+          </a:p>
+        </p:txBody>
+      </p:sp>
+      <p:sp>
+        <p:nvSpPr>
+          <p:cNvPr id="15" name="Text 11"/>
+          <p:cNvSpPr/>
+          <p:nvPr/>
+        </p:nvSpPr>
+        <p:spPr>
+          <a:xfrm>
+            <a:off x="1737360" y="3264408"/>
+            <a:ext cx="7772400" cy="548640"/>
+          </a:xfrm>
+          <a:prstGeom prst="rect">
+            <a:avLst/>
+          </a:prstGeom>
+          <a:noFill/>
+          <a:ln/>
+        </p:spPr>
+        <p:txBody>
+          <a:bodyPr wrap="square" lIns="0" tIns="0" rIns="0" bIns="0" rtlCol="0" anchor="ctr"/>
+          <a:lstStyle/>
+          <a:p>
+            <a:pPr indent="0" marL="0">
+              <a:lnSpc>
+                <a:spcPct val="108000"/>
+              </a:lnSpc>
+              <a:buNone/>
+            </a:pPr>
+            <a:r>
+              <a:rPr lang="en-US" sz="1150" dirty="0">
+                <a:solidFill>
+                  <a:srgbClr val="1A2238"/>
+                </a:solidFill>
+                <a:latin typeface="Calibri" pitchFamily="34" charset="0"/>
+                <a:ea typeface="Calibri" pitchFamily="34" charset="-122"/>
+                <a:cs typeface="Calibri" pitchFamily="34" charset="-120"/>
+              </a:rPr>
+              <a:t>A difference of two one-sided bounds is not itself one-sided. A verdict is issued only after each state is individually converged to certified accuracy — exactly how the CrO and blind VO ground-state calls were made.</a:t>
+            </a:r>
+            <a:endParaRPr lang="en-US" sz="1150" dirty="0"/>
+          </a:p>
+        </p:txBody>
+      </p:sp>
+      <p:sp>
+        <p:nvSpPr>
+          <p:cNvPr id="16" name="Shape 12"/>
+          <p:cNvSpPr/>
+          <p:nvPr/>
+        </p:nvSpPr>
+        <p:spPr>
+          <a:xfrm>
+            <a:off x="9738360" y="3163824"/>
+            <a:ext cx="1645920" cy="310896"/>
           </a:xfrm>
           <a:prstGeom prst="roundRect">
             <a:avLst>
@@ -3663,14 +3960,14 @@
       </p:sp>
       <p:sp>
         <p:nvSpPr>
-          <p:cNvPr id="10" name="Text 8"/>
-          <p:cNvSpPr/>
-          <p:nvPr/>
-        </p:nvSpPr>
-        <p:spPr>
-          <a:xfrm>
-            <a:off x="6501384" y="1458468"/>
-            <a:ext cx="1600200" cy="338328"/>
+          <p:cNvPr id="17" name="Text 13"/>
+          <p:cNvSpPr/>
+          <p:nvPr/>
+        </p:nvSpPr>
+        <p:spPr>
+          <a:xfrm>
+            <a:off x="9738360" y="3150108"/>
+            <a:ext cx="1645920" cy="338328"/>
           </a:xfrm>
           <a:prstGeom prst="rect">
             <a:avLst/>
@@ -3694,7 +3991,7 @@
                 <a:ea typeface="Calibri" pitchFamily="34" charset="-122"/>
                 <a:cs typeface="Calibri" pitchFamily="34" charset="-120"/>
               </a:rPr>
-              <a:t>BLIND TEST</a:t>
+              <a:t>CONDITIONAL</a:t>
             </a:r>
             <a:endParaRPr lang="en-US" sz="1100" dirty="0"/>
           </a:p>
@@ -3702,99 +3999,18 @@
       </p:sp>
       <p:sp>
         <p:nvSpPr>
-          <p:cNvPr id="11" name="Text 9"/>
-          <p:cNvSpPr/>
-          <p:nvPr/>
-        </p:nvSpPr>
-        <p:spPr>
-          <a:xfrm>
-            <a:off x="6501384" y="1856232"/>
-            <a:ext cx="4837176" cy="411480"/>
-          </a:xfrm>
-          <a:prstGeom prst="rect">
-            <a:avLst/>
-          </a:prstGeom>
-          <a:noFill/>
-          <a:ln/>
-        </p:spPr>
-        <p:txBody>
-          <a:bodyPr wrap="square" lIns="0" tIns="0" rIns="0" bIns="0" rtlCol="0" anchor="ctr"/>
-          <a:lstStyle/>
-          <a:p>
-            <a:pPr indent="0" marL="0">
-              <a:buNone/>
-            </a:pPr>
-            <a:r>
-              <a:rPr lang="en-US" sz="1800" b="1" dirty="0">
-                <a:solidFill>
-                  <a:srgbClr val="1A2238"/>
-                </a:solidFill>
-                <a:latin typeface="Calibri" pitchFamily="34" charset="0"/>
-                <a:ea typeface="Calibri" pitchFamily="34" charset="-122"/>
-                <a:cs typeface="Calibri" pitchFamily="34" charset="-120"/>
-              </a:rPr>
-              <a:t>VO ground state — predicted blind</a:t>
-            </a:r>
-            <a:endParaRPr lang="en-US" sz="1800" dirty="0"/>
-          </a:p>
-        </p:txBody>
-      </p:sp>
-      <p:sp>
-        <p:nvSpPr>
-          <p:cNvPr id="12" name="Text 10"/>
-          <p:cNvSpPr/>
-          <p:nvPr/>
-        </p:nvSpPr>
-        <p:spPr>
-          <a:xfrm>
-            <a:off x="6501384" y="2276856"/>
-            <a:ext cx="4837176" cy="1051560"/>
-          </a:xfrm>
-          <a:prstGeom prst="rect">
-            <a:avLst/>
-          </a:prstGeom>
-          <a:noFill/>
-          <a:ln/>
-        </p:spPr>
-        <p:txBody>
-          <a:bodyPr wrap="square" lIns="0" tIns="0" rIns="0" bIns="0" rtlCol="0" anchor="ctr"/>
-          <a:lstStyle/>
-          <a:p>
-            <a:pPr indent="0" marL="0">
-              <a:lnSpc>
-                <a:spcPct val="112000"/>
-              </a:lnSpc>
-              <a:buNone/>
-            </a:pPr>
-            <a:r>
-              <a:rPr lang="en-US" sz="1280" dirty="0">
-                <a:solidFill>
-                  <a:srgbClr val="1A2238"/>
-                </a:solidFill>
-                <a:latin typeface="Calibri" pitchFamily="34" charset="0"/>
-                <a:ea typeface="Calibri" pitchFamily="34" charset="-122"/>
-                <a:cs typeface="Calibri" pitchFamily="34" charset="-120"/>
-              </a:rPr>
-              <a:t>Prediction locked by cryptographic hash before the single frozen run. Result: matches the laboratory ground state. The audit is right when it cannot possibly peek.</a:t>
-            </a:r>
-            <a:endParaRPr lang="en-US" sz="1280" dirty="0"/>
-          </a:p>
-        </p:txBody>
-      </p:sp>
-      <p:sp>
-        <p:nvSpPr>
-          <p:cNvPr id="13" name="Shape 11"/>
-          <p:cNvSpPr/>
-          <p:nvPr/>
-        </p:nvSpPr>
-        <p:spPr>
-          <a:xfrm>
-            <a:off x="640080" y="3630168"/>
-            <a:ext cx="5349240" cy="2194560"/>
+          <p:cNvPr id="18" name="Shape 14"/>
+          <p:cNvSpPr/>
+          <p:nvPr/>
+        </p:nvSpPr>
+        <p:spPr>
+          <a:xfrm>
+            <a:off x="640080" y="3977640"/>
+            <a:ext cx="10927080" cy="1060704"/>
           </a:xfrm>
           <a:prstGeom prst="roundRect">
             <a:avLst>
-              <a:gd name="adj" fmla="val 3750"/>
+              <a:gd name="adj" fmla="val 7759"/>
             </a:avLst>
           </a:prstGeom>
           <a:solidFill>
@@ -3802,9 +4018,9 @@
           </a:solidFill>
           <a:ln/>
           <a:effectLst>
-            <a:outerShdw sx="100000" sy="100000" kx="0" ky="0" algn="bl" rotWithShape="0" blurRad="88900" dist="25400" dir="5400000">
+            <a:outerShdw sx="100000" sy="100000" kx="0" ky="0" algn="bl" rotWithShape="0" blurRad="76200" dist="25400" dir="5400000">
               <a:srgbClr val="9AA3B2">
-                <a:alpha val="32000"/>
+                <a:alpha val="30000"/>
               </a:srgbClr>
             </a:outerShdw>
           </a:effectLst>
@@ -3812,14 +4028,139 @@
       </p:sp>
       <p:sp>
         <p:nvSpPr>
-          <p:cNvPr id="14" name="Shape 12"/>
-          <p:cNvSpPr/>
-          <p:nvPr/>
-        </p:nvSpPr>
-        <p:spPr>
-          <a:xfrm>
-            <a:off x="896112" y="3867912"/>
-            <a:ext cx="1600200" cy="310896"/>
+          <p:cNvPr id="19" name="Shape 15"/>
+          <p:cNvSpPr/>
+          <p:nvPr/>
+        </p:nvSpPr>
+        <p:spPr>
+          <a:xfrm>
+            <a:off x="896112" y="4215384"/>
+            <a:ext cx="585216" cy="585216"/>
+          </a:xfrm>
+          <a:prstGeom prst="ellipse">
+            <a:avLst/>
+          </a:prstGeom>
+          <a:solidFill>
+            <a:srgbClr val="F0A202"/>
+          </a:solidFill>
+          <a:ln/>
+        </p:spPr>
+      </p:sp>
+      <p:pic>
+        <p:nvPicPr>
+          <p:cNvPr id="20" name="Image 2" descr="preencoded.png">    </p:cNvPr>
+          <p:cNvPicPr>
+            <a:picLocks noChangeAspect="1"/>
+          </p:cNvPicPr>
+          <p:nvPr/>
+        </p:nvPicPr>
+        <p:blipFill>
+          <a:blip r:embed="rId3"/>
+          <a:stretch>
+            <a:fillRect/>
+          </a:stretch>
+        </p:blipFill>
+        <p:spPr>
+          <a:xfrm>
+            <a:off x="1048268" y="4367540"/>
+            <a:ext cx="280904" cy="280904"/>
+          </a:xfrm>
+          <a:prstGeom prst="rect">
+            <a:avLst/>
+          </a:prstGeom>
+        </p:spPr>
+      </p:pic>
+      <p:sp>
+        <p:nvSpPr>
+          <p:cNvPr id="21" name="Text 16"/>
+          <p:cNvSpPr/>
+          <p:nvPr/>
+        </p:nvSpPr>
+        <p:spPr>
+          <a:xfrm>
+            <a:off x="1737360" y="4087368"/>
+            <a:ext cx="7680960" cy="365760"/>
+          </a:xfrm>
+          <a:prstGeom prst="rect">
+            <a:avLst/>
+          </a:prstGeom>
+          <a:noFill/>
+          <a:ln/>
+        </p:spPr>
+        <p:txBody>
+          <a:bodyPr wrap="square" lIns="0" tIns="0" rIns="0" bIns="0" rtlCol="0" anchor="ctr"/>
+          <a:lstStyle/>
+          <a:p>
+            <a:pPr indent="0" marL="0">
+              <a:buNone/>
+            </a:pPr>
+            <a:r>
+              <a:rPr lang="en-US" sz="1650" b="1" dirty="0">
+                <a:solidFill>
+                  <a:srgbClr val="1A2238"/>
+                </a:solidFill>
+                <a:latin typeface="Calibri" pitchFamily="34" charset="0"/>
+                <a:ea typeface="Calibri" pitchFamily="34" charset="-122"/>
+                <a:cs typeface="Calibri" pitchFamily="34" charset="-120"/>
+              </a:rPr>
+              <a:t>Extrapolated &amp; derived quantities</a:t>
+            </a:r>
+            <a:endParaRPr lang="en-US" sz="1650" dirty="0"/>
+          </a:p>
+        </p:txBody>
+      </p:sp>
+      <p:sp>
+        <p:nvSpPr>
+          <p:cNvPr id="22" name="Text 17"/>
+          <p:cNvSpPr/>
+          <p:nvPr/>
+        </p:nvSpPr>
+        <p:spPr>
+          <a:xfrm>
+            <a:off x="1737360" y="4453128"/>
+            <a:ext cx="7772400" cy="548640"/>
+          </a:xfrm>
+          <a:prstGeom prst="rect">
+            <a:avLst/>
+          </a:prstGeom>
+          <a:noFill/>
+          <a:ln/>
+        </p:spPr>
+        <p:txBody>
+          <a:bodyPr wrap="square" lIns="0" tIns="0" rIns="0" bIns="0" rtlCol="0" anchor="ctr"/>
+          <a:lstStyle/>
+          <a:p>
+            <a:pPr indent="0" marL="0">
+              <a:lnSpc>
+                <a:spcPct val="108000"/>
+              </a:lnSpc>
+              <a:buNone/>
+            </a:pPr>
+            <a:r>
+              <a:rPr lang="en-US" sz="1150" dirty="0">
+                <a:solidFill>
+                  <a:srgbClr val="1A2238"/>
+                </a:solidFill>
+                <a:latin typeface="Calibri" pitchFamily="34" charset="0"/>
+                <a:ea typeface="Calibri" pitchFamily="34" charset="-122"/>
+                <a:cs typeface="Calibri" pitchFamily="34" charset="-120"/>
+              </a:rPr>
+              <a:t>The certificate’s extrapolation to the exact answer (demonstrated R² = 0.999) is a best estimate, not a bound. The evidence files carry that distinction explicitly — an estimate is never quoted as a guarantee.</a:t>
+            </a:r>
+            <a:endParaRPr lang="en-US" sz="1150" dirty="0"/>
+          </a:p>
+        </p:txBody>
+      </p:sp>
+      <p:sp>
+        <p:nvSpPr>
+          <p:cNvPr id="23" name="Shape 18"/>
+          <p:cNvSpPr/>
+          <p:nvPr/>
+        </p:nvSpPr>
+        <p:spPr>
+          <a:xfrm>
+            <a:off x="9738360" y="4352544"/>
+            <a:ext cx="1645920" cy="310896"/>
           </a:xfrm>
           <a:prstGeom prst="roundRect">
             <a:avLst>
@@ -3827,21 +4168,21 @@
             </a:avLst>
           </a:prstGeom>
           <a:solidFill>
-            <a:srgbClr val="C13438"/>
-          </a:solidFill>
-          <a:ln/>
-        </p:spPr>
-      </p:sp>
-      <p:sp>
-        <p:nvSpPr>
-          <p:cNvPr id="15" name="Text 13"/>
-          <p:cNvSpPr/>
-          <p:nvPr/>
-        </p:nvSpPr>
-        <p:spPr>
-          <a:xfrm>
-            <a:off x="896112" y="3854196"/>
-            <a:ext cx="1600200" cy="338328"/>
+            <a:srgbClr val="9C6A00"/>
+          </a:solidFill>
+          <a:ln/>
+        </p:spPr>
+      </p:sp>
+      <p:sp>
+        <p:nvSpPr>
+          <p:cNvPr id="24" name="Text 19"/>
+          <p:cNvSpPr/>
+          <p:nvPr/>
+        </p:nvSpPr>
+        <p:spPr>
+          <a:xfrm>
+            <a:off x="9738360" y="4338828"/>
+            <a:ext cx="1645920" cy="338328"/>
           </a:xfrm>
           <a:prstGeom prst="rect">
             <a:avLst/>
@@ -3865,7 +4206,7 @@
                 <a:ea typeface="Calibri" pitchFamily="34" charset="-122"/>
                 <a:cs typeface="Calibri" pitchFamily="34" charset="-120"/>
               </a:rPr>
-              <a:t>CONVICTION</a:t>
+              <a:t>ESTIMATE</a:t>
             </a:r>
             <a:endParaRPr lang="en-US" sz="1100" dirty="0"/>
           </a:p>
@@ -3873,99 +4214,18 @@
       </p:sp>
       <p:sp>
         <p:nvSpPr>
-          <p:cNvPr id="16" name="Text 14"/>
-          <p:cNvSpPr/>
-          <p:nvPr/>
-        </p:nvSpPr>
-        <p:spPr>
-          <a:xfrm>
-            <a:off x="896112" y="4251960"/>
-            <a:ext cx="4837176" cy="411480"/>
-          </a:xfrm>
-          <a:prstGeom prst="rect">
-            <a:avLst/>
-          </a:prstGeom>
-          <a:noFill/>
-          <a:ln/>
-        </p:spPr>
-        <p:txBody>
-          <a:bodyPr wrap="square" lIns="0" tIns="0" rIns="0" bIns="0" rtlCol="0" anchor="ctr"/>
-          <a:lstStyle/>
-          <a:p>
-            <a:pPr indent="0" marL="0">
-              <a:buNone/>
-            </a:pPr>
-            <a:r>
-              <a:rPr lang="en-US" sz="1800" b="1" dirty="0">
-                <a:solidFill>
-                  <a:srgbClr val="1A2238"/>
-                </a:solidFill>
-                <a:latin typeface="Calibri" pitchFamily="34" charset="0"/>
-                <a:ea typeface="Calibri" pitchFamily="34" charset="-122"/>
-                <a:cs typeface="Calibri" pitchFamily="34" charset="-120"/>
-              </a:rPr>
-              <a:t>CCSD(T) caught red-handed</a:t>
-            </a:r>
-            <a:endParaRPr lang="en-US" sz="1800" dirty="0"/>
-          </a:p>
-        </p:txBody>
-      </p:sp>
-      <p:sp>
-        <p:nvSpPr>
-          <p:cNvPr id="17" name="Text 15"/>
-          <p:cNvSpPr/>
-          <p:nvPr/>
-        </p:nvSpPr>
-        <p:spPr>
-          <a:xfrm>
-            <a:off x="896112" y="4672584"/>
-            <a:ext cx="4837176" cy="1051560"/>
-          </a:xfrm>
-          <a:prstGeom prst="rect">
-            <a:avLst/>
-          </a:prstGeom>
-          <a:noFill/>
-          <a:ln/>
-        </p:spPr>
-        <p:txBody>
-          <a:bodyPr wrap="square" lIns="0" tIns="0" rIns="0" bIns="0" rtlCol="0" anchor="ctr"/>
-          <a:lstStyle/>
-          <a:p>
-            <a:pPr indent="0" marL="0">
-              <a:lnSpc>
-                <a:spcPct val="112000"/>
-              </a:lnSpc>
-              <a:buNone/>
-            </a:pPr>
-            <a:r>
-              <a:rPr lang="en-US" sz="1280" dirty="0">
-                <a:solidFill>
-                  <a:srgbClr val="1A2238"/>
-                </a:solidFill>
-                <a:latin typeface="Calibri" pitchFamily="34" charset="0"/>
-                <a:ea typeface="Calibri" pitchFamily="34" charset="-122"/>
-                <a:cs typeface="Calibri" pitchFamily="34" charset="-120"/>
-              </a:rPr>
-              <a:t>Its answer sat 217 mHa below the exact energy — inside the region our bound proves impossible. The “accuracy gold standard,” convicted by mathematics.</a:t>
-            </a:r>
-            <a:endParaRPr lang="en-US" sz="1280" dirty="0"/>
-          </a:p>
-        </p:txBody>
-      </p:sp>
-      <p:sp>
-        <p:nvSpPr>
-          <p:cNvPr id="18" name="Shape 16"/>
-          <p:cNvSpPr/>
-          <p:nvPr/>
-        </p:nvSpPr>
-        <p:spPr>
-          <a:xfrm>
-            <a:off x="6245352" y="3630168"/>
-            <a:ext cx="5349240" cy="2194560"/>
+          <p:cNvPr id="25" name="Shape 20"/>
+          <p:cNvSpPr/>
+          <p:nvPr/>
+        </p:nvSpPr>
+        <p:spPr>
+          <a:xfrm>
+            <a:off x="640080" y="5166360"/>
+            <a:ext cx="10927080" cy="1060704"/>
           </a:xfrm>
           <a:prstGeom prst="roundRect">
             <a:avLst>
-              <a:gd name="adj" fmla="val 3750"/>
+              <a:gd name="adj" fmla="val 7759"/>
             </a:avLst>
           </a:prstGeom>
           <a:solidFill>
@@ -3973,9 +4233,9 @@
           </a:solidFill>
           <a:ln/>
           <a:effectLst>
-            <a:outerShdw sx="100000" sy="100000" kx="0" ky="0" algn="bl" rotWithShape="0" blurRad="88900" dist="25400" dir="5400000">
+            <a:outerShdw sx="100000" sy="100000" kx="0" ky="0" algn="bl" rotWithShape="0" blurRad="76200" dist="25400" dir="5400000">
               <a:srgbClr val="9AA3B2">
-                <a:alpha val="32000"/>
+                <a:alpha val="30000"/>
               </a:srgbClr>
             </a:outerShdw>
           </a:effectLst>
@@ -3983,14 +4243,139 @@
       </p:sp>
       <p:sp>
         <p:nvSpPr>
-          <p:cNvPr id="19" name="Shape 17"/>
-          <p:cNvSpPr/>
-          <p:nvPr/>
-        </p:nvSpPr>
-        <p:spPr>
-          <a:xfrm>
-            <a:off x="6501384" y="3867912"/>
-            <a:ext cx="1600200" cy="310896"/>
+          <p:cNvPr id="26" name="Shape 21"/>
+          <p:cNvSpPr/>
+          <p:nvPr/>
+        </p:nvSpPr>
+        <p:spPr>
+          <a:xfrm>
+            <a:off x="896112" y="5404104"/>
+            <a:ext cx="585216" cy="585216"/>
+          </a:xfrm>
+          <a:prstGeom prst="ellipse">
+            <a:avLst/>
+          </a:prstGeom>
+          <a:solidFill>
+            <a:srgbClr val="6B7280"/>
+          </a:solidFill>
+          <a:ln/>
+        </p:spPr>
+      </p:sp>
+      <p:pic>
+        <p:nvPicPr>
+          <p:cNvPr id="27" name="Image 3" descr="preencoded.png">    </p:cNvPr>
+          <p:cNvPicPr>
+            <a:picLocks noChangeAspect="1"/>
+          </p:cNvPicPr>
+          <p:nvPr/>
+        </p:nvPicPr>
+        <p:blipFill>
+          <a:blip r:embed="rId4"/>
+          <a:stretch>
+            <a:fillRect/>
+          </a:stretch>
+        </p:blipFill>
+        <p:spPr>
+          <a:xfrm>
+            <a:off x="1048268" y="5556260"/>
+            <a:ext cx="280904" cy="280904"/>
+          </a:xfrm>
+          <a:prstGeom prst="rect">
+            <a:avLst/>
+          </a:prstGeom>
+        </p:spPr>
+      </p:pic>
+      <p:sp>
+        <p:nvSpPr>
+          <p:cNvPr id="28" name="Text 22"/>
+          <p:cNvSpPr/>
+          <p:nvPr/>
+        </p:nvSpPr>
+        <p:spPr>
+          <a:xfrm>
+            <a:off x="1737360" y="5276088"/>
+            <a:ext cx="7680960" cy="365760"/>
+          </a:xfrm>
+          <a:prstGeom prst="rect">
+            <a:avLst/>
+          </a:prstGeom>
+          <a:noFill/>
+          <a:ln/>
+        </p:spPr>
+        <p:txBody>
+          <a:bodyPr wrap="square" lIns="0" tIns="0" rIns="0" bIns="0" rtlCol="0" anchor="ctr"/>
+          <a:lstStyle/>
+          <a:p>
+            <a:pPr indent="0" marL="0">
+              <a:buNone/>
+            </a:pPr>
+            <a:r>
+              <a:rPr lang="en-US" sz="1650" b="1" dirty="0">
+                <a:solidFill>
+                  <a:srgbClr val="1A2238"/>
+                </a:solidFill>
+                <a:latin typeface="Calibri" pitchFamily="34" charset="0"/>
+                <a:ea typeface="Calibri" pitchFamily="34" charset="-122"/>
+                <a:cs typeface="Calibri" pitchFamily="34" charset="-120"/>
+              </a:rPr>
+              <a:t>Everything upstream of the correlated solve</a:t>
+            </a:r>
+            <a:endParaRPr lang="en-US" sz="1650" dirty="0"/>
+          </a:p>
+        </p:txBody>
+      </p:sp>
+      <p:sp>
+        <p:nvSpPr>
+          <p:cNvPr id="29" name="Text 23"/>
+          <p:cNvSpPr/>
+          <p:nvPr/>
+        </p:nvSpPr>
+        <p:spPr>
+          <a:xfrm>
+            <a:off x="1737360" y="5641848"/>
+            <a:ext cx="7772400" cy="548640"/>
+          </a:xfrm>
+          <a:prstGeom prst="rect">
+            <a:avLst/>
+          </a:prstGeom>
+          <a:noFill/>
+          <a:ln/>
+        </p:spPr>
+        <p:txBody>
+          <a:bodyPr wrap="square" lIns="0" tIns="0" rIns="0" bIns="0" rtlCol="0" anchor="ctr"/>
+          <a:lstStyle/>
+          <a:p>
+            <a:pPr indent="0" marL="0">
+              <a:lnSpc>
+                <a:spcPct val="108000"/>
+              </a:lnSpc>
+              <a:buNone/>
+            </a:pPr>
+            <a:r>
+              <a:rPr lang="en-US" sz="1150" dirty="0">
+                <a:solidFill>
+                  <a:srgbClr val="1A2238"/>
+                </a:solidFill>
+                <a:latin typeface="Calibri" pitchFamily="34" charset="0"/>
+                <a:ea typeface="Calibri" pitchFamily="34" charset="-122"/>
+                <a:cs typeface="Calibri" pitchFamily="34" charset="-120"/>
+              </a:rPr>
+              <a:t>Basis set, active-space choice, environment effects: shared assumptions across every method compared. The audit certifies the step where silent failures live — it does not pretend to certify the whole modeling stack.</a:t>
+            </a:r>
+            <a:endParaRPr lang="en-US" sz="1150" dirty="0"/>
+          </a:p>
+        </p:txBody>
+      </p:sp>
+      <p:sp>
+        <p:nvSpPr>
+          <p:cNvPr id="30" name="Shape 24"/>
+          <p:cNvSpPr/>
+          <p:nvPr/>
+        </p:nvSpPr>
+        <p:spPr>
+          <a:xfrm>
+            <a:off x="9738360" y="5541264"/>
+            <a:ext cx="1645920" cy="310896"/>
           </a:xfrm>
           <a:prstGeom prst="roundRect">
             <a:avLst>
@@ -4005,14 +4390,14 @@
       </p:sp>
       <p:sp>
         <p:nvSpPr>
-          <p:cNvPr id="20" name="Text 18"/>
-          <p:cNvSpPr/>
-          <p:nvPr/>
-        </p:nvSpPr>
-        <p:spPr>
-          <a:xfrm>
-            <a:off x="6501384" y="3854196"/>
-            <a:ext cx="1600200" cy="338328"/>
+          <p:cNvPr id="31" name="Text 25"/>
+          <p:cNvSpPr/>
+          <p:nvPr/>
+        </p:nvSpPr>
+        <p:spPr>
+          <a:xfrm>
+            <a:off x="9738360" y="5527548"/>
+            <a:ext cx="1645920" cy="338328"/>
           </a:xfrm>
           <a:prstGeom prst="rect">
             <a:avLst/>
@@ -4036,7 +4421,7 @@
                 <a:ea typeface="Calibri" pitchFamily="34" charset="-122"/>
                 <a:cs typeface="Calibri" pitchFamily="34" charset="-120"/>
               </a:rPr>
-              <a:t>AT SCALE</a:t>
+              <a:t>NOT CLAIMED</a:t>
             </a:r>
             <a:endParaRPr lang="en-US" sz="1100" dirty="0"/>
           </a:p>
@@ -4044,30 +4429,30 @@
       </p:sp>
       <p:sp>
         <p:nvSpPr>
-          <p:cNvPr id="21" name="Text 19"/>
-          <p:cNvSpPr/>
-          <p:nvPr/>
-        </p:nvSpPr>
-        <p:spPr>
-          <a:xfrm>
-            <a:off x="6501384" y="4251960"/>
-            <a:ext cx="4837176" cy="411480"/>
-          </a:xfrm>
-          <a:prstGeom prst="rect">
-            <a:avLst/>
-          </a:prstGeom>
-          <a:noFill/>
-          <a:ln/>
-        </p:spPr>
-        <p:txBody>
-          <a:bodyPr wrap="square" lIns="0" tIns="0" rIns="0" bIns="0" rtlCol="0" anchor="ctr"/>
-          <a:lstStyle/>
-          <a:p>
-            <a:pPr indent="0" marL="0">
-              <a:buNone/>
-            </a:pPr>
-            <a:r>
-              <a:rPr lang="en-US" sz="1800" b="1" dirty="0">
+          <p:cNvPr id="32" name="Text 26"/>
+          <p:cNvSpPr/>
+          <p:nvPr/>
+        </p:nvSpPr>
+        <p:spPr>
+          <a:xfrm>
+            <a:off x="640080" y="6400800"/>
+            <a:ext cx="10927080" cy="384048"/>
+          </a:xfrm>
+          <a:prstGeom prst="rect">
+            <a:avLst/>
+          </a:prstGeom>
+          <a:noFill/>
+          <a:ln/>
+        </p:spPr>
+        <p:txBody>
+          <a:bodyPr wrap="square" lIns="0" tIns="0" rIns="0" bIns="0" rtlCol="0" anchor="ctr"/>
+          <a:lstStyle/>
+          <a:p>
+            <a:pPr indent="0" marL="0">
+              <a:buNone/>
+            </a:pPr>
+            <a:r>
+              <a:rPr lang="en-US" sz="1150" b="1" i="1" dirty="0">
                 <a:solidFill>
                   <a:srgbClr val="1A2238"/>
                 </a:solidFill>
@@ -4075,100 +4460,13 @@
                 <a:ea typeface="Calibri" pitchFamily="34" charset="-122"/>
                 <a:cs typeface="Calibri" pitchFamily="34" charset="-120"/>
               </a:rPr>
-              <a:t>DMRG reference corrected — for $12</a:t>
-            </a:r>
-            <a:endParaRPr lang="en-US" sz="1800" dirty="0"/>
-          </a:p>
-        </p:txBody>
-      </p:sp>
-      <p:sp>
-        <p:nvSpPr>
-          <p:cNvPr id="22" name="Text 20"/>
-          <p:cNvSpPr/>
-          <p:nvPr/>
-        </p:nvSpPr>
-        <p:spPr>
-          <a:xfrm>
-            <a:off x="6501384" y="4672584"/>
-            <a:ext cx="4837176" cy="1051560"/>
-          </a:xfrm>
-          <a:prstGeom prst="rect">
-            <a:avLst/>
-          </a:prstGeom>
-          <a:noFill/>
-          <a:ln/>
-        </p:spPr>
-        <p:txBody>
-          <a:bodyPr wrap="square" lIns="0" tIns="0" rIns="0" bIns="0" rtlCol="0" anchor="ctr"/>
-          <a:lstStyle/>
-          <a:p>
-            <a:pPr indent="0" marL="0">
-              <a:lnSpc>
-                <a:spcPct val="112000"/>
-              </a:lnSpc>
-              <a:buNone/>
-            </a:pPr>
-            <a:r>
-              <a:rPr lang="en-US" sz="1280" dirty="0">
-                <a:solidFill>
-                  <a:srgbClr val="1A2238"/>
-                </a:solidFill>
-                <a:latin typeface="Calibri" pitchFamily="34" charset="0"/>
-                <a:ea typeface="Calibri" pitchFamily="34" charset="-122"/>
-                <a:cs typeface="Calibri" pitchFamily="34" charset="-120"/>
-              </a:rPr>
-              <a:t>At 38 qubits on CrO, the audit landed below the trusted reference: provably closer to the truth. Compute cost of the audit: ~$12 and under 3 hours on a rented cloud GPU.</a:t>
-            </a:r>
-            <a:endParaRPr lang="en-US" sz="1280" dirty="0"/>
-          </a:p>
-        </p:txBody>
-      </p:sp>
-      <p:sp>
-        <p:nvSpPr>
-          <p:cNvPr id="23" name="Text 21"/>
-          <p:cNvSpPr/>
-          <p:nvPr/>
-        </p:nvSpPr>
-        <p:spPr>
-          <a:xfrm>
-            <a:off x="640080" y="6053328"/>
-            <a:ext cx="10927080" cy="731520"/>
-          </a:xfrm>
-          <a:prstGeom prst="rect">
-            <a:avLst/>
-          </a:prstGeom>
-          <a:noFill/>
-          <a:ln/>
-        </p:spPr>
-        <p:txBody>
-          <a:bodyPr wrap="square" lIns="0" tIns="0" rIns="0" bIns="0" rtlCol="0" anchor="ctr"/>
-          <a:lstStyle/>
-          <a:p>
-            <a:pPr indent="0" marL="0">
-              <a:lnSpc>
-                <a:spcPct val="112000"/>
-              </a:lnSpc>
-              <a:buNone/>
-            </a:pPr>
-            <a:r>
-              <a:rPr lang="en-US" sz="1050" b="1" dirty="0">
-                <a:solidFill>
-                  <a:srgbClr val="1A2238"/>
-                </a:solidFill>
-                <a:latin typeface="Calibri" pitchFamily="34" charset="0"/>
-                <a:ea typeface="Calibri" pitchFamily="34" charset="-122"/>
-                <a:cs typeface="Calibri" pitchFamily="34" charset="-120"/>
-              </a:rPr>
-              <a:t>Fine print, stated openly: </a:t>
-            </a:r>
-            <a:pPr indent="0" marL="0">
-              <a:lnSpc>
-                <a:spcPct val="112000"/>
-              </a:lnSpc>
-              <a:buNone/>
-            </a:pPr>
-            <a:r>
-              <a:rPr lang="en-US" sz="1050" dirty="0">
+              <a:t>A stamp that states exactly what it covers is worth more than one that claims everything. </a:t>
+            </a:r>
+            <a:pPr indent="0" marL="0">
+              <a:buNone/>
+            </a:pPr>
+            <a:r>
+              <a:rPr lang="en-US" sz="1150" dirty="0">
                 <a:solidFill>
                   <a:srgbClr val="6B7280"/>
                 </a:solidFill>
@@ -4176,35 +4474,9 @@
                 <a:ea typeface="Calibri" pitchFamily="34" charset="-122"/>
                 <a:cs typeface="Calibri" pitchFamily="34" charset="-120"/>
               </a:rPr>
-              <a:t>the mathematical guarantee applies to energies; verdicts comparing two states (spin gaps) are trusted only after each state is individually converged to certified accuracy — as the CrO and VO calls above were.</a:t>
-            </a:r>
-            <a:pPr indent="0" marL="0">
-              <a:lnSpc>
-                <a:spcPct val="112000"/>
-              </a:lnSpc>
-              <a:buNone/>
-            </a:pPr>
-            <a:endParaRPr lang="en-US" sz="1050" dirty="0"/>
-          </a:p>
-          <a:p>
-            <a:pPr indent="0" marL="0">
-              <a:lnSpc>
-                <a:spcPct val="112000"/>
-              </a:lnSpc>
-              <a:buNone/>
-            </a:pPr>
-            <a:r>
-              <a:rPr lang="en-US" sz="1050" i="1" dirty="0">
-                <a:solidFill>
-                  <a:srgbClr val="6B7280"/>
-                </a:solidFill>
-                <a:latin typeface="Calibri" pitchFamily="34" charset="0"/>
-                <a:ea typeface="Calibri" pitchFamily="34" charset="-122"/>
-                <a:cs typeface="Calibri" pitchFamily="34" charset="-120"/>
-              </a:rPr>
-              <a:t>Also in the evidence base: NiO (second oxide class), Sn-oxide EUV photoresist chemistry, exact-to-the-digit GPU execution.</a:t>
-            </a:r>
-            <a:endParaRPr lang="en-US" sz="1050" dirty="0"/>
+              <a:t>This taxonomy is printed on the product — every evidence file names its tier — not buried in a footnote.</a:t>
+            </a:r>
+            <a:endParaRPr lang="en-US" sz="1150" dirty="0"/>
           </a:p>
         </p:txBody>
       </p:sp>
@@ -4273,7 +4545,7 @@
                 <a:ea typeface="Calibri" pitchFamily="34" charset="-122"/>
                 <a:cs typeface="Calibri" pitchFamily="34" charset="-120"/>
               </a:rPr>
-              <a:t>Triage, not replacement — audit the load-bearing welds</a:t>
+              <a:t>Proof, not promises — audited against nature and at scale</a:t>
             </a:r>
             <a:endParaRPr lang="en-US" sz="3200" dirty="0"/>
           </a:p>
@@ -4281,125 +4553,132 @@
       </p:sp>
       <p:sp>
         <p:nvSpPr>
-          <p:cNvPr id="3" name="Text 1"/>
-          <p:cNvSpPr/>
-          <p:nvPr/>
-        </p:nvSpPr>
-        <p:spPr>
-          <a:xfrm>
-            <a:off x="640080" y="1051560"/>
-            <a:ext cx="10881360" cy="457200"/>
-          </a:xfrm>
-          <a:prstGeom prst="rect">
-            <a:avLst/>
-          </a:prstGeom>
-          <a:noFill/>
-          <a:ln/>
-        </p:spPr>
-        <p:txBody>
-          <a:bodyPr wrap="square" lIns="0" tIns="0" rIns="0" bIns="0" rtlCol="0" anchor="ctr"/>
-          <a:lstStyle/>
-          <a:p>
-            <a:pPr indent="0" marL="0">
-              <a:buNone/>
-            </a:pPr>
-            <a:r>
-              <a:rPr lang="en-US" sz="1500" dirty="0">
-                <a:solidFill>
-                  <a:srgbClr val="6B7280"/>
-                </a:solidFill>
-                <a:latin typeface="Calibri" pitchFamily="34" charset="0"/>
-                <a:ea typeface="Calibri" pitchFamily="34" charset="-122"/>
-                <a:cs typeface="Calibri" pitchFamily="34" charset="-120"/>
-              </a:rPr>
-              <a:t>DFT keeps the screening job it is priced for. The audit sits at the one place errors become expensive: the go / no-go gate before synthesis.</a:t>
-            </a:r>
-            <a:endParaRPr lang="en-US" sz="1500" dirty="0"/>
-          </a:p>
-        </p:txBody>
-      </p:sp>
-      <p:sp>
-        <p:nvSpPr>
-          <p:cNvPr id="4" name="Shape 2"/>
-          <p:cNvSpPr/>
-          <p:nvPr/>
-        </p:nvSpPr>
-        <p:spPr>
-          <a:xfrm>
-            <a:off x="731520" y="1828800"/>
-            <a:ext cx="5120640" cy="731520"/>
+          <p:cNvPr id="3" name="Shape 1"/>
+          <p:cNvSpPr/>
+          <p:nvPr/>
+        </p:nvSpPr>
+        <p:spPr>
+          <a:xfrm>
+            <a:off x="640080" y="1234440"/>
+            <a:ext cx="5349240" cy="2194560"/>
           </a:xfrm>
           <a:prstGeom prst="roundRect">
             <a:avLst>
-              <a:gd name="adj" fmla="val 10000"/>
+              <a:gd name="adj" fmla="val 3750"/>
             </a:avLst>
           </a:prstGeom>
           <a:solidFill>
-            <a:srgbClr val="CADCFC"/>
-          </a:solidFill>
-          <a:ln/>
-        </p:spPr>
-      </p:sp>
-      <p:sp>
-        <p:nvSpPr>
-          <p:cNvPr id="5" name="Text 3"/>
-          <p:cNvSpPr/>
-          <p:nvPr/>
-        </p:nvSpPr>
-        <p:spPr>
-          <a:xfrm>
-            <a:off x="822960" y="1828800"/>
-            <a:ext cx="4937760" cy="731520"/>
-          </a:xfrm>
-          <a:prstGeom prst="rect">
-            <a:avLst/>
-          </a:prstGeom>
-          <a:noFill/>
-          <a:ln/>
-        </p:spPr>
-        <p:txBody>
-          <a:bodyPr wrap="square" lIns="0" tIns="0" rIns="0" bIns="0" rtlCol="0" anchor="ctr"/>
-          <a:lstStyle/>
-          <a:p>
-            <a:pPr algn="ctr" indent="0" marL="0">
-              <a:buNone/>
-            </a:pPr>
-            <a:r>
-              <a:rPr lang="en-US" sz="1250" dirty="0">
-                <a:solidFill>
-                  <a:srgbClr val="1A2238"/>
-                </a:solidFill>
-                <a:latin typeface="Calibri" pitchFamily="34" charset="0"/>
-                <a:ea typeface="Calibri" pitchFamily="34" charset="-122"/>
-                <a:cs typeface="Calibri" pitchFamily="34" charset="-120"/>
-              </a:rPr>
-              <a:t>~10⁶ candidates — DFT screen (pennies each)</a:t>
-            </a:r>
-            <a:endParaRPr lang="en-US" sz="1250" dirty="0"/>
-          </a:p>
-        </p:txBody>
-      </p:sp>
-      <p:sp>
-        <p:nvSpPr>
-          <p:cNvPr id="6" name="Shape 4"/>
-          <p:cNvSpPr/>
-          <p:nvPr/>
-        </p:nvSpPr>
-        <p:spPr>
-          <a:xfrm>
-            <a:off x="1550822" y="2788920"/>
-            <a:ext cx="3482035" cy="731520"/>
+            <a:srgbClr val="F3F6FC"/>
+          </a:solidFill>
+          <a:ln/>
+          <a:effectLst>
+            <a:outerShdw sx="100000" sy="100000" kx="0" ky="0" algn="bl" rotWithShape="0" blurRad="88900" dist="25400" dir="5400000">
+              <a:srgbClr val="9AA3B2">
+                <a:alpha val="32000"/>
+              </a:srgbClr>
+            </a:outerShdw>
+          </a:effectLst>
+        </p:spPr>
+      </p:sp>
+      <p:sp>
+        <p:nvSpPr>
+          <p:cNvPr id="4" name="Shape 2"/>
+          <p:cNvSpPr/>
+          <p:nvPr/>
+        </p:nvSpPr>
+        <p:spPr>
+          <a:xfrm>
+            <a:off x="896112" y="1472184"/>
+            <a:ext cx="1600200" cy="310896"/>
           </a:xfrm>
           <a:prstGeom prst="roundRect">
             <a:avLst>
-              <a:gd name="adj" fmla="val 10000"/>
+              <a:gd name="adj" fmla="val 50000"/>
             </a:avLst>
           </a:prstGeom>
           <a:solidFill>
-            <a:srgbClr val="9DB8E8"/>
-          </a:solidFill>
-          <a:ln/>
-        </p:spPr>
+            <a:srgbClr val="018A6D"/>
+          </a:solidFill>
+          <a:ln/>
+        </p:spPr>
+      </p:sp>
+      <p:sp>
+        <p:nvSpPr>
+          <p:cNvPr id="5" name="Text 3"/>
+          <p:cNvSpPr/>
+          <p:nvPr/>
+        </p:nvSpPr>
+        <p:spPr>
+          <a:xfrm>
+            <a:off x="896112" y="1458468"/>
+            <a:ext cx="1600200" cy="338328"/>
+          </a:xfrm>
+          <a:prstGeom prst="rect">
+            <a:avLst/>
+          </a:prstGeom>
+          <a:noFill/>
+          <a:ln/>
+        </p:spPr>
+        <p:txBody>
+          <a:bodyPr wrap="square" lIns="0" tIns="0" rIns="0" bIns="0" rtlCol="0" anchor="ctr"/>
+          <a:lstStyle/>
+          <a:p>
+            <a:pPr algn="ctr" indent="0" marL="0">
+              <a:buNone/>
+            </a:pPr>
+            <a:r>
+              <a:rPr lang="en-US" sz="1100" b="1" spc="100" kern="0" dirty="0">
+                <a:solidFill>
+                  <a:srgbClr val="FFFFFF"/>
+                </a:solidFill>
+                <a:latin typeface="Calibri" pitchFamily="34" charset="0"/>
+                <a:ea typeface="Calibri" pitchFamily="34" charset="-122"/>
+                <a:cs typeface="Calibri" pitchFamily="34" charset="-120"/>
+              </a:rPr>
+              <a:t>LAB-VERIFIED</a:t>
+            </a:r>
+            <a:endParaRPr lang="en-US" sz="1100" dirty="0"/>
+          </a:p>
+        </p:txBody>
+      </p:sp>
+      <p:sp>
+        <p:nvSpPr>
+          <p:cNvPr id="6" name="Text 4"/>
+          <p:cNvSpPr/>
+          <p:nvPr/>
+        </p:nvSpPr>
+        <p:spPr>
+          <a:xfrm>
+            <a:off x="896112" y="1856232"/>
+            <a:ext cx="4837176" cy="411480"/>
+          </a:xfrm>
+          <a:prstGeom prst="rect">
+            <a:avLst/>
+          </a:prstGeom>
+          <a:noFill/>
+          <a:ln/>
+        </p:spPr>
+        <p:txBody>
+          <a:bodyPr wrap="square" lIns="0" tIns="0" rIns="0" bIns="0" rtlCol="0" anchor="ctr"/>
+          <a:lstStyle/>
+          <a:p>
+            <a:pPr indent="0" marL="0">
+              <a:buNone/>
+            </a:pPr>
+            <a:r>
+              <a:rPr lang="en-US" sz="1800" b="1" dirty="0">
+                <a:solidFill>
+                  <a:srgbClr val="1A2238"/>
+                </a:solidFill>
+                <a:latin typeface="Calibri" pitchFamily="34" charset="0"/>
+                <a:ea typeface="Calibri" pitchFamily="34" charset="-122"/>
+                <a:cs typeface="Calibri" pitchFamily="34" charset="-120"/>
+              </a:rPr>
+              <a:t>CrO ground state</a:t>
+            </a:r>
+            <a:endParaRPr lang="en-US" sz="1800" dirty="0"/>
+          </a:p>
+        </p:txBody>
       </p:sp>
       <p:sp>
         <p:nvSpPr>
@@ -4409,281 +4688,8 @@
         </p:nvSpPr>
         <p:spPr>
           <a:xfrm>
-            <a:off x="1642262" y="2788920"/>
-            <a:ext cx="3299155" cy="731520"/>
-          </a:xfrm>
-          <a:prstGeom prst="rect">
-            <a:avLst/>
-          </a:prstGeom>
-          <a:noFill/>
-          <a:ln/>
-        </p:spPr>
-        <p:txBody>
-          <a:bodyPr wrap="square" lIns="0" tIns="0" rIns="0" bIns="0" rtlCol="0" anchor="ctr"/>
-          <a:lstStyle/>
-          <a:p>
-            <a:pPr algn="ctr" indent="0" marL="0">
-              <a:buNone/>
-            </a:pPr>
-            <a:r>
-              <a:rPr lang="en-US" sz="1250" dirty="0">
-                <a:solidFill>
-                  <a:srgbClr val="1A2238"/>
-                </a:solidFill>
-                <a:latin typeface="Calibri" pitchFamily="34" charset="0"/>
-                <a:ea typeface="Calibri" pitchFamily="34" charset="-122"/>
-                <a:cs typeface="Calibri" pitchFamily="34" charset="-120"/>
-              </a:rPr>
-              <a:t>~10² survivors — refined models</a:t>
-            </a:r>
-            <a:endParaRPr lang="en-US" sz="1250" dirty="0"/>
-          </a:p>
-        </p:txBody>
-      </p:sp>
-      <p:sp>
-        <p:nvSpPr>
-          <p:cNvPr id="8" name="Shape 6"/>
-          <p:cNvSpPr/>
-          <p:nvPr/>
-        </p:nvSpPr>
-        <p:spPr>
-          <a:xfrm>
-            <a:off x="2216506" y="3749040"/>
-            <a:ext cx="2150669" cy="731520"/>
-          </a:xfrm>
-          <a:prstGeom prst="roundRect">
-            <a:avLst>
-              <a:gd name="adj" fmla="val 10000"/>
-            </a:avLst>
-          </a:prstGeom>
-          <a:solidFill>
-            <a:srgbClr val="16205B"/>
-          </a:solidFill>
-          <a:ln/>
-        </p:spPr>
-      </p:sp>
-      <p:sp>
-        <p:nvSpPr>
-          <p:cNvPr id="9" name="Text 7"/>
-          <p:cNvSpPr/>
-          <p:nvPr/>
-        </p:nvSpPr>
-        <p:spPr>
-          <a:xfrm>
-            <a:off x="2307946" y="3749040"/>
-            <a:ext cx="1967789" cy="731520"/>
-          </a:xfrm>
-          <a:prstGeom prst="rect">
-            <a:avLst/>
-          </a:prstGeom>
-          <a:noFill/>
-          <a:ln/>
-        </p:spPr>
-        <p:txBody>
-          <a:bodyPr wrap="square" lIns="0" tIns="0" rIns="0" bIns="0" rtlCol="0" anchor="ctr"/>
-          <a:lstStyle/>
-          <a:p>
-            <a:pPr algn="ctr" indent="0" marL="0">
-              <a:buNone/>
-            </a:pPr>
-            <a:r>
-              <a:rPr lang="en-US" sz="1250" b="1" dirty="0">
-                <a:solidFill>
-                  <a:srgbClr val="FFFFFF"/>
-                </a:solidFill>
-                <a:latin typeface="Calibri" pitchFamily="34" charset="0"/>
-                <a:ea typeface="Calibri" pitchFamily="34" charset="-122"/>
-                <a:cs typeface="Calibri" pitchFamily="34" charset="-120"/>
-              </a:rPr>
-              <a:t>Dozens: go / no-go synthesis decisions</a:t>
-            </a:r>
-            <a:endParaRPr lang="en-US" sz="1250" dirty="0"/>
-          </a:p>
-        </p:txBody>
-      </p:sp>
-      <p:sp>
-        <p:nvSpPr>
-          <p:cNvPr id="10" name="Shape 8"/>
-          <p:cNvSpPr/>
-          <p:nvPr/>
-        </p:nvSpPr>
-        <p:spPr>
-          <a:xfrm>
-            <a:off x="1051560" y="4892040"/>
-            <a:ext cx="4480560" cy="868680"/>
-          </a:xfrm>
-          <a:prstGeom prst="roundRect">
-            <a:avLst>
-              <a:gd name="adj" fmla="val 9474"/>
-            </a:avLst>
-          </a:prstGeom>
-          <a:solidFill>
-            <a:srgbClr val="02C39A"/>
-          </a:solidFill>
-          <a:ln/>
-        </p:spPr>
-      </p:sp>
-      <p:pic>
-        <p:nvPicPr>
-          <p:cNvPr id="11" name="Image 0" descr="preencoded.png">    </p:cNvPr>
-          <p:cNvPicPr>
-            <a:picLocks noChangeAspect="1"/>
-          </p:cNvPicPr>
-          <p:nvPr/>
-        </p:nvPicPr>
-        <p:blipFill>
-          <a:blip r:embed="rId1"/>
-          <a:stretch>
-            <a:fillRect/>
-          </a:stretch>
-        </p:blipFill>
-        <p:spPr>
-          <a:xfrm>
-            <a:off x="1298448" y="5120640"/>
-            <a:ext cx="411480" cy="411480"/>
-          </a:xfrm>
-          <a:prstGeom prst="rect">
-            <a:avLst/>
-          </a:prstGeom>
-        </p:spPr>
-      </p:pic>
-      <p:sp>
-        <p:nvSpPr>
-          <p:cNvPr id="12" name="Text 9"/>
-          <p:cNvSpPr/>
-          <p:nvPr/>
-        </p:nvSpPr>
-        <p:spPr>
-          <a:xfrm>
-            <a:off x="1828800" y="4892040"/>
-            <a:ext cx="3657600" cy="868680"/>
-          </a:xfrm>
-          <a:prstGeom prst="rect">
-            <a:avLst/>
-          </a:prstGeom>
-          <a:noFill/>
-          <a:ln/>
-        </p:spPr>
-        <p:txBody>
-          <a:bodyPr wrap="square" lIns="0" tIns="0" rIns="0" bIns="0" rtlCol="0" anchor="ctr"/>
-          <a:lstStyle/>
-          <a:p>
-            <a:pPr indent="0" marL="0">
-              <a:lnSpc>
-                <a:spcPct val="105000"/>
-              </a:lnSpc>
-              <a:buNone/>
-            </a:pPr>
-            <a:r>
-              <a:rPr lang="en-US" sz="1350" b="1" dirty="0">
-                <a:solidFill>
-                  <a:srgbClr val="16205B"/>
-                </a:solidFill>
-                <a:latin typeface="Calibri" pitchFamily="34" charset="0"/>
-                <a:ea typeface="Calibri" pitchFamily="34" charset="-122"/>
-                <a:cs typeface="Calibri" pitchFamily="34" charset="-120"/>
-              </a:rPr>
-              <a:t>MATGEN-Q AUDIT — $10–100 per decisive number</a:t>
-            </a:r>
-            <a:endParaRPr lang="en-US" sz="1350" dirty="0"/>
-          </a:p>
-        </p:txBody>
-      </p:sp>
-      <p:sp>
-        <p:nvSpPr>
-          <p:cNvPr id="13" name="Shape 10"/>
-          <p:cNvSpPr/>
-          <p:nvPr/>
-        </p:nvSpPr>
-        <p:spPr>
-          <a:xfrm>
-            <a:off x="3291840" y="4480560"/>
-            <a:ext cx="0" cy="411480"/>
-          </a:xfrm>
-          <a:prstGeom prst="line">
-            <a:avLst/>
-          </a:prstGeom>
-          <a:noFill/>
-          <a:ln w="31750">
-            <a:solidFill>
-              <a:srgbClr val="018A6D"/>
-            </a:solidFill>
-            <a:prstDash val="solid"/>
-            <a:tailEnd type="triangle"/>
-          </a:ln>
-        </p:spPr>
-      </p:sp>
-      <p:sp>
-        <p:nvSpPr>
-          <p:cNvPr id="14" name="Shape 11"/>
-          <p:cNvSpPr/>
-          <p:nvPr/>
-        </p:nvSpPr>
-        <p:spPr>
-          <a:xfrm>
-            <a:off x="6400800" y="1828800"/>
-            <a:ext cx="5120640" cy="1920240"/>
-          </a:xfrm>
-          <a:prstGeom prst="roundRect">
-            <a:avLst>
-              <a:gd name="adj" fmla="val 4286"/>
-            </a:avLst>
-          </a:prstGeom>
-          <a:solidFill>
-            <a:srgbClr val="F3F6FC"/>
-          </a:solidFill>
-          <a:ln/>
-        </p:spPr>
-      </p:sp>
-      <p:sp>
-        <p:nvSpPr>
-          <p:cNvPr id="15" name="Text 12"/>
-          <p:cNvSpPr/>
-          <p:nvPr/>
-        </p:nvSpPr>
-        <p:spPr>
-          <a:xfrm>
-            <a:off x="6675120" y="2011680"/>
-            <a:ext cx="4572000" cy="685800"/>
-          </a:xfrm>
-          <a:prstGeom prst="rect">
-            <a:avLst/>
-          </a:prstGeom>
-          <a:noFill/>
-          <a:ln/>
-        </p:spPr>
-        <p:txBody>
-          <a:bodyPr wrap="square" lIns="0" tIns="0" rIns="0" bIns="0" rtlCol="0" anchor="ctr"/>
-          <a:lstStyle/>
-          <a:p>
-            <a:pPr indent="0" marL="0">
-              <a:buNone/>
-            </a:pPr>
-            <a:r>
-              <a:rPr lang="en-US" sz="3400" b="1" dirty="0">
-                <a:solidFill>
-                  <a:srgbClr val="C13438"/>
-                </a:solidFill>
-                <a:latin typeface="Calibri" pitchFamily="34" charset="0"/>
-                <a:ea typeface="Calibri" pitchFamily="34" charset="-122"/>
-                <a:cs typeface="Calibri" pitchFamily="34" charset="-120"/>
-              </a:rPr>
-              <a:t>$100k – $1M+</a:t>
-            </a:r>
-            <a:endParaRPr lang="en-US" sz="3400" dirty="0"/>
-          </a:p>
-        </p:txBody>
-      </p:sp>
-      <p:sp>
-        <p:nvSpPr>
-          <p:cNvPr id="16" name="Text 13"/>
-          <p:cNvSpPr/>
-          <p:nvPr/>
-        </p:nvSpPr>
-        <p:spPr>
-          <a:xfrm>
-            <a:off x="6675120" y="2697480"/>
-            <a:ext cx="4572000" cy="914400"/>
+            <a:off x="896112" y="2276856"/>
+            <a:ext cx="4837176" cy="1051560"/>
           </a:xfrm>
           <a:prstGeom prst="rect">
             <a:avLst/>
@@ -4702,7 +4708,7 @@
               <a:buNone/>
             </a:pPr>
             <a:r>
-              <a:rPr lang="en-US" sz="1300" dirty="0">
+              <a:rPr lang="en-US" sz="1280" dirty="0">
                 <a:solidFill>
                   <a:srgbClr val="1A2238"/>
                 </a:solidFill>
@@ -4710,83 +4716,151 @@
                 <a:ea typeface="Calibri" pitchFamily="34" charset="-122"/>
                 <a:cs typeface="Calibri" pitchFamily="34" charset="-120"/>
               </a:rPr>
-              <a:t>cost of one synthesis campaign chasing a computationally mis-ranked candidate — the failure mode the audit exists to catch.</a:t>
-            </a:r>
-            <a:endParaRPr lang="en-US" sz="1300" dirty="0"/>
-          </a:p>
-        </p:txBody>
-      </p:sp>
-      <p:sp>
-        <p:nvSpPr>
-          <p:cNvPr id="17" name="Shape 14"/>
-          <p:cNvSpPr/>
-          <p:nvPr/>
-        </p:nvSpPr>
-        <p:spPr>
-          <a:xfrm>
-            <a:off x="6400800" y="3931920"/>
-            <a:ext cx="5120640" cy="1828800"/>
+              <a:t>DFT (B3LYP) predicts the wrong ground state. The audit predicts the one measured in the laboratory — decades of spectroscopy agree with us, not DFT.</a:t>
+            </a:r>
+            <a:endParaRPr lang="en-US" sz="1280" dirty="0"/>
+          </a:p>
+        </p:txBody>
+      </p:sp>
+      <p:sp>
+        <p:nvSpPr>
+          <p:cNvPr id="8" name="Shape 6"/>
+          <p:cNvSpPr/>
+          <p:nvPr/>
+        </p:nvSpPr>
+        <p:spPr>
+          <a:xfrm>
+            <a:off x="6245352" y="1234440"/>
+            <a:ext cx="5349240" cy="2194560"/>
           </a:xfrm>
           <a:prstGeom prst="roundRect">
             <a:avLst>
-              <a:gd name="adj" fmla="val 4500"/>
+              <a:gd name="adj" fmla="val 3750"/>
             </a:avLst>
           </a:prstGeom>
           <a:solidFill>
-            <a:srgbClr val="16205B"/>
-          </a:solidFill>
-          <a:ln/>
-        </p:spPr>
-      </p:sp>
-      <p:sp>
-        <p:nvSpPr>
-          <p:cNvPr id="18" name="Text 15"/>
-          <p:cNvSpPr/>
-          <p:nvPr/>
-        </p:nvSpPr>
-        <p:spPr>
-          <a:xfrm>
-            <a:off x="6675120" y="4114800"/>
-            <a:ext cx="4572000" cy="457200"/>
-          </a:xfrm>
-          <a:prstGeom prst="rect">
-            <a:avLst/>
-          </a:prstGeom>
-          <a:noFill/>
-          <a:ln/>
-        </p:spPr>
-        <p:txBody>
-          <a:bodyPr wrap="square" lIns="0" tIns="0" rIns="0" bIns="0" rtlCol="0" anchor="ctr"/>
-          <a:lstStyle/>
-          <a:p>
-            <a:pPr indent="0" marL="0">
-              <a:buNone/>
-            </a:pPr>
-            <a:r>
-              <a:rPr lang="en-US" sz="1900" b="1" dirty="0">
-                <a:solidFill>
-                  <a:srgbClr val="02C39A"/>
-                </a:solidFill>
-                <a:latin typeface="Calibri" pitchFamily="34" charset="0"/>
-                <a:ea typeface="Calibri" pitchFamily="34" charset="-122"/>
-                <a:cs typeface="Calibri" pitchFamily="34" charset="-120"/>
-              </a:rPr>
-              <a:t>One avoided dead-end per year</a:t>
-            </a:r>
-            <a:endParaRPr lang="en-US" sz="1900" dirty="0"/>
-          </a:p>
-        </p:txBody>
-      </p:sp>
-      <p:sp>
-        <p:nvSpPr>
-          <p:cNvPr id="19" name="Text 16"/>
-          <p:cNvSpPr/>
-          <p:nvPr/>
-        </p:nvSpPr>
-        <p:spPr>
-          <a:xfrm>
-            <a:off x="6675120" y="4572000"/>
-            <a:ext cx="4572000" cy="1051560"/>
+            <a:srgbClr val="F3F6FC"/>
+          </a:solidFill>
+          <a:ln/>
+          <a:effectLst>
+            <a:outerShdw sx="100000" sy="100000" kx="0" ky="0" algn="bl" rotWithShape="0" blurRad="88900" dist="25400" dir="5400000">
+              <a:srgbClr val="9AA3B2">
+                <a:alpha val="32000"/>
+              </a:srgbClr>
+            </a:outerShdw>
+          </a:effectLst>
+        </p:spPr>
+      </p:sp>
+      <p:sp>
+        <p:nvSpPr>
+          <p:cNvPr id="9" name="Shape 7"/>
+          <p:cNvSpPr/>
+          <p:nvPr/>
+        </p:nvSpPr>
+        <p:spPr>
+          <a:xfrm>
+            <a:off x="6501384" y="1472184"/>
+            <a:ext cx="1600200" cy="310896"/>
+          </a:xfrm>
+          <a:prstGeom prst="roundRect">
+            <a:avLst>
+              <a:gd name="adj" fmla="val 50000"/>
+            </a:avLst>
+          </a:prstGeom>
+          <a:solidFill>
+            <a:srgbClr val="018A6D"/>
+          </a:solidFill>
+          <a:ln/>
+        </p:spPr>
+      </p:sp>
+      <p:sp>
+        <p:nvSpPr>
+          <p:cNvPr id="10" name="Text 8"/>
+          <p:cNvSpPr/>
+          <p:nvPr/>
+        </p:nvSpPr>
+        <p:spPr>
+          <a:xfrm>
+            <a:off x="6501384" y="1458468"/>
+            <a:ext cx="1600200" cy="338328"/>
+          </a:xfrm>
+          <a:prstGeom prst="rect">
+            <a:avLst/>
+          </a:prstGeom>
+          <a:noFill/>
+          <a:ln/>
+        </p:spPr>
+        <p:txBody>
+          <a:bodyPr wrap="square" lIns="0" tIns="0" rIns="0" bIns="0" rtlCol="0" anchor="ctr"/>
+          <a:lstStyle/>
+          <a:p>
+            <a:pPr algn="ctr" indent="0" marL="0">
+              <a:buNone/>
+            </a:pPr>
+            <a:r>
+              <a:rPr lang="en-US" sz="1100" b="1" spc="100" kern="0" dirty="0">
+                <a:solidFill>
+                  <a:srgbClr val="FFFFFF"/>
+                </a:solidFill>
+                <a:latin typeface="Calibri" pitchFamily="34" charset="0"/>
+                <a:ea typeface="Calibri" pitchFamily="34" charset="-122"/>
+                <a:cs typeface="Calibri" pitchFamily="34" charset="-120"/>
+              </a:rPr>
+              <a:t>BLIND TEST</a:t>
+            </a:r>
+            <a:endParaRPr lang="en-US" sz="1100" dirty="0"/>
+          </a:p>
+        </p:txBody>
+      </p:sp>
+      <p:sp>
+        <p:nvSpPr>
+          <p:cNvPr id="11" name="Text 9"/>
+          <p:cNvSpPr/>
+          <p:nvPr/>
+        </p:nvSpPr>
+        <p:spPr>
+          <a:xfrm>
+            <a:off x="6501384" y="1856232"/>
+            <a:ext cx="4837176" cy="411480"/>
+          </a:xfrm>
+          <a:prstGeom prst="rect">
+            <a:avLst/>
+          </a:prstGeom>
+          <a:noFill/>
+          <a:ln/>
+        </p:spPr>
+        <p:txBody>
+          <a:bodyPr wrap="square" lIns="0" tIns="0" rIns="0" bIns="0" rtlCol="0" anchor="ctr"/>
+          <a:lstStyle/>
+          <a:p>
+            <a:pPr indent="0" marL="0">
+              <a:buNone/>
+            </a:pPr>
+            <a:r>
+              <a:rPr lang="en-US" sz="1800" b="1" dirty="0">
+                <a:solidFill>
+                  <a:srgbClr val="1A2238"/>
+                </a:solidFill>
+                <a:latin typeface="Calibri" pitchFamily="34" charset="0"/>
+                <a:ea typeface="Calibri" pitchFamily="34" charset="-122"/>
+                <a:cs typeface="Calibri" pitchFamily="34" charset="-120"/>
+              </a:rPr>
+              <a:t>VO ground state — predicted blind</a:t>
+            </a:r>
+            <a:endParaRPr lang="en-US" sz="1800" dirty="0"/>
+          </a:p>
+        </p:txBody>
+      </p:sp>
+      <p:sp>
+        <p:nvSpPr>
+          <p:cNvPr id="12" name="Text 10"/>
+          <p:cNvSpPr/>
+          <p:nvPr/>
+        </p:nvSpPr>
+        <p:spPr>
+          <a:xfrm>
+            <a:off x="6501384" y="2276856"/>
+            <a:ext cx="4837176" cy="1051560"/>
           </a:xfrm>
           <a:prstGeom prst="rect">
             <a:avLst/>
@@ -4805,7 +4879,97 @@
               <a:buNone/>
             </a:pPr>
             <a:r>
-              <a:rPr lang="en-US" sz="1300" dirty="0">
+              <a:rPr lang="en-US" sz="1280" dirty="0">
+                <a:solidFill>
+                  <a:srgbClr val="1A2238"/>
+                </a:solidFill>
+                <a:latin typeface="Calibri" pitchFamily="34" charset="0"/>
+                <a:ea typeface="Calibri" pitchFamily="34" charset="-122"/>
+                <a:cs typeface="Calibri" pitchFamily="34" charset="-120"/>
+              </a:rPr>
+              <a:t>Prediction locked by cryptographic hash before the single frozen run. Result: matches the laboratory ground state. The audit is right when it cannot possibly peek.</a:t>
+            </a:r>
+            <a:endParaRPr lang="en-US" sz="1280" dirty="0"/>
+          </a:p>
+        </p:txBody>
+      </p:sp>
+      <p:sp>
+        <p:nvSpPr>
+          <p:cNvPr id="13" name="Shape 11"/>
+          <p:cNvSpPr/>
+          <p:nvPr/>
+        </p:nvSpPr>
+        <p:spPr>
+          <a:xfrm>
+            <a:off x="640080" y="3630168"/>
+            <a:ext cx="5349240" cy="2194560"/>
+          </a:xfrm>
+          <a:prstGeom prst="roundRect">
+            <a:avLst>
+              <a:gd name="adj" fmla="val 3750"/>
+            </a:avLst>
+          </a:prstGeom>
+          <a:solidFill>
+            <a:srgbClr val="F3F6FC"/>
+          </a:solidFill>
+          <a:ln/>
+          <a:effectLst>
+            <a:outerShdw sx="100000" sy="100000" kx="0" ky="0" algn="bl" rotWithShape="0" blurRad="88900" dist="25400" dir="5400000">
+              <a:srgbClr val="9AA3B2">
+                <a:alpha val="32000"/>
+              </a:srgbClr>
+            </a:outerShdw>
+          </a:effectLst>
+        </p:spPr>
+      </p:sp>
+      <p:sp>
+        <p:nvSpPr>
+          <p:cNvPr id="14" name="Shape 12"/>
+          <p:cNvSpPr/>
+          <p:nvPr/>
+        </p:nvSpPr>
+        <p:spPr>
+          <a:xfrm>
+            <a:off x="896112" y="3867912"/>
+            <a:ext cx="1600200" cy="310896"/>
+          </a:xfrm>
+          <a:prstGeom prst="roundRect">
+            <a:avLst>
+              <a:gd name="adj" fmla="val 50000"/>
+            </a:avLst>
+          </a:prstGeom>
+          <a:solidFill>
+            <a:srgbClr val="C13438"/>
+          </a:solidFill>
+          <a:ln/>
+        </p:spPr>
+      </p:sp>
+      <p:sp>
+        <p:nvSpPr>
+          <p:cNvPr id="15" name="Text 13"/>
+          <p:cNvSpPr/>
+          <p:nvPr/>
+        </p:nvSpPr>
+        <p:spPr>
+          <a:xfrm>
+            <a:off x="896112" y="3854196"/>
+            <a:ext cx="1600200" cy="338328"/>
+          </a:xfrm>
+          <a:prstGeom prst="rect">
+            <a:avLst/>
+          </a:prstGeom>
+          <a:noFill/>
+          <a:ln/>
+        </p:spPr>
+        <p:txBody>
+          <a:bodyPr wrap="square" lIns="0" tIns="0" rIns="0" bIns="0" rtlCol="0" anchor="ctr"/>
+          <a:lstStyle/>
+          <a:p>
+            <a:pPr algn="ctr" indent="0" marL="0">
+              <a:buNone/>
+            </a:pPr>
+            <a:r>
+              <a:rPr lang="en-US" sz="1100" b="1" spc="100" kern="0" dirty="0">
                 <a:solidFill>
                   <a:srgbClr val="FFFFFF"/>
                 </a:solidFill>
@@ -4813,22 +4977,61 @@
                 <a:ea typeface="Calibri" pitchFamily="34" charset="-122"/>
                 <a:cs typeface="Calibri" pitchFamily="34" charset="-120"/>
               </a:rPr>
-              <a:t>pays for the audit layer across an entire screening portfolio. It doesn’t need “millions saved” to be worth deploying — though that is where the mechanism points.</a:t>
-            </a:r>
-            <a:endParaRPr lang="en-US" sz="1300" dirty="0"/>
-          </a:p>
-        </p:txBody>
-      </p:sp>
-      <p:sp>
-        <p:nvSpPr>
-          <p:cNvPr id="20" name="Text 17"/>
-          <p:cNvSpPr/>
-          <p:nvPr/>
-        </p:nvSpPr>
-        <p:spPr>
-          <a:xfrm>
-            <a:off x="640080" y="5989320"/>
-            <a:ext cx="10927080" cy="822960"/>
+              <a:t>CONVICTION</a:t>
+            </a:r>
+            <a:endParaRPr lang="en-US" sz="1100" dirty="0"/>
+          </a:p>
+        </p:txBody>
+      </p:sp>
+      <p:sp>
+        <p:nvSpPr>
+          <p:cNvPr id="16" name="Text 14"/>
+          <p:cNvSpPr/>
+          <p:nvPr/>
+        </p:nvSpPr>
+        <p:spPr>
+          <a:xfrm>
+            <a:off x="896112" y="4251960"/>
+            <a:ext cx="4837176" cy="411480"/>
+          </a:xfrm>
+          <a:prstGeom prst="rect">
+            <a:avLst/>
+          </a:prstGeom>
+          <a:noFill/>
+          <a:ln/>
+        </p:spPr>
+        <p:txBody>
+          <a:bodyPr wrap="square" lIns="0" tIns="0" rIns="0" bIns="0" rtlCol="0" anchor="ctr"/>
+          <a:lstStyle/>
+          <a:p>
+            <a:pPr indent="0" marL="0">
+              <a:buNone/>
+            </a:pPr>
+            <a:r>
+              <a:rPr lang="en-US" sz="1800" b="1" dirty="0">
+                <a:solidFill>
+                  <a:srgbClr val="1A2238"/>
+                </a:solidFill>
+                <a:latin typeface="Calibri" pitchFamily="34" charset="0"/>
+                <a:ea typeface="Calibri" pitchFamily="34" charset="-122"/>
+                <a:cs typeface="Calibri" pitchFamily="34" charset="-120"/>
+              </a:rPr>
+              <a:t>CCSD(T) caught red-handed</a:t>
+            </a:r>
+            <a:endParaRPr lang="en-US" sz="1800" dirty="0"/>
+          </a:p>
+        </p:txBody>
+      </p:sp>
+      <p:sp>
+        <p:nvSpPr>
+          <p:cNvPr id="17" name="Text 15"/>
+          <p:cNvSpPr/>
+          <p:nvPr/>
+        </p:nvSpPr>
+        <p:spPr>
+          <a:xfrm>
+            <a:off x="896112" y="4672584"/>
+            <a:ext cx="4837176" cy="1051560"/>
           </a:xfrm>
           <a:prstGeom prst="rect">
             <a:avLst/>
@@ -4847,7 +5050,7 @@
               <a:buNone/>
             </a:pPr>
             <a:r>
-              <a:rPr lang="en-US" sz="1250" i="1" dirty="0">
+              <a:rPr lang="en-US" sz="1280" dirty="0">
                 <a:solidFill>
                   <a:srgbClr val="1A2238"/>
                 </a:solidFill>
@@ -4855,8 +5058,162 @@
                 <a:ea typeface="Calibri" pitchFamily="34" charset="-122"/>
                 <a:cs typeface="Calibri" pitchFamily="34" charset="-120"/>
               </a:rPr>
-              <a:t>You don’t X-ray every weld in the shipyard — you X-ray the ones the hull depends on.</a:t>
-            </a:r>
+              <a:t>Its answer sat 217 mHa below the exact energy — inside the region our bound proves impossible. The “accuracy gold standard,” convicted by mathematics.</a:t>
+            </a:r>
+            <a:endParaRPr lang="en-US" sz="1280" dirty="0"/>
+          </a:p>
+        </p:txBody>
+      </p:sp>
+      <p:sp>
+        <p:nvSpPr>
+          <p:cNvPr id="18" name="Shape 16"/>
+          <p:cNvSpPr/>
+          <p:nvPr/>
+        </p:nvSpPr>
+        <p:spPr>
+          <a:xfrm>
+            <a:off x="6245352" y="3630168"/>
+            <a:ext cx="5349240" cy="2194560"/>
+          </a:xfrm>
+          <a:prstGeom prst="roundRect">
+            <a:avLst>
+              <a:gd name="adj" fmla="val 3750"/>
+            </a:avLst>
+          </a:prstGeom>
+          <a:solidFill>
+            <a:srgbClr val="F3F6FC"/>
+          </a:solidFill>
+          <a:ln/>
+          <a:effectLst>
+            <a:outerShdw sx="100000" sy="100000" kx="0" ky="0" algn="bl" rotWithShape="0" blurRad="88900" dist="25400" dir="5400000">
+              <a:srgbClr val="9AA3B2">
+                <a:alpha val="32000"/>
+              </a:srgbClr>
+            </a:outerShdw>
+          </a:effectLst>
+        </p:spPr>
+      </p:sp>
+      <p:sp>
+        <p:nvSpPr>
+          <p:cNvPr id="19" name="Shape 17"/>
+          <p:cNvSpPr/>
+          <p:nvPr/>
+        </p:nvSpPr>
+        <p:spPr>
+          <a:xfrm>
+            <a:off x="6501384" y="3867912"/>
+            <a:ext cx="1600200" cy="310896"/>
+          </a:xfrm>
+          <a:prstGeom prst="roundRect">
+            <a:avLst>
+              <a:gd name="adj" fmla="val 50000"/>
+            </a:avLst>
+          </a:prstGeom>
+          <a:solidFill>
+            <a:srgbClr val="C13438"/>
+          </a:solidFill>
+          <a:ln/>
+        </p:spPr>
+      </p:sp>
+      <p:sp>
+        <p:nvSpPr>
+          <p:cNvPr id="20" name="Text 18"/>
+          <p:cNvSpPr/>
+          <p:nvPr/>
+        </p:nvSpPr>
+        <p:spPr>
+          <a:xfrm>
+            <a:off x="6501384" y="3854196"/>
+            <a:ext cx="1600200" cy="338328"/>
+          </a:xfrm>
+          <a:prstGeom prst="rect">
+            <a:avLst/>
+          </a:prstGeom>
+          <a:noFill/>
+          <a:ln/>
+        </p:spPr>
+        <p:txBody>
+          <a:bodyPr wrap="square" lIns="0" tIns="0" rIns="0" bIns="0" rtlCol="0" anchor="ctr"/>
+          <a:lstStyle/>
+          <a:p>
+            <a:pPr algn="ctr" indent="0" marL="0">
+              <a:buNone/>
+            </a:pPr>
+            <a:r>
+              <a:rPr lang="en-US" sz="1100" b="1" spc="100" kern="0" dirty="0">
+                <a:solidFill>
+                  <a:srgbClr val="FFFFFF"/>
+                </a:solidFill>
+                <a:latin typeface="Calibri" pitchFamily="34" charset="0"/>
+                <a:ea typeface="Calibri" pitchFamily="34" charset="-122"/>
+                <a:cs typeface="Calibri" pitchFamily="34" charset="-120"/>
+              </a:rPr>
+              <a:t>AT SCALE</a:t>
+            </a:r>
+            <a:endParaRPr lang="en-US" sz="1100" dirty="0"/>
+          </a:p>
+        </p:txBody>
+      </p:sp>
+      <p:sp>
+        <p:nvSpPr>
+          <p:cNvPr id="21" name="Text 19"/>
+          <p:cNvSpPr/>
+          <p:nvPr/>
+        </p:nvSpPr>
+        <p:spPr>
+          <a:xfrm>
+            <a:off x="6501384" y="4251960"/>
+            <a:ext cx="4837176" cy="411480"/>
+          </a:xfrm>
+          <a:prstGeom prst="rect">
+            <a:avLst/>
+          </a:prstGeom>
+          <a:noFill/>
+          <a:ln/>
+        </p:spPr>
+        <p:txBody>
+          <a:bodyPr wrap="square" lIns="0" tIns="0" rIns="0" bIns="0" rtlCol="0" anchor="ctr"/>
+          <a:lstStyle/>
+          <a:p>
+            <a:pPr indent="0" marL="0">
+              <a:buNone/>
+            </a:pPr>
+            <a:r>
+              <a:rPr lang="en-US" sz="1800" b="1" dirty="0">
+                <a:solidFill>
+                  <a:srgbClr val="1A2238"/>
+                </a:solidFill>
+                <a:latin typeface="Calibri" pitchFamily="34" charset="0"/>
+                <a:ea typeface="Calibri" pitchFamily="34" charset="-122"/>
+                <a:cs typeface="Calibri" pitchFamily="34" charset="-120"/>
+              </a:rPr>
+              <a:t>DMRG reference corrected — for $12</a:t>
+            </a:r>
+            <a:endParaRPr lang="en-US" sz="1800" dirty="0"/>
+          </a:p>
+        </p:txBody>
+      </p:sp>
+      <p:sp>
+        <p:nvSpPr>
+          <p:cNvPr id="22" name="Text 20"/>
+          <p:cNvSpPr/>
+          <p:nvPr/>
+        </p:nvSpPr>
+        <p:spPr>
+          <a:xfrm>
+            <a:off x="6501384" y="4672584"/>
+            <a:ext cx="4837176" cy="1051560"/>
+          </a:xfrm>
+          <a:prstGeom prst="rect">
+            <a:avLst/>
+          </a:prstGeom>
+          <a:noFill/>
+          <a:ln/>
+        </p:spPr>
+        <p:txBody>
+          <a:bodyPr wrap="square" lIns="0" tIns="0" rIns="0" bIns="0" rtlCol="0" anchor="ctr"/>
+          <a:lstStyle/>
+          <a:p>
             <a:pPr indent="0" marL="0">
               <a:lnSpc>
                 <a:spcPct val="112000"/>
@@ -4864,7 +5221,7 @@
               <a:buNone/>
             </a:pPr>
             <a:r>
-              <a:rPr lang="en-US" sz="1050" dirty="0">
+              <a:rPr lang="en-US" sz="1280" dirty="0">
                 <a:solidFill>
                   <a:srgbClr val="1A2238"/>
                 </a:solidFill>
@@ -4872,9 +5229,33 @@
                 <a:ea typeface="Calibri" pitchFamily="34" charset="-122"/>
                 <a:cs typeface="Calibri" pitchFamily="34" charset="-120"/>
               </a:rPr>
-              <a:t>
-</a:t>
-            </a:r>
+              <a:t>At 38 qubits on CrO, the audit landed below the trusted reference: provably closer to the truth. Compute cost of the audit: ~$12 and under 3 hours on a rented cloud GPU.</a:t>
+            </a:r>
+            <a:endParaRPr lang="en-US" sz="1280" dirty="0"/>
+          </a:p>
+        </p:txBody>
+      </p:sp>
+      <p:sp>
+        <p:nvSpPr>
+          <p:cNvPr id="23" name="Text 21"/>
+          <p:cNvSpPr/>
+          <p:nvPr/>
+        </p:nvSpPr>
+        <p:spPr>
+          <a:xfrm>
+            <a:off x="640080" y="6053328"/>
+            <a:ext cx="10927080" cy="731520"/>
+          </a:xfrm>
+          <a:prstGeom prst="rect">
+            <a:avLst/>
+          </a:prstGeom>
+          <a:noFill/>
+          <a:ln/>
+        </p:spPr>
+        <p:txBody>
+          <a:bodyPr wrap="square" lIns="0" tIns="0" rIns="0" bIns="0" rtlCol="0" anchor="ctr"/>
+          <a:lstStyle/>
+          <a:p>
             <a:pPr indent="0" marL="0">
               <a:lnSpc>
                 <a:spcPct val="112000"/>
@@ -4907,7 +5288,33 @@
                 <a:ea typeface="Calibri" pitchFamily="34" charset="-122"/>
                 <a:cs typeface="Calibri" pitchFamily="34" charset="-120"/>
               </a:rPr>
-              <a:t>we do not claim a validated market size. Coverage today is the demonstrated oxide classes, and the audit certifies the correlated-electron solve — the silent-failure part — not every assumption in the modeling stack. The defensible claim is the one above: one avoided dead-end pays for the layer.</a:t>
+              <a:t>the mathematical guarantee applies to energies; verdicts comparing two states (spin gaps) are trusted only after each state is individually converged to certified accuracy — as the CrO and VO calls above were.</a:t>
+            </a:r>
+            <a:pPr indent="0" marL="0">
+              <a:lnSpc>
+                <a:spcPct val="112000"/>
+              </a:lnSpc>
+              <a:buNone/>
+            </a:pPr>
+            <a:endParaRPr lang="en-US" sz="1050" dirty="0"/>
+          </a:p>
+          <a:p>
+            <a:pPr indent="0" marL="0">
+              <a:lnSpc>
+                <a:spcPct val="112000"/>
+              </a:lnSpc>
+              <a:buNone/>
+            </a:pPr>
+            <a:r>
+              <a:rPr lang="en-US" sz="1050" i="1" dirty="0">
+                <a:solidFill>
+                  <a:srgbClr val="6B7280"/>
+                </a:solidFill>
+                <a:latin typeface="Calibri" pitchFamily="34" charset="0"/>
+                <a:ea typeface="Calibri" pitchFamily="34" charset="-122"/>
+                <a:cs typeface="Calibri" pitchFamily="34" charset="-120"/>
+              </a:rPr>
+              <a:t>Also in the evidence base: NiO (second oxide class), Sn-oxide EUV photoresist chemistry, exact-to-the-digit GPU execution.</a:t>
             </a:r>
             <a:endParaRPr lang="en-US" sz="1050" dirty="0"/>
           </a:p>
@@ -4978,7 +5385,7 @@
                 <a:ea typeface="Calibri" pitchFamily="34" charset="-122"/>
                 <a:cs typeface="Calibri" pitchFamily="34" charset="-120"/>
               </a:rPr>
-              <a:t>Why now: it runs today, and the frontier only moves outward</a:t>
+              <a:t>Triage, not replacement — audit the load-bearing welds</a:t>
             </a:r>
             <a:endParaRPr lang="en-US" sz="3200" dirty="0"/>
           </a:p>
@@ -4986,56 +5393,251 @@
       </p:sp>
       <p:sp>
         <p:nvSpPr>
-          <p:cNvPr id="3" name="Shape 1"/>
-          <p:cNvSpPr/>
-          <p:nvPr/>
-        </p:nvSpPr>
-        <p:spPr>
-          <a:xfrm>
-            <a:off x="640080" y="1325880"/>
-            <a:ext cx="10927080" cy="1371600"/>
+          <p:cNvPr id="3" name="Text 1"/>
+          <p:cNvSpPr/>
+          <p:nvPr/>
+        </p:nvSpPr>
+        <p:spPr>
+          <a:xfrm>
+            <a:off x="640080" y="1051560"/>
+            <a:ext cx="10881360" cy="457200"/>
+          </a:xfrm>
+          <a:prstGeom prst="rect">
+            <a:avLst/>
+          </a:prstGeom>
+          <a:noFill/>
+          <a:ln/>
+        </p:spPr>
+        <p:txBody>
+          <a:bodyPr wrap="square" lIns="0" tIns="0" rIns="0" bIns="0" rtlCol="0" anchor="ctr"/>
+          <a:lstStyle/>
+          <a:p>
+            <a:pPr indent="0" marL="0">
+              <a:buNone/>
+            </a:pPr>
+            <a:r>
+              <a:rPr lang="en-US" sz="1500" dirty="0">
+                <a:solidFill>
+                  <a:srgbClr val="6B7280"/>
+                </a:solidFill>
+                <a:latin typeface="Calibri" pitchFamily="34" charset="0"/>
+                <a:ea typeface="Calibri" pitchFamily="34" charset="-122"/>
+                <a:cs typeface="Calibri" pitchFamily="34" charset="-120"/>
+              </a:rPr>
+              <a:t>DFT keeps the screening job it is priced for. The audit sits at the one place errors become expensive: the go / no-go gate before synthesis.</a:t>
+            </a:r>
+            <a:endParaRPr lang="en-US" sz="1500" dirty="0"/>
+          </a:p>
+        </p:txBody>
+      </p:sp>
+      <p:sp>
+        <p:nvSpPr>
+          <p:cNvPr id="4" name="Shape 2"/>
+          <p:cNvSpPr/>
+          <p:nvPr/>
+        </p:nvSpPr>
+        <p:spPr>
+          <a:xfrm>
+            <a:off x="731520" y="1828800"/>
+            <a:ext cx="5120640" cy="731520"/>
           </a:xfrm>
           <a:prstGeom prst="roundRect">
             <a:avLst>
-              <a:gd name="adj" fmla="val 6000"/>
+              <a:gd name="adj" fmla="val 10000"/>
             </a:avLst>
           </a:prstGeom>
           <a:solidFill>
-            <a:srgbClr val="F3F6FC"/>
-          </a:solidFill>
-          <a:ln/>
-          <a:effectLst>
-            <a:outerShdw sx="100000" sy="100000" kx="0" ky="0" algn="bl" rotWithShape="0" blurRad="76200" dist="25400" dir="5400000">
-              <a:srgbClr val="9AA3B2">
-                <a:alpha val="30000"/>
-              </a:srgbClr>
-            </a:outerShdw>
-          </a:effectLst>
-        </p:spPr>
-      </p:sp>
-      <p:sp>
-        <p:nvSpPr>
-          <p:cNvPr id="4" name="Shape 2"/>
-          <p:cNvSpPr/>
-          <p:nvPr/>
-        </p:nvSpPr>
-        <p:spPr>
-          <a:xfrm>
-            <a:off x="914400" y="1664208"/>
-            <a:ext cx="694944" cy="694944"/>
-          </a:xfrm>
-          <a:prstGeom prst="ellipse">
-            <a:avLst/>
+            <a:srgbClr val="CADCFC"/>
+          </a:solidFill>
+          <a:ln/>
+        </p:spPr>
+      </p:sp>
+      <p:sp>
+        <p:nvSpPr>
+          <p:cNvPr id="5" name="Text 3"/>
+          <p:cNvSpPr/>
+          <p:nvPr/>
+        </p:nvSpPr>
+        <p:spPr>
+          <a:xfrm>
+            <a:off x="822960" y="1828800"/>
+            <a:ext cx="4937760" cy="731520"/>
+          </a:xfrm>
+          <a:prstGeom prst="rect">
+            <a:avLst/>
+          </a:prstGeom>
+          <a:noFill/>
+          <a:ln/>
+        </p:spPr>
+        <p:txBody>
+          <a:bodyPr wrap="square" lIns="0" tIns="0" rIns="0" bIns="0" rtlCol="0" anchor="ctr"/>
+          <a:lstStyle/>
+          <a:p>
+            <a:pPr algn="ctr" indent="0" marL="0">
+              <a:buNone/>
+            </a:pPr>
+            <a:r>
+              <a:rPr lang="en-US" sz="1250" dirty="0">
+                <a:solidFill>
+                  <a:srgbClr val="1A2238"/>
+                </a:solidFill>
+                <a:latin typeface="Calibri" pitchFamily="34" charset="0"/>
+                <a:ea typeface="Calibri" pitchFamily="34" charset="-122"/>
+                <a:cs typeface="Calibri" pitchFamily="34" charset="-120"/>
+              </a:rPr>
+              <a:t>~10⁶ candidates — DFT screen (pennies each)</a:t>
+            </a:r>
+            <a:endParaRPr lang="en-US" sz="1250" dirty="0"/>
+          </a:p>
+        </p:txBody>
+      </p:sp>
+      <p:sp>
+        <p:nvSpPr>
+          <p:cNvPr id="6" name="Shape 4"/>
+          <p:cNvSpPr/>
+          <p:nvPr/>
+        </p:nvSpPr>
+        <p:spPr>
+          <a:xfrm>
+            <a:off x="1550822" y="2788920"/>
+            <a:ext cx="3482035" cy="731520"/>
+          </a:xfrm>
+          <a:prstGeom prst="roundRect">
+            <a:avLst>
+              <a:gd name="adj" fmla="val 10000"/>
+            </a:avLst>
+          </a:prstGeom>
+          <a:solidFill>
+            <a:srgbClr val="9DB8E8"/>
+          </a:solidFill>
+          <a:ln/>
+        </p:spPr>
+      </p:sp>
+      <p:sp>
+        <p:nvSpPr>
+          <p:cNvPr id="7" name="Text 5"/>
+          <p:cNvSpPr/>
+          <p:nvPr/>
+        </p:nvSpPr>
+        <p:spPr>
+          <a:xfrm>
+            <a:off x="1642262" y="2788920"/>
+            <a:ext cx="3299155" cy="731520"/>
+          </a:xfrm>
+          <a:prstGeom prst="rect">
+            <a:avLst/>
+          </a:prstGeom>
+          <a:noFill/>
+          <a:ln/>
+        </p:spPr>
+        <p:txBody>
+          <a:bodyPr wrap="square" lIns="0" tIns="0" rIns="0" bIns="0" rtlCol="0" anchor="ctr"/>
+          <a:lstStyle/>
+          <a:p>
+            <a:pPr algn="ctr" indent="0" marL="0">
+              <a:buNone/>
+            </a:pPr>
+            <a:r>
+              <a:rPr lang="en-US" sz="1250" dirty="0">
+                <a:solidFill>
+                  <a:srgbClr val="1A2238"/>
+                </a:solidFill>
+                <a:latin typeface="Calibri" pitchFamily="34" charset="0"/>
+                <a:ea typeface="Calibri" pitchFamily="34" charset="-122"/>
+                <a:cs typeface="Calibri" pitchFamily="34" charset="-120"/>
+              </a:rPr>
+              <a:t>~10² survivors — refined models</a:t>
+            </a:r>
+            <a:endParaRPr lang="en-US" sz="1250" dirty="0"/>
+          </a:p>
+        </p:txBody>
+      </p:sp>
+      <p:sp>
+        <p:nvSpPr>
+          <p:cNvPr id="8" name="Shape 6"/>
+          <p:cNvSpPr/>
+          <p:nvPr/>
+        </p:nvSpPr>
+        <p:spPr>
+          <a:xfrm>
+            <a:off x="2216506" y="3749040"/>
+            <a:ext cx="2150669" cy="731520"/>
+          </a:xfrm>
+          <a:prstGeom prst="roundRect">
+            <a:avLst>
+              <a:gd name="adj" fmla="val 10000"/>
+            </a:avLst>
           </a:prstGeom>
           <a:solidFill>
             <a:srgbClr val="16205B"/>
+          </a:solidFill>
+          <a:ln/>
+        </p:spPr>
+      </p:sp>
+      <p:sp>
+        <p:nvSpPr>
+          <p:cNvPr id="9" name="Text 7"/>
+          <p:cNvSpPr/>
+          <p:nvPr/>
+        </p:nvSpPr>
+        <p:spPr>
+          <a:xfrm>
+            <a:off x="2307946" y="3749040"/>
+            <a:ext cx="1967789" cy="731520"/>
+          </a:xfrm>
+          <a:prstGeom prst="rect">
+            <a:avLst/>
+          </a:prstGeom>
+          <a:noFill/>
+          <a:ln/>
+        </p:spPr>
+        <p:txBody>
+          <a:bodyPr wrap="square" lIns="0" tIns="0" rIns="0" bIns="0" rtlCol="0" anchor="ctr"/>
+          <a:lstStyle/>
+          <a:p>
+            <a:pPr algn="ctr" indent="0" marL="0">
+              <a:buNone/>
+            </a:pPr>
+            <a:r>
+              <a:rPr lang="en-US" sz="1250" b="1" dirty="0">
+                <a:solidFill>
+                  <a:srgbClr val="FFFFFF"/>
+                </a:solidFill>
+                <a:latin typeface="Calibri" pitchFamily="34" charset="0"/>
+                <a:ea typeface="Calibri" pitchFamily="34" charset="-122"/>
+                <a:cs typeface="Calibri" pitchFamily="34" charset="-120"/>
+              </a:rPr>
+              <a:t>Dozens: go / no-go synthesis decisions</a:t>
+            </a:r>
+            <a:endParaRPr lang="en-US" sz="1250" dirty="0"/>
+          </a:p>
+        </p:txBody>
+      </p:sp>
+      <p:sp>
+        <p:nvSpPr>
+          <p:cNvPr id="10" name="Shape 8"/>
+          <p:cNvSpPr/>
+          <p:nvPr/>
+        </p:nvSpPr>
+        <p:spPr>
+          <a:xfrm>
+            <a:off x="1051560" y="4892040"/>
+            <a:ext cx="4480560" cy="868680"/>
+          </a:xfrm>
+          <a:prstGeom prst="roundRect">
+            <a:avLst>
+              <a:gd name="adj" fmla="val 9474"/>
+            </a:avLst>
+          </a:prstGeom>
+          <a:solidFill>
+            <a:srgbClr val="02C39A"/>
           </a:solidFill>
           <a:ln/>
         </p:spPr>
       </p:sp>
       <p:pic>
         <p:nvPicPr>
-          <p:cNvPr id="5" name="Image 0" descr="preencoded.png">    </p:cNvPr>
+          <p:cNvPr id="11" name="Image 0" descr="preencoded.png">    </p:cNvPr>
           <p:cNvPicPr>
             <a:picLocks noChangeAspect="1"/>
           </p:cNvPicPr>
@@ -5049,8 +5651,8 @@
         </p:blipFill>
         <p:spPr>
           <a:xfrm>
-            <a:off x="1095085" y="1844893"/>
-            <a:ext cx="333573" cy="333573"/>
+            <a:off x="1298448" y="5120640"/>
+            <a:ext cx="411480" cy="411480"/>
           </a:xfrm>
           <a:prstGeom prst="rect">
             <a:avLst/>
@@ -5059,53 +5661,14 @@
       </p:pic>
       <p:sp>
         <p:nvSpPr>
-          <p:cNvPr id="6" name="Text 3"/>
-          <p:cNvSpPr/>
-          <p:nvPr/>
-        </p:nvSpPr>
-        <p:spPr>
-          <a:xfrm>
-            <a:off x="1920240" y="1490472"/>
-            <a:ext cx="9326880" cy="411480"/>
-          </a:xfrm>
-          <a:prstGeom prst="rect">
-            <a:avLst/>
-          </a:prstGeom>
-          <a:noFill/>
-          <a:ln/>
-        </p:spPr>
-        <p:txBody>
-          <a:bodyPr wrap="square" lIns="0" tIns="0" rIns="0" bIns="0" rtlCol="0" anchor="ctr"/>
-          <a:lstStyle/>
-          <a:p>
-            <a:pPr indent="0" marL="0">
-              <a:buNone/>
-            </a:pPr>
-            <a:r>
-              <a:rPr lang="en-US" sz="1850" b="1" dirty="0">
-                <a:solidFill>
-                  <a:srgbClr val="1A2238"/>
-                </a:solidFill>
-                <a:latin typeface="Calibri" pitchFamily="34" charset="0"/>
-                <a:ea typeface="Calibri" pitchFamily="34" charset="-122"/>
-                <a:cs typeface="Calibri" pitchFamily="34" charset="-120"/>
-              </a:rPr>
-              <a:t>Executed on real hardware — today</a:t>
-            </a:r>
-            <a:endParaRPr lang="en-US" sz="1850" dirty="0"/>
-          </a:p>
-        </p:txBody>
-      </p:sp>
-      <p:sp>
-        <p:nvSpPr>
-          <p:cNvPr id="7" name="Text 4"/>
-          <p:cNvSpPr/>
-          <p:nvPr/>
-        </p:nvSpPr>
-        <p:spPr>
-          <a:xfrm>
-            <a:off x="1920240" y="1901952"/>
-            <a:ext cx="9326880" cy="731520"/>
+          <p:cNvPr id="12" name="Text 9"/>
+          <p:cNvSpPr/>
+          <p:nvPr/>
+        </p:nvSpPr>
+        <p:spPr>
+          <a:xfrm>
+            <a:off x="1828800" y="4892040"/>
+            <a:ext cx="3657600" cy="868680"/>
           </a:xfrm>
           <a:prstGeom prst="rect">
             <a:avLst/>
@@ -5119,140 +5682,120 @@
           <a:p>
             <a:pPr indent="0" marL="0">
               <a:lnSpc>
-                <a:spcPct val="110000"/>
+                <a:spcPct val="105000"/>
               </a:lnSpc>
               <a:buNone/>
             </a:pPr>
             <a:r>
-              <a:rPr lang="en-US" sz="1300" dirty="0">
-                <a:solidFill>
-                  <a:srgbClr val="1A2238"/>
-                </a:solidFill>
-                <a:latin typeface="Calibri" pitchFamily="34" charset="0"/>
-                <a:ea typeface="Calibri" pitchFamily="34" charset="-122"/>
-                <a:cs typeface="Calibri" pitchFamily="34" charset="-120"/>
-              </a:rPr>
-              <a:t>Exact to the digit at 20 qubits and chemically accurate at 28 on rented NVIDIA GPUs; reference-correcting at 38; the 40-qubit flagship in flight. No exotic infrastructure — cloud instances anyone can rent.</a:t>
-            </a:r>
-            <a:endParaRPr lang="en-US" sz="1300" dirty="0"/>
-          </a:p>
-        </p:txBody>
-      </p:sp>
-      <p:sp>
-        <p:nvSpPr>
-          <p:cNvPr id="8" name="Shape 5"/>
-          <p:cNvSpPr/>
-          <p:nvPr/>
-        </p:nvSpPr>
-        <p:spPr>
-          <a:xfrm>
-            <a:off x="640080" y="2898648"/>
-            <a:ext cx="10927080" cy="1371600"/>
+              <a:rPr lang="en-US" sz="1350" b="1" dirty="0">
+                <a:solidFill>
+                  <a:srgbClr val="16205B"/>
+                </a:solidFill>
+                <a:latin typeface="Calibri" pitchFamily="34" charset="0"/>
+                <a:ea typeface="Calibri" pitchFamily="34" charset="-122"/>
+                <a:cs typeface="Calibri" pitchFamily="34" charset="-120"/>
+              </a:rPr>
+              <a:t>MATGEN-Q AUDIT — $10–100 per decisive number</a:t>
+            </a:r>
+            <a:endParaRPr lang="en-US" sz="1350" dirty="0"/>
+          </a:p>
+        </p:txBody>
+      </p:sp>
+      <p:sp>
+        <p:nvSpPr>
+          <p:cNvPr id="13" name="Shape 10"/>
+          <p:cNvSpPr/>
+          <p:nvPr/>
+        </p:nvSpPr>
+        <p:spPr>
+          <a:xfrm>
+            <a:off x="3291840" y="4480560"/>
+            <a:ext cx="0" cy="411480"/>
+          </a:xfrm>
+          <a:prstGeom prst="line">
+            <a:avLst/>
+          </a:prstGeom>
+          <a:noFill/>
+          <a:ln w="31750">
+            <a:solidFill>
+              <a:srgbClr val="018A6D"/>
+            </a:solidFill>
+            <a:prstDash val="solid"/>
+            <a:tailEnd type="triangle"/>
+          </a:ln>
+        </p:spPr>
+      </p:sp>
+      <p:sp>
+        <p:nvSpPr>
+          <p:cNvPr id="14" name="Shape 11"/>
+          <p:cNvSpPr/>
+          <p:nvPr/>
+        </p:nvSpPr>
+        <p:spPr>
+          <a:xfrm>
+            <a:off x="6400800" y="1828800"/>
+            <a:ext cx="5120640" cy="1920240"/>
           </a:xfrm>
           <a:prstGeom prst="roundRect">
             <a:avLst>
-              <a:gd name="adj" fmla="val 6000"/>
+              <a:gd name="adj" fmla="val 4286"/>
             </a:avLst>
           </a:prstGeom>
           <a:solidFill>
-            <a:srgbClr val="16205B"/>
-          </a:solidFill>
-          <a:ln/>
-        </p:spPr>
-      </p:sp>
-      <p:sp>
-        <p:nvSpPr>
-          <p:cNvPr id="9" name="Shape 6"/>
-          <p:cNvSpPr/>
-          <p:nvPr/>
-        </p:nvSpPr>
-        <p:spPr>
-          <a:xfrm>
-            <a:off x="914400" y="3236976"/>
-            <a:ext cx="694944" cy="694944"/>
-          </a:xfrm>
-          <a:prstGeom prst="ellipse">
-            <a:avLst/>
-          </a:prstGeom>
-          <a:solidFill>
-            <a:srgbClr val="02C39A"/>
-          </a:solidFill>
-          <a:ln/>
-        </p:spPr>
-      </p:sp>
-      <p:pic>
-        <p:nvPicPr>
-          <p:cNvPr id="10" name="Image 1" descr="preencoded.png">    </p:cNvPr>
-          <p:cNvPicPr>
-            <a:picLocks noChangeAspect="1"/>
-          </p:cNvPicPr>
-          <p:nvPr/>
-        </p:nvPicPr>
-        <p:blipFill>
-          <a:blip r:embed="rId2"/>
-          <a:stretch>
-            <a:fillRect/>
-          </a:stretch>
-        </p:blipFill>
-        <p:spPr>
-          <a:xfrm>
-            <a:off x="1095085" y="3417661"/>
-            <a:ext cx="333573" cy="333573"/>
-          </a:xfrm>
-          <a:prstGeom prst="rect">
-            <a:avLst/>
-          </a:prstGeom>
-        </p:spPr>
-      </p:pic>
-      <p:sp>
-        <p:nvSpPr>
-          <p:cNvPr id="11" name="Text 7"/>
-          <p:cNvSpPr/>
-          <p:nvPr/>
-        </p:nvSpPr>
-        <p:spPr>
-          <a:xfrm>
-            <a:off x="1920240" y="3063240"/>
-            <a:ext cx="9326880" cy="411480"/>
-          </a:xfrm>
-          <a:prstGeom prst="rect">
-            <a:avLst/>
-          </a:prstGeom>
-          <a:noFill/>
-          <a:ln/>
-        </p:spPr>
-        <p:txBody>
-          <a:bodyPr wrap="square" lIns="0" tIns="0" rIns="0" bIns="0" rtlCol="0" anchor="ctr"/>
-          <a:lstStyle/>
-          <a:p>
-            <a:pPr indent="0" marL="0">
-              <a:buNone/>
-            </a:pPr>
-            <a:r>
-              <a:rPr lang="en-US" sz="1850" b="1" dirty="0">
-                <a:solidFill>
-                  <a:srgbClr val="02C39A"/>
-                </a:solidFill>
-                <a:latin typeface="Calibri" pitchFamily="34" charset="0"/>
-                <a:ea typeface="Calibri" pitchFamily="34" charset="-122"/>
-                <a:cs typeface="Calibri" pitchFamily="34" charset="-120"/>
-              </a:rPr>
-              <a:t>Built for the quantum curve</a:t>
-            </a:r>
-            <a:endParaRPr lang="en-US" sz="1850" dirty="0"/>
-          </a:p>
-        </p:txBody>
-      </p:sp>
-      <p:sp>
-        <p:nvSpPr>
-          <p:cNvPr id="12" name="Text 8"/>
-          <p:cNvSpPr/>
-          <p:nvPr/>
-        </p:nvSpPr>
-        <p:spPr>
-          <a:xfrm>
-            <a:off x="1920240" y="3474720"/>
-            <a:ext cx="9326880" cy="731520"/>
+            <a:srgbClr val="F3F6FC"/>
+          </a:solidFill>
+          <a:ln/>
+        </p:spPr>
+      </p:sp>
+      <p:sp>
+        <p:nvSpPr>
+          <p:cNvPr id="15" name="Text 12"/>
+          <p:cNvSpPr/>
+          <p:nvPr/>
+        </p:nvSpPr>
+        <p:spPr>
+          <a:xfrm>
+            <a:off x="6675120" y="2011680"/>
+            <a:ext cx="4572000" cy="685800"/>
+          </a:xfrm>
+          <a:prstGeom prst="rect">
+            <a:avLst/>
+          </a:prstGeom>
+          <a:noFill/>
+          <a:ln/>
+        </p:spPr>
+        <p:txBody>
+          <a:bodyPr wrap="square" lIns="0" tIns="0" rIns="0" bIns="0" rtlCol="0" anchor="ctr"/>
+          <a:lstStyle/>
+          <a:p>
+            <a:pPr indent="0" marL="0">
+              <a:buNone/>
+            </a:pPr>
+            <a:r>
+              <a:rPr lang="en-US" sz="3400" b="1" dirty="0">
+                <a:solidFill>
+                  <a:srgbClr val="C13438"/>
+                </a:solidFill>
+                <a:latin typeface="Calibri" pitchFamily="34" charset="0"/>
+                <a:ea typeface="Calibri" pitchFamily="34" charset="-122"/>
+                <a:cs typeface="Calibri" pitchFamily="34" charset="-120"/>
+              </a:rPr>
+              <a:t>$100k – $1M+</a:t>
+            </a:r>
+            <a:endParaRPr lang="en-US" sz="3400" dirty="0"/>
+          </a:p>
+        </p:txBody>
+      </p:sp>
+      <p:sp>
+        <p:nvSpPr>
+          <p:cNvPr id="16" name="Text 13"/>
+          <p:cNvSpPr/>
+          <p:nvPr/>
+        </p:nvSpPr>
+        <p:spPr>
+          <a:xfrm>
+            <a:off x="6675120" y="2697480"/>
+            <a:ext cx="4572000" cy="914400"/>
           </a:xfrm>
           <a:prstGeom prst="rect">
             <a:avLst/>
@@ -5266,20 +5809,20 @@
           <a:p>
             <a:pPr indent="0" marL="0">
               <a:lnSpc>
-                <a:spcPct val="110000"/>
+                <a:spcPct val="112000"/>
               </a:lnSpc>
               <a:buNone/>
             </a:pPr>
             <a:r>
               <a:rPr lang="en-US" sz="1300" dirty="0">
                 <a:solidFill>
-                  <a:srgbClr val="FFFFFF"/>
-                </a:solidFill>
-                <a:latin typeface="Calibri" pitchFamily="34" charset="0"/>
-                <a:ea typeface="Calibri" pitchFamily="34" charset="-122"/>
-                <a:cs typeface="Calibri" pitchFamily="34" charset="-120"/>
-              </a:rPr>
-              <a:t>The expensive step — selecting which configurations matter — is exactly what a quantum sampler does natively (CUDA-Q today, trapped-ion QPUs next: our verified circuits are already in the queue). As devices mature, certified truth gets cheaper every year.</a:t>
+                  <a:srgbClr val="1A2238"/>
+                </a:solidFill>
+                <a:latin typeface="Calibri" pitchFamily="34" charset="0"/>
+                <a:ea typeface="Calibri" pitchFamily="34" charset="-122"/>
+                <a:cs typeface="Calibri" pitchFamily="34" charset="-120"/>
+              </a:rPr>
+              <a:t>cost of one synthesis campaign chasing a computationally mis-ranked candidate — the failure mode the audit exists to catch.</a:t>
             </a:r>
             <a:endParaRPr lang="en-US" sz="1300" dirty="0"/>
           </a:p>
@@ -5287,103 +5830,136 @@
       </p:sp>
       <p:sp>
         <p:nvSpPr>
-          <p:cNvPr id="13" name="Shape 9"/>
-          <p:cNvSpPr/>
-          <p:nvPr/>
-        </p:nvSpPr>
-        <p:spPr>
-          <a:xfrm>
-            <a:off x="640080" y="4471416"/>
-            <a:ext cx="10927080" cy="1371600"/>
+          <p:cNvPr id="17" name="Shape 14"/>
+          <p:cNvSpPr/>
+          <p:nvPr/>
+        </p:nvSpPr>
+        <p:spPr>
+          <a:xfrm>
+            <a:off x="6400800" y="3931920"/>
+            <a:ext cx="5120640" cy="1828800"/>
           </a:xfrm>
           <a:prstGeom prst="roundRect">
             <a:avLst>
-              <a:gd name="adj" fmla="val 6000"/>
+              <a:gd name="adj" fmla="val 4500"/>
             </a:avLst>
           </a:prstGeom>
           <a:solidFill>
-            <a:srgbClr val="F3F6FC"/>
-          </a:solidFill>
-          <a:ln/>
-          <a:effectLst>
-            <a:outerShdw sx="100000" sy="100000" kx="0" ky="0" algn="bl" rotWithShape="0" blurRad="76200" dist="25400" dir="5400000">
-              <a:srgbClr val="9AA3B2">
-                <a:alpha val="30000"/>
-              </a:srgbClr>
-            </a:outerShdw>
-          </a:effectLst>
-        </p:spPr>
-      </p:sp>
-      <p:sp>
-        <p:nvSpPr>
-          <p:cNvPr id="14" name="Shape 10"/>
-          <p:cNvSpPr/>
-          <p:nvPr/>
-        </p:nvSpPr>
-        <p:spPr>
-          <a:xfrm>
-            <a:off x="914400" y="4809744"/>
-            <a:ext cx="694944" cy="694944"/>
-          </a:xfrm>
-          <a:prstGeom prst="ellipse">
-            <a:avLst/>
-          </a:prstGeom>
-          <a:solidFill>
             <a:srgbClr val="16205B"/>
           </a:solidFill>
           <a:ln/>
         </p:spPr>
       </p:sp>
-      <p:pic>
-        <p:nvPicPr>
-          <p:cNvPr id="15" name="Image 2" descr="preencoded.png">    </p:cNvPr>
-          <p:cNvPicPr>
-            <a:picLocks noChangeAspect="1"/>
-          </p:cNvPicPr>
-          <p:nvPr/>
-        </p:nvPicPr>
-        <p:blipFill>
-          <a:blip r:embed="rId3"/>
-          <a:stretch>
-            <a:fillRect/>
-          </a:stretch>
-        </p:blipFill>
-        <p:spPr>
-          <a:xfrm>
-            <a:off x="1095085" y="4990429"/>
-            <a:ext cx="333573" cy="333573"/>
-          </a:xfrm>
-          <a:prstGeom prst="rect">
-            <a:avLst/>
-          </a:prstGeom>
-        </p:spPr>
-      </p:pic>
-      <p:sp>
-        <p:nvSpPr>
-          <p:cNvPr id="16" name="Text 11"/>
-          <p:cNvSpPr/>
-          <p:nvPr/>
-        </p:nvSpPr>
-        <p:spPr>
-          <a:xfrm>
-            <a:off x="1920240" y="4636008"/>
-            <a:ext cx="9326880" cy="411480"/>
-          </a:xfrm>
-          <a:prstGeom prst="rect">
-            <a:avLst/>
-          </a:prstGeom>
-          <a:noFill/>
-          <a:ln/>
-        </p:spPr>
-        <p:txBody>
-          <a:bodyPr wrap="square" lIns="0" tIns="0" rIns="0" bIns="0" rtlCol="0" anchor="ctr"/>
-          <a:lstStyle/>
-          <a:p>
-            <a:pPr indent="0" marL="0">
-              <a:buNone/>
-            </a:pPr>
-            <a:r>
-              <a:rPr lang="en-US" sz="1850" b="1" dirty="0">
+      <p:sp>
+        <p:nvSpPr>
+          <p:cNvPr id="18" name="Text 15"/>
+          <p:cNvSpPr/>
+          <p:nvPr/>
+        </p:nvSpPr>
+        <p:spPr>
+          <a:xfrm>
+            <a:off x="6675120" y="4114800"/>
+            <a:ext cx="4572000" cy="457200"/>
+          </a:xfrm>
+          <a:prstGeom prst="rect">
+            <a:avLst/>
+          </a:prstGeom>
+          <a:noFill/>
+          <a:ln/>
+        </p:spPr>
+        <p:txBody>
+          <a:bodyPr wrap="square" lIns="0" tIns="0" rIns="0" bIns="0" rtlCol="0" anchor="ctr"/>
+          <a:lstStyle/>
+          <a:p>
+            <a:pPr indent="0" marL="0">
+              <a:buNone/>
+            </a:pPr>
+            <a:r>
+              <a:rPr lang="en-US" sz="1900" b="1" dirty="0">
+                <a:solidFill>
+                  <a:srgbClr val="02C39A"/>
+                </a:solidFill>
+                <a:latin typeface="Calibri" pitchFamily="34" charset="0"/>
+                <a:ea typeface="Calibri" pitchFamily="34" charset="-122"/>
+                <a:cs typeface="Calibri" pitchFamily="34" charset="-120"/>
+              </a:rPr>
+              <a:t>One avoided dead-end per year</a:t>
+            </a:r>
+            <a:endParaRPr lang="en-US" sz="1900" dirty="0"/>
+          </a:p>
+        </p:txBody>
+      </p:sp>
+      <p:sp>
+        <p:nvSpPr>
+          <p:cNvPr id="19" name="Text 16"/>
+          <p:cNvSpPr/>
+          <p:nvPr/>
+        </p:nvSpPr>
+        <p:spPr>
+          <a:xfrm>
+            <a:off x="6675120" y="4572000"/>
+            <a:ext cx="4572000" cy="1051560"/>
+          </a:xfrm>
+          <a:prstGeom prst="rect">
+            <a:avLst/>
+          </a:prstGeom>
+          <a:noFill/>
+          <a:ln/>
+        </p:spPr>
+        <p:txBody>
+          <a:bodyPr wrap="square" lIns="0" tIns="0" rIns="0" bIns="0" rtlCol="0" anchor="ctr"/>
+          <a:lstStyle/>
+          <a:p>
+            <a:pPr indent="0" marL="0">
+              <a:lnSpc>
+                <a:spcPct val="112000"/>
+              </a:lnSpc>
+              <a:buNone/>
+            </a:pPr>
+            <a:r>
+              <a:rPr lang="en-US" sz="1300" dirty="0">
+                <a:solidFill>
+                  <a:srgbClr val="FFFFFF"/>
+                </a:solidFill>
+                <a:latin typeface="Calibri" pitchFamily="34" charset="0"/>
+                <a:ea typeface="Calibri" pitchFamily="34" charset="-122"/>
+                <a:cs typeface="Calibri" pitchFamily="34" charset="-120"/>
+              </a:rPr>
+              <a:t>pays for the audit layer across an entire screening portfolio. It doesn’t need “millions saved” to be worth deploying — though that is where the mechanism points.</a:t>
+            </a:r>
+            <a:endParaRPr lang="en-US" sz="1300" dirty="0"/>
+          </a:p>
+        </p:txBody>
+      </p:sp>
+      <p:sp>
+        <p:nvSpPr>
+          <p:cNvPr id="20" name="Text 17"/>
+          <p:cNvSpPr/>
+          <p:nvPr/>
+        </p:nvSpPr>
+        <p:spPr>
+          <a:xfrm>
+            <a:off x="640080" y="5989320"/>
+            <a:ext cx="10927080" cy="822960"/>
+          </a:xfrm>
+          <a:prstGeom prst="rect">
+            <a:avLst/>
+          </a:prstGeom>
+          <a:noFill/>
+          <a:ln/>
+        </p:spPr>
+        <p:txBody>
+          <a:bodyPr wrap="square" lIns="0" tIns="0" rIns="0" bIns="0" rtlCol="0" anchor="ctr"/>
+          <a:lstStyle/>
+          <a:p>
+            <a:pPr indent="0" marL="0">
+              <a:lnSpc>
+                <a:spcPct val="112000"/>
+              </a:lnSpc>
+              <a:buNone/>
+            </a:pPr>
+            <a:r>
+              <a:rPr lang="en-US" sz="1250" i="1" dirty="0">
                 <a:solidFill>
                   <a:srgbClr val="1A2238"/>
                 </a:solidFill>
@@ -5391,41 +5967,16 @@
                 <a:ea typeface="Calibri" pitchFamily="34" charset="-122"/>
                 <a:cs typeface="Calibri" pitchFamily="34" charset="-120"/>
               </a:rPr>
-              <a:t>Credibility as a feature</a:t>
-            </a:r>
-            <a:endParaRPr lang="en-US" sz="1850" dirty="0"/>
-          </a:p>
-        </p:txBody>
-      </p:sp>
-      <p:sp>
-        <p:nvSpPr>
-          <p:cNvPr id="17" name="Text 12"/>
-          <p:cNvSpPr/>
-          <p:nvPr/>
-        </p:nvSpPr>
-        <p:spPr>
-          <a:xfrm>
-            <a:off x="1920240" y="5047488"/>
-            <a:ext cx="9326880" cy="731520"/>
-          </a:xfrm>
-          <a:prstGeom prst="rect">
-            <a:avLst/>
-          </a:prstGeom>
-          <a:noFill/>
-          <a:ln/>
-        </p:spPr>
-        <p:txBody>
-          <a:bodyPr wrap="square" lIns="0" tIns="0" rIns="0" bIns="0" rtlCol="0" anchor="ctr"/>
-          <a:lstStyle/>
-          <a:p>
+              <a:t>You don’t X-ray every weld in the shipyard — you X-ray the ones the hull depends on.</a:t>
+            </a:r>
             <a:pPr indent="0" marL="0">
               <a:lnSpc>
-                <a:spcPct val="110000"/>
+                <a:spcPct val="112000"/>
               </a:lnSpc>
               <a:buNone/>
             </a:pPr>
             <a:r>
-              <a:rPr lang="en-US" sz="1300" dirty="0">
+              <a:rPr lang="en-US" sz="1050" dirty="0">
                 <a:solidFill>
                   <a:srgbClr val="1A2238"/>
                 </a:solidFill>
@@ -5433,38 +5984,34 @@
                 <a:ea typeface="Calibri" pitchFamily="34" charset="-122"/>
                 <a:cs typeface="Calibri" pitchFamily="34" charset="-120"/>
               </a:rPr>
-              <a:t>Clinical-trial-style pre-registration, cryptographically frozen blind tests, published failures, and a one-command reproduction path with 24 automated checks. An audit you can audit.</a:t>
-            </a:r>
-            <a:endParaRPr lang="en-US" sz="1300" dirty="0"/>
-          </a:p>
-        </p:txBody>
-      </p:sp>
-      <p:sp>
-        <p:nvSpPr>
-          <p:cNvPr id="18" name="Text 13"/>
-          <p:cNvSpPr/>
-          <p:nvPr/>
-        </p:nvSpPr>
-        <p:spPr>
-          <a:xfrm>
-            <a:off x="640080" y="6199632"/>
-            <a:ext cx="10927080" cy="411480"/>
-          </a:xfrm>
-          <a:prstGeom prst="rect">
-            <a:avLst/>
-          </a:prstGeom>
-          <a:noFill/>
-          <a:ln/>
-        </p:spPr>
-        <p:txBody>
-          <a:bodyPr wrap="square" lIns="0" tIns="0" rIns="0" bIns="0" rtlCol="0" anchor="ctr"/>
-          <a:lstStyle/>
-          <a:p>
-            <a:pPr indent="0" marL="0">
-              <a:buNone/>
-            </a:pPr>
-            <a:r>
-              <a:rPr lang="en-US" sz="1250" i="1" dirty="0">
+              <a:t>
+</a:t>
+            </a:r>
+            <a:pPr indent="0" marL="0">
+              <a:lnSpc>
+                <a:spcPct val="112000"/>
+              </a:lnSpc>
+              <a:buNone/>
+            </a:pPr>
+            <a:r>
+              <a:rPr lang="en-US" sz="1050" b="1" dirty="0">
+                <a:solidFill>
+                  <a:srgbClr val="1A2238"/>
+                </a:solidFill>
+                <a:latin typeface="Calibri" pitchFamily="34" charset="0"/>
+                <a:ea typeface="Calibri" pitchFamily="34" charset="-122"/>
+                <a:cs typeface="Calibri" pitchFamily="34" charset="-120"/>
+              </a:rPr>
+              <a:t>Fine print, stated openly: </a:t>
+            </a:r>
+            <a:pPr indent="0" marL="0">
+              <a:lnSpc>
+                <a:spcPct val="112000"/>
+              </a:lnSpc>
+              <a:buNone/>
+            </a:pPr>
+            <a:r>
+              <a:rPr lang="en-US" sz="1050" dirty="0">
                 <a:solidFill>
                   <a:srgbClr val="6B7280"/>
                 </a:solidFill>
@@ -5472,9 +6019,9 @@
                 <a:ea typeface="Calibri" pitchFamily="34" charset="-122"/>
                 <a:cs typeface="Calibri" pitchFamily="34" charset="-120"/>
               </a:rPr>
-              <a:t>Semiconductors (EUV photoresists) · catalysis · battery materials · magnetics — demonstrated on the chemistry these industries actually struggle with.</a:t>
-            </a:r>
-            <a:endParaRPr lang="en-US" sz="1250" dirty="0"/>
+              <a:t>we do not claim a validated market size. Coverage today is the demonstrated oxide classes, and the audit certifies the correlated-electron solve — the silent-failure part — not every assumption in the modeling stack. The defensible claim is the one above: one avoided dead-end pays for the layer.</a:t>
+            </a:r>
+            <a:endParaRPr lang="en-US" sz="1050" dirty="0"/>
           </a:p>
         </p:txBody>
       </p:sp>
@@ -5489,6 +6036,571 @@
 <file path=ppt/slides/slide7.xml><?xml version="1.0" encoding="utf-8"?>
 <p:sld xmlns:a="http://schemas.openxmlformats.org/drawingml/2006/main" xmlns:r="http://schemas.openxmlformats.org/officeDocument/2006/relationships" xmlns:p="http://schemas.openxmlformats.org/presentationml/2006/main">
   <p:cSld name="Slide 7">
+    <p:bg>
+      <p:bgPr>
+        <a:solidFill>
+          <a:srgbClr val="FFFFFF"/>
+        </a:solidFill>
+      </p:bgPr>
+    </p:bg>
+    <p:spTree>
+      <p:nvGrpSpPr>
+        <p:cNvPr id="1" name=""/>
+        <p:cNvGrpSpPr/>
+        <p:nvPr/>
+      </p:nvGrpSpPr>
+      <p:grpSpPr>
+        <a:xfrm>
+          <a:off x="0" y="0"/>
+          <a:ext cx="0" cy="0"/>
+          <a:chOff x="0" y="0"/>
+          <a:chExt cx="0" cy="0"/>
+        </a:xfrm>
+      </p:grpSpPr>
+      <p:sp>
+        <p:nvSpPr>
+          <p:cNvPr id="2" name="Text 0"/>
+          <p:cNvSpPr/>
+          <p:nvPr/>
+        </p:nvSpPr>
+        <p:spPr>
+          <a:xfrm>
+            <a:off x="640080" y="411480"/>
+            <a:ext cx="10972800" cy="594360"/>
+          </a:xfrm>
+          <a:prstGeom prst="rect">
+            <a:avLst/>
+          </a:prstGeom>
+          <a:noFill/>
+          <a:ln/>
+        </p:spPr>
+        <p:txBody>
+          <a:bodyPr wrap="square" lIns="0" tIns="0" rIns="0" bIns="0" rtlCol="0" anchor="ctr"/>
+          <a:lstStyle/>
+          <a:p>
+            <a:pPr indent="0" marL="0">
+              <a:buNone/>
+            </a:pPr>
+            <a:r>
+              <a:rPr lang="en-US" sz="3200" b="1" dirty="0">
+                <a:solidFill>
+                  <a:srgbClr val="1A2238"/>
+                </a:solidFill>
+                <a:latin typeface="Calibri" pitchFamily="34" charset="0"/>
+                <a:ea typeface="Calibri" pitchFamily="34" charset="-122"/>
+                <a:cs typeface="Calibri" pitchFamily="34" charset="-120"/>
+              </a:rPr>
+              <a:t>Why now: it runs today, and the frontier only moves outward</a:t>
+            </a:r>
+            <a:endParaRPr lang="en-US" sz="3200" dirty="0"/>
+          </a:p>
+        </p:txBody>
+      </p:sp>
+      <p:sp>
+        <p:nvSpPr>
+          <p:cNvPr id="3" name="Shape 1"/>
+          <p:cNvSpPr/>
+          <p:nvPr/>
+        </p:nvSpPr>
+        <p:spPr>
+          <a:xfrm>
+            <a:off x="640080" y="1325880"/>
+            <a:ext cx="10927080" cy="1371600"/>
+          </a:xfrm>
+          <a:prstGeom prst="roundRect">
+            <a:avLst>
+              <a:gd name="adj" fmla="val 6000"/>
+            </a:avLst>
+          </a:prstGeom>
+          <a:solidFill>
+            <a:srgbClr val="F3F6FC"/>
+          </a:solidFill>
+          <a:ln/>
+          <a:effectLst>
+            <a:outerShdw sx="100000" sy="100000" kx="0" ky="0" algn="bl" rotWithShape="0" blurRad="76200" dist="25400" dir="5400000">
+              <a:srgbClr val="9AA3B2">
+                <a:alpha val="30000"/>
+              </a:srgbClr>
+            </a:outerShdw>
+          </a:effectLst>
+        </p:spPr>
+      </p:sp>
+      <p:sp>
+        <p:nvSpPr>
+          <p:cNvPr id="4" name="Shape 2"/>
+          <p:cNvSpPr/>
+          <p:nvPr/>
+        </p:nvSpPr>
+        <p:spPr>
+          <a:xfrm>
+            <a:off x="914400" y="1664208"/>
+            <a:ext cx="694944" cy="694944"/>
+          </a:xfrm>
+          <a:prstGeom prst="ellipse">
+            <a:avLst/>
+          </a:prstGeom>
+          <a:solidFill>
+            <a:srgbClr val="16205B"/>
+          </a:solidFill>
+          <a:ln/>
+        </p:spPr>
+      </p:sp>
+      <p:pic>
+        <p:nvPicPr>
+          <p:cNvPr id="5" name="Image 0" descr="preencoded.png">    </p:cNvPr>
+          <p:cNvPicPr>
+            <a:picLocks noChangeAspect="1"/>
+          </p:cNvPicPr>
+          <p:nvPr/>
+        </p:nvPicPr>
+        <p:blipFill>
+          <a:blip r:embed="rId1"/>
+          <a:stretch>
+            <a:fillRect/>
+          </a:stretch>
+        </p:blipFill>
+        <p:spPr>
+          <a:xfrm>
+            <a:off x="1095085" y="1844893"/>
+            <a:ext cx="333573" cy="333573"/>
+          </a:xfrm>
+          <a:prstGeom prst="rect">
+            <a:avLst/>
+          </a:prstGeom>
+        </p:spPr>
+      </p:pic>
+      <p:sp>
+        <p:nvSpPr>
+          <p:cNvPr id="6" name="Text 3"/>
+          <p:cNvSpPr/>
+          <p:nvPr/>
+        </p:nvSpPr>
+        <p:spPr>
+          <a:xfrm>
+            <a:off x="1920240" y="1490472"/>
+            <a:ext cx="9326880" cy="411480"/>
+          </a:xfrm>
+          <a:prstGeom prst="rect">
+            <a:avLst/>
+          </a:prstGeom>
+          <a:noFill/>
+          <a:ln/>
+        </p:spPr>
+        <p:txBody>
+          <a:bodyPr wrap="square" lIns="0" tIns="0" rIns="0" bIns="0" rtlCol="0" anchor="ctr"/>
+          <a:lstStyle/>
+          <a:p>
+            <a:pPr indent="0" marL="0">
+              <a:buNone/>
+            </a:pPr>
+            <a:r>
+              <a:rPr lang="en-US" sz="1850" b="1" dirty="0">
+                <a:solidFill>
+                  <a:srgbClr val="1A2238"/>
+                </a:solidFill>
+                <a:latin typeface="Calibri" pitchFamily="34" charset="0"/>
+                <a:ea typeface="Calibri" pitchFamily="34" charset="-122"/>
+                <a:cs typeface="Calibri" pitchFamily="34" charset="-120"/>
+              </a:rPr>
+              <a:t>Executed on real hardware — today</a:t>
+            </a:r>
+            <a:endParaRPr lang="en-US" sz="1850" dirty="0"/>
+          </a:p>
+        </p:txBody>
+      </p:sp>
+      <p:sp>
+        <p:nvSpPr>
+          <p:cNvPr id="7" name="Text 4"/>
+          <p:cNvSpPr/>
+          <p:nvPr/>
+        </p:nvSpPr>
+        <p:spPr>
+          <a:xfrm>
+            <a:off x="1920240" y="1901952"/>
+            <a:ext cx="9326880" cy="731520"/>
+          </a:xfrm>
+          <a:prstGeom prst="rect">
+            <a:avLst/>
+          </a:prstGeom>
+          <a:noFill/>
+          <a:ln/>
+        </p:spPr>
+        <p:txBody>
+          <a:bodyPr wrap="square" lIns="0" tIns="0" rIns="0" bIns="0" rtlCol="0" anchor="ctr"/>
+          <a:lstStyle/>
+          <a:p>
+            <a:pPr indent="0" marL="0">
+              <a:lnSpc>
+                <a:spcPct val="110000"/>
+              </a:lnSpc>
+              <a:buNone/>
+            </a:pPr>
+            <a:r>
+              <a:rPr lang="en-US" sz="1300" dirty="0">
+                <a:solidFill>
+                  <a:srgbClr val="1A2238"/>
+                </a:solidFill>
+                <a:latin typeface="Calibri" pitchFamily="34" charset="0"/>
+                <a:ea typeface="Calibri" pitchFamily="34" charset="-122"/>
+                <a:cs typeface="Calibri" pitchFamily="34" charset="-120"/>
+              </a:rPr>
+              <a:t>Exact to the digit at 20 qubits and chemically accurate at 28 on rented NVIDIA GPUs; reference-correcting at 38; the 40-qubit flagship in flight. No exotic infrastructure — cloud instances anyone can rent.</a:t>
+            </a:r>
+            <a:endParaRPr lang="en-US" sz="1300" dirty="0"/>
+          </a:p>
+        </p:txBody>
+      </p:sp>
+      <p:sp>
+        <p:nvSpPr>
+          <p:cNvPr id="8" name="Shape 5"/>
+          <p:cNvSpPr/>
+          <p:nvPr/>
+        </p:nvSpPr>
+        <p:spPr>
+          <a:xfrm>
+            <a:off x="640080" y="2898648"/>
+            <a:ext cx="10927080" cy="1371600"/>
+          </a:xfrm>
+          <a:prstGeom prst="roundRect">
+            <a:avLst>
+              <a:gd name="adj" fmla="val 6000"/>
+            </a:avLst>
+          </a:prstGeom>
+          <a:solidFill>
+            <a:srgbClr val="16205B"/>
+          </a:solidFill>
+          <a:ln/>
+        </p:spPr>
+      </p:sp>
+      <p:sp>
+        <p:nvSpPr>
+          <p:cNvPr id="9" name="Shape 6"/>
+          <p:cNvSpPr/>
+          <p:nvPr/>
+        </p:nvSpPr>
+        <p:spPr>
+          <a:xfrm>
+            <a:off x="914400" y="3236976"/>
+            <a:ext cx="694944" cy="694944"/>
+          </a:xfrm>
+          <a:prstGeom prst="ellipse">
+            <a:avLst/>
+          </a:prstGeom>
+          <a:solidFill>
+            <a:srgbClr val="02C39A"/>
+          </a:solidFill>
+          <a:ln/>
+        </p:spPr>
+      </p:sp>
+      <p:pic>
+        <p:nvPicPr>
+          <p:cNvPr id="10" name="Image 1" descr="preencoded.png">    </p:cNvPr>
+          <p:cNvPicPr>
+            <a:picLocks noChangeAspect="1"/>
+          </p:cNvPicPr>
+          <p:nvPr/>
+        </p:nvPicPr>
+        <p:blipFill>
+          <a:blip r:embed="rId2"/>
+          <a:stretch>
+            <a:fillRect/>
+          </a:stretch>
+        </p:blipFill>
+        <p:spPr>
+          <a:xfrm>
+            <a:off x="1095085" y="3417661"/>
+            <a:ext cx="333573" cy="333573"/>
+          </a:xfrm>
+          <a:prstGeom prst="rect">
+            <a:avLst/>
+          </a:prstGeom>
+        </p:spPr>
+      </p:pic>
+      <p:sp>
+        <p:nvSpPr>
+          <p:cNvPr id="11" name="Text 7"/>
+          <p:cNvSpPr/>
+          <p:nvPr/>
+        </p:nvSpPr>
+        <p:spPr>
+          <a:xfrm>
+            <a:off x="1920240" y="3063240"/>
+            <a:ext cx="9326880" cy="411480"/>
+          </a:xfrm>
+          <a:prstGeom prst="rect">
+            <a:avLst/>
+          </a:prstGeom>
+          <a:noFill/>
+          <a:ln/>
+        </p:spPr>
+        <p:txBody>
+          <a:bodyPr wrap="square" lIns="0" tIns="0" rIns="0" bIns="0" rtlCol="0" anchor="ctr"/>
+          <a:lstStyle/>
+          <a:p>
+            <a:pPr indent="0" marL="0">
+              <a:buNone/>
+            </a:pPr>
+            <a:r>
+              <a:rPr lang="en-US" sz="1850" b="1" dirty="0">
+                <a:solidFill>
+                  <a:srgbClr val="02C39A"/>
+                </a:solidFill>
+                <a:latin typeface="Calibri" pitchFamily="34" charset="0"/>
+                <a:ea typeface="Calibri" pitchFamily="34" charset="-122"/>
+                <a:cs typeface="Calibri" pitchFamily="34" charset="-120"/>
+              </a:rPr>
+              <a:t>Built for the quantum curve</a:t>
+            </a:r>
+            <a:endParaRPr lang="en-US" sz="1850" dirty="0"/>
+          </a:p>
+        </p:txBody>
+      </p:sp>
+      <p:sp>
+        <p:nvSpPr>
+          <p:cNvPr id="12" name="Text 8"/>
+          <p:cNvSpPr/>
+          <p:nvPr/>
+        </p:nvSpPr>
+        <p:spPr>
+          <a:xfrm>
+            <a:off x="1920240" y="3474720"/>
+            <a:ext cx="9326880" cy="731520"/>
+          </a:xfrm>
+          <a:prstGeom prst="rect">
+            <a:avLst/>
+          </a:prstGeom>
+          <a:noFill/>
+          <a:ln/>
+        </p:spPr>
+        <p:txBody>
+          <a:bodyPr wrap="square" lIns="0" tIns="0" rIns="0" bIns="0" rtlCol="0" anchor="ctr"/>
+          <a:lstStyle/>
+          <a:p>
+            <a:pPr indent="0" marL="0">
+              <a:lnSpc>
+                <a:spcPct val="110000"/>
+              </a:lnSpc>
+              <a:buNone/>
+            </a:pPr>
+            <a:r>
+              <a:rPr lang="en-US" sz="1300" dirty="0">
+                <a:solidFill>
+                  <a:srgbClr val="FFFFFF"/>
+                </a:solidFill>
+                <a:latin typeface="Calibri" pitchFamily="34" charset="0"/>
+                <a:ea typeface="Calibri" pitchFamily="34" charset="-122"/>
+                <a:cs typeface="Calibri" pitchFamily="34" charset="-120"/>
+              </a:rPr>
+              <a:t>The expensive step — selecting which configurations matter — is exactly what a quantum sampler does natively (CUDA-Q today, trapped-ion QPUs next: our verified circuits are already in the queue). As devices mature, certified truth gets cheaper every year.</a:t>
+            </a:r>
+            <a:endParaRPr lang="en-US" sz="1300" dirty="0"/>
+          </a:p>
+        </p:txBody>
+      </p:sp>
+      <p:sp>
+        <p:nvSpPr>
+          <p:cNvPr id="13" name="Shape 9"/>
+          <p:cNvSpPr/>
+          <p:nvPr/>
+        </p:nvSpPr>
+        <p:spPr>
+          <a:xfrm>
+            <a:off x="640080" y="4471416"/>
+            <a:ext cx="10927080" cy="1371600"/>
+          </a:xfrm>
+          <a:prstGeom prst="roundRect">
+            <a:avLst>
+              <a:gd name="adj" fmla="val 6000"/>
+            </a:avLst>
+          </a:prstGeom>
+          <a:solidFill>
+            <a:srgbClr val="F3F6FC"/>
+          </a:solidFill>
+          <a:ln/>
+          <a:effectLst>
+            <a:outerShdw sx="100000" sy="100000" kx="0" ky="0" algn="bl" rotWithShape="0" blurRad="76200" dist="25400" dir="5400000">
+              <a:srgbClr val="9AA3B2">
+                <a:alpha val="30000"/>
+              </a:srgbClr>
+            </a:outerShdw>
+          </a:effectLst>
+        </p:spPr>
+      </p:sp>
+      <p:sp>
+        <p:nvSpPr>
+          <p:cNvPr id="14" name="Shape 10"/>
+          <p:cNvSpPr/>
+          <p:nvPr/>
+        </p:nvSpPr>
+        <p:spPr>
+          <a:xfrm>
+            <a:off x="914400" y="4809744"/>
+            <a:ext cx="694944" cy="694944"/>
+          </a:xfrm>
+          <a:prstGeom prst="ellipse">
+            <a:avLst/>
+          </a:prstGeom>
+          <a:solidFill>
+            <a:srgbClr val="16205B"/>
+          </a:solidFill>
+          <a:ln/>
+        </p:spPr>
+      </p:sp>
+      <p:pic>
+        <p:nvPicPr>
+          <p:cNvPr id="15" name="Image 2" descr="preencoded.png">    </p:cNvPr>
+          <p:cNvPicPr>
+            <a:picLocks noChangeAspect="1"/>
+          </p:cNvPicPr>
+          <p:nvPr/>
+        </p:nvPicPr>
+        <p:blipFill>
+          <a:blip r:embed="rId3"/>
+          <a:stretch>
+            <a:fillRect/>
+          </a:stretch>
+        </p:blipFill>
+        <p:spPr>
+          <a:xfrm>
+            <a:off x="1095085" y="4990429"/>
+            <a:ext cx="333573" cy="333573"/>
+          </a:xfrm>
+          <a:prstGeom prst="rect">
+            <a:avLst/>
+          </a:prstGeom>
+        </p:spPr>
+      </p:pic>
+      <p:sp>
+        <p:nvSpPr>
+          <p:cNvPr id="16" name="Text 11"/>
+          <p:cNvSpPr/>
+          <p:nvPr/>
+        </p:nvSpPr>
+        <p:spPr>
+          <a:xfrm>
+            <a:off x="1920240" y="4636008"/>
+            <a:ext cx="9326880" cy="411480"/>
+          </a:xfrm>
+          <a:prstGeom prst="rect">
+            <a:avLst/>
+          </a:prstGeom>
+          <a:noFill/>
+          <a:ln/>
+        </p:spPr>
+        <p:txBody>
+          <a:bodyPr wrap="square" lIns="0" tIns="0" rIns="0" bIns="0" rtlCol="0" anchor="ctr"/>
+          <a:lstStyle/>
+          <a:p>
+            <a:pPr indent="0" marL="0">
+              <a:buNone/>
+            </a:pPr>
+            <a:r>
+              <a:rPr lang="en-US" sz="1850" b="1" dirty="0">
+                <a:solidFill>
+                  <a:srgbClr val="1A2238"/>
+                </a:solidFill>
+                <a:latin typeface="Calibri" pitchFamily="34" charset="0"/>
+                <a:ea typeface="Calibri" pitchFamily="34" charset="-122"/>
+                <a:cs typeface="Calibri" pitchFamily="34" charset="-120"/>
+              </a:rPr>
+              <a:t>Credibility as a feature</a:t>
+            </a:r>
+            <a:endParaRPr lang="en-US" sz="1850" dirty="0"/>
+          </a:p>
+        </p:txBody>
+      </p:sp>
+      <p:sp>
+        <p:nvSpPr>
+          <p:cNvPr id="17" name="Text 12"/>
+          <p:cNvSpPr/>
+          <p:nvPr/>
+        </p:nvSpPr>
+        <p:spPr>
+          <a:xfrm>
+            <a:off x="1920240" y="5047488"/>
+            <a:ext cx="9326880" cy="731520"/>
+          </a:xfrm>
+          <a:prstGeom prst="rect">
+            <a:avLst/>
+          </a:prstGeom>
+          <a:noFill/>
+          <a:ln/>
+        </p:spPr>
+        <p:txBody>
+          <a:bodyPr wrap="square" lIns="0" tIns="0" rIns="0" bIns="0" rtlCol="0" anchor="ctr"/>
+          <a:lstStyle/>
+          <a:p>
+            <a:pPr indent="0" marL="0">
+              <a:lnSpc>
+                <a:spcPct val="110000"/>
+              </a:lnSpc>
+              <a:buNone/>
+            </a:pPr>
+            <a:r>
+              <a:rPr lang="en-US" sz="1300" dirty="0">
+                <a:solidFill>
+                  <a:srgbClr val="1A2238"/>
+                </a:solidFill>
+                <a:latin typeface="Calibri" pitchFamily="34" charset="0"/>
+                <a:ea typeface="Calibri" pitchFamily="34" charset="-122"/>
+                <a:cs typeface="Calibri" pitchFamily="34" charset="-120"/>
+              </a:rPr>
+              <a:t>Clinical-trial-style pre-registration, cryptographically frozen blind tests, published failures, and a one-command reproduction path with 24 automated checks. An audit you can audit.</a:t>
+            </a:r>
+            <a:endParaRPr lang="en-US" sz="1300" dirty="0"/>
+          </a:p>
+        </p:txBody>
+      </p:sp>
+      <p:sp>
+        <p:nvSpPr>
+          <p:cNvPr id="18" name="Text 13"/>
+          <p:cNvSpPr/>
+          <p:nvPr/>
+        </p:nvSpPr>
+        <p:spPr>
+          <a:xfrm>
+            <a:off x="640080" y="6199632"/>
+            <a:ext cx="10927080" cy="411480"/>
+          </a:xfrm>
+          <a:prstGeom prst="rect">
+            <a:avLst/>
+          </a:prstGeom>
+          <a:noFill/>
+          <a:ln/>
+        </p:spPr>
+        <p:txBody>
+          <a:bodyPr wrap="square" lIns="0" tIns="0" rIns="0" bIns="0" rtlCol="0" anchor="ctr"/>
+          <a:lstStyle/>
+          <a:p>
+            <a:pPr indent="0" marL="0">
+              <a:buNone/>
+            </a:pPr>
+            <a:r>
+              <a:rPr lang="en-US" sz="1250" i="1" dirty="0">
+                <a:solidFill>
+                  <a:srgbClr val="6B7280"/>
+                </a:solidFill>
+                <a:latin typeface="Calibri" pitchFamily="34" charset="0"/>
+                <a:ea typeface="Calibri" pitchFamily="34" charset="-122"/>
+                <a:cs typeface="Calibri" pitchFamily="34" charset="-120"/>
+              </a:rPr>
+              <a:t>Semiconductors (EUV photoresists) · catalysis · battery materials · magnetics — demonstrated on the chemistry these industries actually struggle with.</a:t>
+            </a:r>
+            <a:endParaRPr lang="en-US" sz="1250" dirty="0"/>
+          </a:p>
+        </p:txBody>
+      </p:sp>
+    </p:spTree>
+  </p:cSld>
+  <p:clrMapOvr>
+    <a:masterClrMapping/>
+  </p:clrMapOvr>
+</p:sld>
+</file>
+
+<file path=ppt/slides/slide8.xml><?xml version="1.0" encoding="utf-8"?>
+<p:sld xmlns:a="http://schemas.openxmlformats.org/drawingml/2006/main" xmlns:r="http://schemas.openxmlformats.org/officeDocument/2006/relationships" xmlns:p="http://schemas.openxmlformats.org/presentationml/2006/main">
+  <p:cSld name="Slide 8">
     <p:bg>
       <p:bgPr>
         <a:solidFill>

</xml_diff>

<commit_message>
40q flagship PROVEN: deck + work package updated on B1 terminal evidence
B1 P1 PASS (+1.226 mHa vs DMRG chi=400) and P2 PASS (450,257 dets in
band) per gpu_run1_h20_mp2seed_evidence.json (7fec4cf). Deck: title
status readout, slide 7 hardware claim, slide 8 ROADMAP->PROVEN swap.
Work package: title status, section 4.1 terminal verdict + early-stop
disclosure, prereg table P1/P2 final, open items refreshed.

Co-Authored-By: Claude Fable 5 <noreply@anthropic.com>
Claude-Session: https://claude.ai/code/session_016ijNmQwafUUda99bWttvKv
</commit_message>
<xml_diff>
--- a/docs/MATGENQ_Audit_CxO.pptx
+++ b/docs/MATGENQ_Audit_CxO.pptx
@@ -2379,7 +2379,7 @@
                 <a:ea typeface="Consolas" pitchFamily="34" charset="-122"/>
                 <a:cs typeface="Consolas" pitchFamily="34" charset="-120"/>
               </a:rPr>
-              <a:t>[ ERROR CERTIFICATE ... R² = 0.999 ]</a:t>
+              <a:t>[ 40Q FLAGSHIP ......... P1/P2 PASS ]</a:t>
             </a:r>
             <a:endParaRPr lang="en-US" sz="1100" dirty="0"/>
           </a:p>
@@ -9380,7 +9380,7 @@
                 <a:ea typeface="Calibri" pitchFamily="34" charset="-122"/>
                 <a:cs typeface="Calibri" pitchFamily="34" charset="-120"/>
               </a:rPr>
-              <a:t>Exact to the digit at 20 qubits and chemically accurate at 28 on rented NVIDIA GPUs; reference-correcting at 38; the 40-qubit flagship in flight. No exotic infrastructure — cloud instances anyone can rent.</a:t>
+              <a:t>Exact to the digit at 20 qubits, chemically accurate at 28 — and now certified at the 40-qubit flagship: pre-registered chemical-accuracy and determinant-budget tests both PASS. Reference-correcting at 38. All on cloud instances anyone can rent.</a:t>
             </a:r>
             <a:endParaRPr lang="en-US" sz="1300" dirty="0"/>
           </a:p>
@@ -10403,7 +10403,7 @@
                 <a:ea typeface="Calibri" pitchFamily="34" charset="-122"/>
                 <a:cs typeface="Calibri" pitchFamily="34" charset="-120"/>
               </a:rPr>
-              <a:t>Exact GPU execution (20q) and chemical accuracy beyond it (28q)</a:t>
+              <a:t>Chemical accuracy certified at the 40-qubit flagship — pre-registered P1 + P2 PASS (plus exact 20q, chem-acc 28q)</a:t>
             </a:r>
             <a:endParaRPr lang="en-US" sz="1350" dirty="0"/>
           </a:p>
@@ -10539,7 +10539,7 @@
                 <a:ea typeface="Calibri" pitchFamily="34" charset="-122"/>
                 <a:cs typeface="Calibri" pitchFamily="34" charset="-120"/>
               </a:rPr>
-              <a:t>40-qubit certified pass — flagship run executing now</a:t>
+              <a:t>38-qubit CrO audit completing now — final margin below the DMRG reference still growing</a:t>
             </a:r>
             <a:endParaRPr lang="en-US" sz="1350" dirty="0"/>
           </a:p>

</xml_diff>

<commit_message>
CxO deck: fix two physicist-flagged overclaim lines (P1 from physics review)
Slide 3 (mechanism): 'convicts even before full convergence' -> 'once converged'
— the conviction is airtight only once our variational bound is converged to
chemical accuracy; before that we don't know where exact sits. Header, body, and
pull-quote all reworded to the convergence-guarded claim.
Slide 5 (evidence): 'decades of spectroscopy agree with us, not DFT' -> 'the
ordering the audit predicts matches the experimental ground term (X5Pi)' — we got
the CrO gap sign/ordering right in a small CAS, not the measured magnitude.
Schema/relationship validation PASSED (--original baseline); edits are contiguous
single-run text swaps, equal-or-shorter, formatting preserved.

Co-Authored-By: Claude Fable 5 <noreply@anthropic.com>
Claude-Session: https://claude.ai/code/session_016ijNmQwafUUda99bWttvKv
</commit_message>
<xml_diff>
--- a/docs/MATGENQ_Audit_CxO.pptx
+++ b/docs/MATGENQ_Audit_CxO.pptx
@@ -4780,7 +4780,7 @@
                 <a:ea typeface="Calibri" pitchFamily="34" charset="-122"/>
                 <a:cs typeface="Calibri" pitchFamily="34" charset="-120"/>
               </a:rPr>
-              <a:t>Convicts other methods — even before full convergence</a:t>
+              <a:t>Convicts other methods — once converged</a:t>
             </a:r>
             <a:endParaRPr lang="en-US" sz="1850" dirty="0"/>
           </a:p>
@@ -4822,7 +4822,7 @@
                 <a:ea typeface="Calibri" pitchFamily="34" charset="-122"/>
                 <a:cs typeface="Calibri" pitchFamily="34" charset="-120"/>
               </a:rPr>
-              <a:t>Any answer sitting on the impossible side of the audit’s bound is provably wrong. No expert judgment call, no debate — that is how CCSD(T) and the DMRG reference were caught.</a:t>
+              <a:t>Once the audit is converged to chemical accuracy, any answer sitting below the bound is provably wrong. No expert judgment call, no debate — that is how CCSD(T) and the DMRG reference were caught.</a:t>
             </a:r>
             <a:endParaRPr lang="en-US" sz="1350" dirty="0"/>
           </a:p>
@@ -4864,7 +4864,7 @@
                 <a:ea typeface="Calibri" pitchFamily="34" charset="-122"/>
                 <a:cs typeface="Calibri" pitchFamily="34" charset="-120"/>
               </a:rPr>
-              <a:t>“It always knows which side of the truth it is on, always knows roughly how far, becomes the truth if you pay enough compute — and can convict other methods of being wrong even before it gets there.”</a:t>
+              <a:t>“It always knows which side of the truth it is on, always knows roughly how far, becomes the truth if you pay enough compute — and, once there, convicts other methods of being wrong.”</a:t>
             </a:r>
             <a:endParaRPr lang="en-US" sz="1450" dirty="0"/>
           </a:p>
@@ -6981,7 +6981,7 @@
                 <a:ea typeface="Calibri" pitchFamily="34" charset="-122"/>
                 <a:cs typeface="Calibri" pitchFamily="34" charset="-120"/>
               </a:rPr>
-              <a:t>DFT (B3LYP) predicts the wrong ground state. The audit predicts the one measured in the laboratory — decades of spectroscopy agree with us, not DFT.</a:t>
+              <a:t>DFT (B3LYP) predicts the wrong ground state. The ordering the audit predicts matches the experimental ground term (X⁵Π) — where DFT does not.</a:t>
             </a:r>
             <a:endParaRPr lang="en-US" sz="1280" dirty="0"/>
           </a:p>

</xml_diff>